<commit_message>
docs: add content images to MHBE deck + set date to today
The deck was text-only. Added real visuals and updated the date to June 26, 2026:
- 5 content images: an architecture data-flow diagram (metadata-only, nothing in
  the data path) on the compliance slide, and live product screenshots (Overview,
  Spend, Accuracy, Governance) captured from the console on sample data with the
  demo/onboarding chrome hidden and two example programs defined.
- builder: pic() helper (PIL-sized, framed); slides 4–8 restructured for imagery.
- regenerated the .pptx (5 embedded images, notes intact) and the present-ready
  .pdf to match; assets committed under docs/assets/.

Co-Authored-By: Claude Opus 4.8 <noreply@anthropic.com>
Claude-Session: https://claude.ai/code/session_01Mev79UpmJmZS58W3eyakhL
</commit_message>
<xml_diff>
--- a/docs/mhbe-demo-deck.pptx
+++ b/docs/mhbe-demo-deck.pptx
@@ -4824,7 +4824,7 @@
                 </a:solidFill>
                 <a:latin typeface="Calibri"/>
               </a:rPr>
-              <a:t>Outlay.ai   ·   Demo · [date] · [presenter]</a:t>
+              <a:t>Outlay.ai   ·   Demo · June 26, 2026 · [presenter]</a:t>
             </a:r>
           </a:p>
         </p:txBody>
@@ -7006,7 +7006,7 @@
         </p:nvSpPr>
         <p:spPr>
           <a:xfrm>
-            <a:off x="822960" y="1371600"/>
+            <a:off x="822960" y="1325880"/>
             <a:ext cx="10515600" cy="914400"/>
           </a:xfrm>
           <a:prstGeom prst="rect">
@@ -7026,7 +7026,7 @@
               </a:spcAft>
             </a:pPr>
             <a:r>
-              <a:rPr sz="3200" b="1">
+              <a:rPr sz="3000" b="1">
                 <a:solidFill>
                   <a:srgbClr val="1F2430"/>
                 </a:solidFill>
@@ -7045,8 +7045,8 @@
         </p:nvSpPr>
         <p:spPr>
           <a:xfrm>
-            <a:off x="822960" y="2560320"/>
-            <a:ext cx="6035040" cy="3657600"/>
+            <a:off x="822960" y="2468880"/>
+            <a:ext cx="4114800" cy="3657600"/>
           </a:xfrm>
           <a:prstGeom prst="rect">
             <a:avLst/>
@@ -7061,27 +7061,27 @@
           <a:p>
             <a:pPr algn="l">
               <a:spcAft>
-                <a:spcPts val="1200"/>
-              </a:spcAft>
-            </a:pPr>
-            <a:r>
-              <a:rPr sz="1700" b="0">
+                <a:spcPts val="1100"/>
+              </a:spcAft>
+            </a:pPr>
+            <a:r>
+              <a:rPr sz="1500" b="0">
                 <a:solidFill>
                   <a:srgbClr val="1F2430"/>
                 </a:solidFill>
                 <a:latin typeface="Calibri"/>
               </a:rPr>
-              <a:t>•  Metadata-only — token counts, ticket IDs, work types, dollar figures. Never prompts or model outputs.</a:t>
-            </a:r>
-          </a:p>
-          <a:p>
-            <a:pPr algn="l">
-              <a:spcAft>
-                <a:spcPts val="1200"/>
-              </a:spcAft>
-            </a:pPr>
-            <a:r>
-              <a:rPr sz="1700" b="0">
+              <a:t>•  Metadata-only — token counts, ticket IDs, work types, dollar figures. Never prompts or outputs.</a:t>
+            </a:r>
+          </a:p>
+          <a:p>
+            <a:pPr algn="l">
+              <a:spcAft>
+                <a:spcPts val="1100"/>
+              </a:spcAft>
+            </a:pPr>
+            <a:r>
+              <a:rPr sz="1500" b="0">
                 <a:solidFill>
                   <a:srgbClr val="1F2430"/>
                 </a:solidFill>
@@ -7093,112 +7093,66 @@
           <a:p>
             <a:pPr algn="l">
               <a:spcAft>
-                <a:spcPts val="1200"/>
-              </a:spcAft>
-            </a:pPr>
-            <a:r>
-              <a:rPr sz="1700" b="0">
+                <a:spcPts val="1100"/>
+              </a:spcAft>
+            </a:pPr>
+            <a:r>
+              <a:rPr sz="1500" b="0">
                 <a:solidFill>
                   <a:srgbClr val="1F2430"/>
                 </a:solidFill>
                 <a:latin typeface="Calibri"/>
               </a:rPr>
-              <a:t>•  Read-only — Outlay observes; it's not a proxy or gateway in any data path.</a:t>
-            </a:r>
-          </a:p>
-        </p:txBody>
-      </p:sp>
-      <p:sp>
-        <p:nvSpPr>
-          <p:cNvPr id="6" name="Rectangle 5"/>
-          <p:cNvSpPr/>
+              <a:t>•  Read-only — never a proxy or gateway in any data path.</a:t>
+            </a:r>
+          </a:p>
+          <a:p>
+            <a:pPr algn="l">
+              <a:spcAft>
+                <a:spcPts val="1100"/>
+              </a:spcAft>
+            </a:pPr>
+            <a:r>
+              <a:rPr sz="1500" b="0">
+                <a:solidFill>
+                  <a:srgbClr val="1F2430"/>
+                </a:solidFill>
+                <a:latin typeface="Calibri"/>
+              </a:rPr>
+              <a:t>•  Out of MARS-E / IRS 1075 / HIPAA data scope — what stops most vendors at the door.</a:t>
+            </a:r>
+          </a:p>
+        </p:txBody>
+      </p:sp>
+      <p:pic>
+        <p:nvPicPr>
+          <p:cNvPr id="6" name="Picture 5" descr="diagram-architecture.png"/>
+          <p:cNvPicPr>
+            <a:picLocks noChangeAspect="1"/>
+          </p:cNvPicPr>
           <p:nvPr/>
-        </p:nvSpPr>
+        </p:nvPicPr>
+        <p:blipFill>
+          <a:blip r:embed="rId2"/>
+          <a:stretch>
+            <a:fillRect/>
+          </a:stretch>
+        </p:blipFill>
         <p:spPr>
           <a:xfrm>
-            <a:off x="7223760" y="2560320"/>
-            <a:ext cx="4114800" cy="2743200"/>
+            <a:off x="5074920" y="2331720"/>
+            <a:ext cx="6629400" cy="3598817"/>
           </a:xfrm>
           <a:prstGeom prst="rect">
             <a:avLst/>
           </a:prstGeom>
-          <a:solidFill>
-            <a:srgbClr val="E7F1EC"/>
-          </a:solidFill>
           <a:ln w="12700">
             <a:solidFill>
-              <a:srgbClr val="0F6B4F"/>
+              <a:srgbClr val="E1DDD2"/>
             </a:solidFill>
           </a:ln>
-          <a:effectLst/>
         </p:spPr>
-        <p:style>
-          <a:lnRef idx="1">
-            <a:schemeClr val="accent1"/>
-          </a:lnRef>
-          <a:fillRef idx="3">
-            <a:schemeClr val="accent1"/>
-          </a:fillRef>
-          <a:effectRef idx="2">
-            <a:schemeClr val="accent1"/>
-          </a:effectRef>
-          <a:fontRef idx="minor">
-            <a:schemeClr val="lt1"/>
-          </a:fontRef>
-        </p:style>
-        <p:txBody>
-          <a:bodyPr rtlCol="0" anchor="t" wrap="square" lIns="228600" rIns="228600" tIns="164592"/>
-          <a:lstStyle/>
-          <a:p>
-            <a:pPr algn="l">
-              <a:spcAft>
-                <a:spcPts val="800"/>
-              </a:spcAft>
-            </a:pPr>
-            <a:r>
-              <a:rPr sz="1200" b="1">
-                <a:solidFill>
-                  <a:srgbClr val="5C6470"/>
-                </a:solidFill>
-                <a:latin typeface="Calibri"/>
-              </a:rPr>
-              <a:t>WHAT THAT MEANS FOR YOUR REVIEW</a:t>
-            </a:r>
-          </a:p>
-          <a:p>
-            <a:pPr algn="l">
-              <a:spcAft>
-                <a:spcPts val="500"/>
-              </a:spcAft>
-            </a:pPr>
-            <a:r>
-              <a:rPr sz="1350" b="0">
-                <a:solidFill>
-                  <a:srgbClr val="1F2430"/>
-                </a:solidFill>
-                <a:latin typeface="Calibri"/>
-              </a:rPr>
-              <a:t>None of the data MARS-E / ARC-AMPE, IRS Pub 1075, or HIPAA govern ever reaches us.</a:t>
-            </a:r>
-          </a:p>
-          <a:p>
-            <a:pPr algn="l">
-              <a:spcAft>
-                <a:spcPts val="500"/>
-              </a:spcAft>
-            </a:pPr>
-            <a:r>
-              <a:rPr sz="1350" b="0">
-                <a:solidFill>
-                  <a:srgbClr val="1F2430"/>
-                </a:solidFill>
-                <a:latin typeface="Calibri"/>
-              </a:rPr>
-              <a:t>The integration sits OUTSIDE that data scope — which is what stops most vendors at the door.</a:t>
-            </a:r>
-          </a:p>
-        </p:txBody>
-      </p:sp>
+      </p:pic>
     </p:spTree>
   </p:cSld>
   <p:clrMapOvr>
@@ -7308,8 +7262,8 @@
         </p:nvSpPr>
         <p:spPr>
           <a:xfrm>
-            <a:off x="822960" y="2194560"/>
-            <a:ext cx="10515600" cy="1828800"/>
+            <a:off x="822960" y="1920240"/>
+            <a:ext cx="4937760" cy="2743200"/>
           </a:xfrm>
           <a:prstGeom prst="rect">
             <a:avLst/>
@@ -7328,7 +7282,7 @@
               </a:spcAft>
             </a:pPr>
             <a:r>
-              <a:rPr sz="4000" b="1">
+              <a:rPr sz="3400" b="1">
                 <a:solidFill>
                   <a:srgbClr val="FFFFFF"/>
                 </a:solidFill>
@@ -7344,7 +7298,7 @@
               </a:spcAft>
             </a:pPr>
             <a:r>
-              <a:rPr sz="2000" b="0">
+              <a:rPr sz="1800" b="0">
                 <a:solidFill>
                   <a:srgbClr val="DDF0E7"/>
                 </a:solidFill>
@@ -7355,6 +7309,35 @@
           </a:p>
         </p:txBody>
       </p:sp>
+      <p:pic>
+        <p:nvPicPr>
+          <p:cNvPr id="5" name="Picture 4" descr="shot-overview.png"/>
+          <p:cNvPicPr>
+            <a:picLocks noChangeAspect="1"/>
+          </p:cNvPicPr>
+          <p:nvPr/>
+        </p:nvPicPr>
+        <p:blipFill>
+          <a:blip r:embed="rId2"/>
+          <a:stretch>
+            <a:fillRect/>
+          </a:stretch>
+        </p:blipFill>
+        <p:spPr>
+          <a:xfrm>
+            <a:off x="6126480" y="1371600"/>
+            <a:ext cx="5577840" cy="3556883"/>
+          </a:xfrm>
+          <a:prstGeom prst="rect">
+            <a:avLst/>
+          </a:prstGeom>
+          <a:ln w="12700">
+            <a:solidFill>
+              <a:srgbClr val="FFFFFF"/>
+            </a:solidFill>
+          </a:ln>
+        </p:spPr>
+      </p:pic>
     </p:spTree>
   </p:cSld>
   <p:clrMapOvr>
@@ -7464,8 +7447,8 @@
         </p:nvSpPr>
         <p:spPr>
           <a:xfrm>
-            <a:off x="822960" y="1371600"/>
-            <a:ext cx="10515600" cy="3657600"/>
+            <a:off x="822960" y="960120"/>
+            <a:ext cx="10515600" cy="640080"/>
           </a:xfrm>
           <a:prstGeom prst="rect">
             <a:avLst/>
@@ -7480,11 +7463,11 @@
           <a:p>
             <a:pPr algn="l">
               <a:spcAft>
-                <a:spcPts val="1600"/>
-              </a:spcAft>
-            </a:pPr>
-            <a:r>
-              <a:rPr sz="3200" b="1">
+                <a:spcPts val="600"/>
+              </a:spcAft>
+            </a:pPr>
+            <a:r>
+              <a:rPr sz="2700" b="1">
                 <a:solidFill>
                   <a:srgbClr val="1F2430"/>
                 </a:solidFill>
@@ -7493,40 +7476,76 @@
               <a:t>Every dollar, on the roadmap.</a:t>
             </a:r>
           </a:p>
-          <a:p>
-            <a:pPr algn="l">
-              <a:spcAft>
-                <a:spcPts val="1200"/>
-              </a:spcAft>
-            </a:pPr>
-            <a:r>
-              <a:rPr sz="1900" b="0">
+        </p:txBody>
+      </p:sp>
+      <p:sp>
+        <p:nvSpPr>
+          <p:cNvPr id="5" name="TextBox 4"/>
+          <p:cNvSpPr txBox="1"/>
+          <p:nvPr/>
+        </p:nvSpPr>
+        <p:spPr>
+          <a:xfrm>
+            <a:off x="822960" y="1481328"/>
+            <a:ext cx="10515600" cy="365760"/>
+          </a:xfrm>
+          <a:prstGeom prst="rect">
+            <a:avLst/>
+          </a:prstGeom>
+          <a:noFill/>
+        </p:spPr>
+        <p:txBody>
+          <a:bodyPr wrap="square">
+            <a:spAutoFit/>
+          </a:bodyPr>
+          <a:lstStyle/>
+          <a:p>
+            <a:pPr algn="l">
+              <a:spcAft>
+                <a:spcPts val="600"/>
+              </a:spcAft>
+            </a:pPr>
+            <a:r>
+              <a:rPr sz="1400" b="0">
                 <a:solidFill>
                   <a:srgbClr val="5C6470"/>
                 </a:solidFill>
                 <a:latin typeface="Calibri"/>
               </a:rPr>
-              <a:t>Spend by team and cost center, by work type, by ticket, by engineer — with the share that maps to a real work item shown honestly, and the cheapest way to lift it.</a:t>
-            </a:r>
-          </a:p>
-          <a:p>
-            <a:pPr algn="l">
-              <a:spcAft>
-                <a:spcPts val="600"/>
-              </a:spcAft>
-            </a:pPr>
-            <a:r>
-              <a:rPr sz="1600" b="0">
-                <a:solidFill>
-                  <a:srgbClr val="5C6470"/>
-                </a:solidFill>
-                <a:latin typeface="Calibri"/>
-              </a:rPr>
-              <a:t>Showback today; the same data feeds chargeback and your FOCUS-aligned export for the books.</a:t>
-            </a:r>
-          </a:p>
-        </p:txBody>
-      </p:sp>
+              <a:t>By team, work type, ticket, and engineer — with ticket coverage shown honestly.</a:t>
+            </a:r>
+          </a:p>
+        </p:txBody>
+      </p:sp>
+      <p:pic>
+        <p:nvPicPr>
+          <p:cNvPr id="6" name="Picture 5" descr="shot-spend.png"/>
+          <p:cNvPicPr>
+            <a:picLocks noChangeAspect="1"/>
+          </p:cNvPicPr>
+          <p:nvPr/>
+        </p:nvPicPr>
+        <p:blipFill>
+          <a:blip r:embed="rId2"/>
+          <a:stretch>
+            <a:fillRect/>
+          </a:stretch>
+        </p:blipFill>
+        <p:spPr>
+          <a:xfrm>
+            <a:off x="2350008" y="1874519"/>
+            <a:ext cx="7498079" cy="4781384"/>
+          </a:xfrm>
+          <a:prstGeom prst="rect">
+            <a:avLst/>
+          </a:prstGeom>
+          <a:ln w="12700">
+            <a:solidFill>
+              <a:srgbClr val="E1DDD2"/>
+            </a:solidFill>
+          </a:ln>
+        </p:spPr>
+      </p:pic>
     </p:spTree>
   </p:cSld>
   <p:clrMapOvr>
@@ -7636,8 +7655,8 @@
         </p:nvSpPr>
         <p:spPr>
           <a:xfrm>
-            <a:off x="822960" y="1371600"/>
-            <a:ext cx="10515600" cy="3657600"/>
+            <a:off x="822960" y="960120"/>
+            <a:ext cx="10515600" cy="640080"/>
           </a:xfrm>
           <a:prstGeom prst="rect">
             <a:avLst/>
@@ -7652,11 +7671,11 @@
           <a:p>
             <a:pPr algn="l">
               <a:spcAft>
-                <a:spcPts val="1600"/>
-              </a:spcAft>
-            </a:pPr>
-            <a:r>
-              <a:rPr sz="3200" b="1">
+                <a:spcPts val="600"/>
+              </a:spcAft>
+            </a:pPr>
+            <a:r>
+              <a:rPr sz="2700" b="1">
                 <a:solidFill>
                   <a:srgbClr val="1F2430"/>
                 </a:solidFill>
@@ -7665,40 +7684,76 @@
               <a:t>We don't ask you to trust a vendor benchmark.</a:t>
             </a:r>
           </a:p>
-          <a:p>
-            <a:pPr algn="l">
-              <a:spcAft>
-                <a:spcPts val="1200"/>
-              </a:spcAft>
-            </a:pPr>
-            <a:r>
-              <a:rPr sz="1900" b="0">
+        </p:txBody>
+      </p:sp>
+      <p:sp>
+        <p:nvSpPr>
+          <p:cNvPr id="5" name="TextBox 4"/>
+          <p:cNvSpPr txBox="1"/>
+          <p:nvPr/>
+        </p:nvSpPr>
+        <p:spPr>
+          <a:xfrm>
+            <a:off x="822960" y="1481328"/>
+            <a:ext cx="10515600" cy="365760"/>
+          </a:xfrm>
+          <a:prstGeom prst="rect">
+            <a:avLst/>
+          </a:prstGeom>
+          <a:noFill/>
+        </p:spPr>
+        <p:txBody>
+          <a:bodyPr wrap="square">
+            <a:spAutoFit/>
+          </a:bodyPr>
+          <a:lstStyle/>
+          <a:p>
+            <a:pPr algn="l">
+              <a:spcAft>
+                <a:spcPts val="600"/>
+              </a:spcAft>
+            </a:pPr>
+            <a:r>
+              <a:rPr sz="1400" b="0">
                 <a:solidFill>
                   <a:srgbClr val="5C6470"/>
                 </a:solidFill>
                 <a:latin typeface="Calibri"/>
               </a:rPr>
-              <a:t>Outlay back-tests its forecast on your own closed tickets, leave-one-out: hide a ticket, predict it from the rest, compare to what it actually cost.</a:t>
-            </a:r>
-          </a:p>
-          <a:p>
-            <a:pPr algn="l">
-              <a:spcAft>
-                <a:spcPts val="600"/>
-              </a:spcAft>
-            </a:pPr>
-            <a:r>
-              <a:rPr sz="1600" b="0">
-                <a:solidFill>
-                  <a:srgbClr val="5C6470"/>
-                </a:solidFill>
-                <a:latin typeface="Calibri"/>
-              </a:rPr>
-              <a:t>You see the measured error on your data — and we never hide the sample size.</a:t>
-            </a:r>
-          </a:p>
-        </p:txBody>
-      </p:sp>
+              <a:t>Back-tested on your own closed tickets, leave-one-out — the measured error on your data.</a:t>
+            </a:r>
+          </a:p>
+        </p:txBody>
+      </p:sp>
+      <p:pic>
+        <p:nvPicPr>
+          <p:cNvPr id="6" name="Picture 5" descr="shot-accuracy.png"/>
+          <p:cNvPicPr>
+            <a:picLocks noChangeAspect="1"/>
+          </p:cNvPicPr>
+          <p:nvPr/>
+        </p:nvPicPr>
+        <p:blipFill>
+          <a:blip r:embed="rId2"/>
+          <a:stretch>
+            <a:fillRect/>
+          </a:stretch>
+        </p:blipFill>
+        <p:spPr>
+          <a:xfrm>
+            <a:off x="2350008" y="1874519"/>
+            <a:ext cx="7498079" cy="4781384"/>
+          </a:xfrm>
+          <a:prstGeom prst="rect">
+            <a:avLst/>
+          </a:prstGeom>
+          <a:ln w="12700">
+            <a:solidFill>
+              <a:srgbClr val="E1DDD2"/>
+            </a:solidFill>
+          </a:ln>
+        </p:spPr>
+      </p:pic>
     </p:spTree>
   </p:cSld>
   <p:clrMapOvr>
@@ -7808,8 +7863,8 @@
         </p:nvSpPr>
         <p:spPr>
           <a:xfrm>
-            <a:off x="822960" y="1280160"/>
-            <a:ext cx="10515600" cy="914400"/>
+            <a:off x="822960" y="960120"/>
+            <a:ext cx="10515600" cy="640080"/>
           </a:xfrm>
           <a:prstGeom prst="rect">
             <a:avLst/>
@@ -7828,7 +7883,7 @@
               </a:spcAft>
             </a:pPr>
             <a:r>
-              <a:rPr sz="3000" b="1">
+              <a:rPr sz="2700" b="1">
                 <a:solidFill>
                   <a:srgbClr val="1F2430"/>
                 </a:solidFill>
@@ -7847,8 +7902,8 @@
         </p:nvSpPr>
         <p:spPr>
           <a:xfrm>
-            <a:off x="822960" y="2468880"/>
-            <a:ext cx="6035040" cy="3657600"/>
+            <a:off x="822960" y="1481328"/>
+            <a:ext cx="10515600" cy="365760"/>
           </a:xfrm>
           <a:prstGeom prst="rect">
             <a:avLst/>
@@ -7863,128 +7918,50 @@
           <a:p>
             <a:pPr algn="l">
               <a:spcAft>
-                <a:spcPts val="1200"/>
-              </a:spcAft>
-            </a:pPr>
-            <a:r>
-              <a:rPr sz="1700" b="0">
-                <a:solidFill>
-                  <a:srgbClr val="1F2430"/>
+                <a:spcPts val="600"/>
+              </a:spcAft>
+            </a:pPr>
+            <a:r>
+              <a:rPr sz="1400" b="0">
+                <a:solidFill>
+                  <a:srgbClr val="5C6470"/>
                 </a:solidFill>
                 <a:latin typeface="Calibri"/>
               </a:rPr>
-              <a:t>•  Program budgets spanning teams, projects, and work types.</a:t>
-            </a:r>
-          </a:p>
-          <a:p>
-            <a:pPr algn="l">
-              <a:spcAft>
-                <a:spcPts val="1200"/>
-              </a:spcAft>
-            </a:pPr>
-            <a:r>
-              <a:rPr sz="1700" b="0">
-                <a:solidFill>
-                  <a:srgbClr val="1F2430"/>
-                </a:solidFill>
-                <a:latin typeface="Calibri"/>
-              </a:rPr>
-              <a:t>•  Real-time pacing — projected to breach, and the date.</a:t>
-            </a:r>
-          </a:p>
-          <a:p>
-            <a:pPr algn="l">
-              <a:spcAft>
-                <a:spcPts val="1200"/>
-              </a:spcAft>
-            </a:pPr>
-            <a:r>
-              <a:rPr sz="1700" b="0">
-                <a:solidFill>
-                  <a:srgbClr val="1F2430"/>
-                </a:solidFill>
-                <a:latin typeface="Calibri"/>
-              </a:rPr>
-              <a:t>•  Earned-value rating — on track / watch / off track from forecast vs actual on completed work.</a:t>
-            </a:r>
-          </a:p>
-        </p:txBody>
-      </p:sp>
-      <p:sp>
-        <p:nvSpPr>
-          <p:cNvPr id="6" name="Rectangle 5"/>
-          <p:cNvSpPr/>
+              <a:t>Program budgets, projected breach dates, and an on-/off-track earned-value rating.</a:t>
+            </a:r>
+          </a:p>
+        </p:txBody>
+      </p:sp>
+      <p:pic>
+        <p:nvPicPr>
+          <p:cNvPr id="6" name="Picture 5" descr="shot-governance.png"/>
+          <p:cNvPicPr>
+            <a:picLocks noChangeAspect="1"/>
+          </p:cNvPicPr>
           <p:nvPr/>
-        </p:nvSpPr>
+        </p:nvPicPr>
+        <p:blipFill>
+          <a:blip r:embed="rId2"/>
+          <a:stretch>
+            <a:fillRect/>
+          </a:stretch>
+        </p:blipFill>
         <p:spPr>
           <a:xfrm>
-            <a:off x="7223760" y="2468880"/>
-            <a:ext cx="4114800" cy="2560320"/>
+            <a:off x="2350008" y="1874519"/>
+            <a:ext cx="7498079" cy="4781384"/>
           </a:xfrm>
           <a:prstGeom prst="rect">
             <a:avLst/>
           </a:prstGeom>
-          <a:solidFill>
-            <a:srgbClr val="FFFFFF"/>
-          </a:solidFill>
           <a:ln w="12700">
             <a:solidFill>
               <a:srgbClr val="E1DDD2"/>
             </a:solidFill>
           </a:ln>
-          <a:effectLst/>
         </p:spPr>
-        <p:style>
-          <a:lnRef idx="1">
-            <a:schemeClr val="accent1"/>
-          </a:lnRef>
-          <a:fillRef idx="3">
-            <a:schemeClr val="accent1"/>
-          </a:fillRef>
-          <a:effectRef idx="2">
-            <a:schemeClr val="accent1"/>
-          </a:effectRef>
-          <a:fontRef idx="minor">
-            <a:schemeClr val="lt1"/>
-          </a:fontRef>
-        </p:style>
-        <p:txBody>
-          <a:bodyPr rtlCol="0" anchor="t" wrap="square" lIns="228600" rIns="228600" tIns="164592"/>
-          <a:lstStyle/>
-          <a:p>
-            <a:pPr algn="l">
-              <a:spcAft>
-                <a:spcPts val="800"/>
-              </a:spcAft>
-            </a:pPr>
-            <a:r>
-              <a:rPr sz="1200" b="1">
-                <a:solidFill>
-                  <a:srgbClr val="5C6470"/>
-                </a:solidFill>
-                <a:latin typeface="Calibri"/>
-              </a:rPr>
-              <a:t>REACHES YOU PROACTIVELY</a:t>
-            </a:r>
-          </a:p>
-          <a:p>
-            <a:pPr algn="l">
-              <a:spcAft>
-                <a:spcPts val="500"/>
-              </a:spcAft>
-            </a:pPr>
-            <a:r>
-              <a:rPr sz="1350" b="0">
-                <a:solidFill>
-                  <a:srgbClr val="1F2430"/>
-                </a:solidFill>
-                <a:latin typeface="Calibri"/>
-              </a:rPr>
-              <a:t>Off-track programs surface in the weekly digest, the monthly close pack, Slack/Teams, and a webhook to your SIEM — not just in the dashboard.</a:t>
-            </a:r>
-          </a:p>
-        </p:txBody>
-      </p:sp>
+      </p:pic>
     </p:spTree>
   </p:cSld>
   <p:clrMapOvr>

</xml_diff>

<commit_message>
docs: add content images to MHBE deck + set date to today (#247)
The deck was text-only. Added real visuals and updated the date to June 26, 2026:
- 5 content images: an architecture data-flow diagram (metadata-only, nothing in
  the data path) on the compliance slide, and live product screenshots (Overview,
  Spend, Accuracy, Governance) captured from the console on sample data with the
  demo/onboarding chrome hidden and two example programs defined.
- builder: pic() helper (PIL-sized, framed); slides 4–8 restructured for imagery.
- regenerated the .pptx (5 embedded images, notes intact) and the present-ready
  .pdf to match; assets committed under docs/assets/.


Claude-Session: https://claude.ai/code/session_01Mev79UpmJmZS58W3eyakhL

Co-authored-by: Claude <noreply@anthropic.com>
</commit_message>
<xml_diff>
--- a/docs/mhbe-demo-deck.pptx
+++ b/docs/mhbe-demo-deck.pptx
@@ -4824,7 +4824,7 @@
                 </a:solidFill>
                 <a:latin typeface="Calibri"/>
               </a:rPr>
-              <a:t>Outlay.ai   ·   Demo · [date] · [presenter]</a:t>
+              <a:t>Outlay.ai   ·   Demo · June 26, 2026 · [presenter]</a:t>
             </a:r>
           </a:p>
         </p:txBody>
@@ -7006,7 +7006,7 @@
         </p:nvSpPr>
         <p:spPr>
           <a:xfrm>
-            <a:off x="822960" y="1371600"/>
+            <a:off x="822960" y="1325880"/>
             <a:ext cx="10515600" cy="914400"/>
           </a:xfrm>
           <a:prstGeom prst="rect">
@@ -7026,7 +7026,7 @@
               </a:spcAft>
             </a:pPr>
             <a:r>
-              <a:rPr sz="3200" b="1">
+              <a:rPr sz="3000" b="1">
                 <a:solidFill>
                   <a:srgbClr val="1F2430"/>
                 </a:solidFill>
@@ -7045,8 +7045,8 @@
         </p:nvSpPr>
         <p:spPr>
           <a:xfrm>
-            <a:off x="822960" y="2560320"/>
-            <a:ext cx="6035040" cy="3657600"/>
+            <a:off x="822960" y="2468880"/>
+            <a:ext cx="4114800" cy="3657600"/>
           </a:xfrm>
           <a:prstGeom prst="rect">
             <a:avLst/>
@@ -7061,27 +7061,27 @@
           <a:p>
             <a:pPr algn="l">
               <a:spcAft>
-                <a:spcPts val="1200"/>
-              </a:spcAft>
-            </a:pPr>
-            <a:r>
-              <a:rPr sz="1700" b="0">
+                <a:spcPts val="1100"/>
+              </a:spcAft>
+            </a:pPr>
+            <a:r>
+              <a:rPr sz="1500" b="0">
                 <a:solidFill>
                   <a:srgbClr val="1F2430"/>
                 </a:solidFill>
                 <a:latin typeface="Calibri"/>
               </a:rPr>
-              <a:t>•  Metadata-only — token counts, ticket IDs, work types, dollar figures. Never prompts or model outputs.</a:t>
-            </a:r>
-          </a:p>
-          <a:p>
-            <a:pPr algn="l">
-              <a:spcAft>
-                <a:spcPts val="1200"/>
-              </a:spcAft>
-            </a:pPr>
-            <a:r>
-              <a:rPr sz="1700" b="0">
+              <a:t>•  Metadata-only — token counts, ticket IDs, work types, dollar figures. Never prompts or outputs.</a:t>
+            </a:r>
+          </a:p>
+          <a:p>
+            <a:pPr algn="l">
+              <a:spcAft>
+                <a:spcPts val="1100"/>
+              </a:spcAft>
+            </a:pPr>
+            <a:r>
+              <a:rPr sz="1500" b="0">
                 <a:solidFill>
                   <a:srgbClr val="1F2430"/>
                 </a:solidFill>
@@ -7093,112 +7093,66 @@
           <a:p>
             <a:pPr algn="l">
               <a:spcAft>
-                <a:spcPts val="1200"/>
-              </a:spcAft>
-            </a:pPr>
-            <a:r>
-              <a:rPr sz="1700" b="0">
+                <a:spcPts val="1100"/>
+              </a:spcAft>
+            </a:pPr>
+            <a:r>
+              <a:rPr sz="1500" b="0">
                 <a:solidFill>
                   <a:srgbClr val="1F2430"/>
                 </a:solidFill>
                 <a:latin typeface="Calibri"/>
               </a:rPr>
-              <a:t>•  Read-only — Outlay observes; it's not a proxy or gateway in any data path.</a:t>
-            </a:r>
-          </a:p>
-        </p:txBody>
-      </p:sp>
-      <p:sp>
-        <p:nvSpPr>
-          <p:cNvPr id="6" name="Rectangle 5"/>
-          <p:cNvSpPr/>
+              <a:t>•  Read-only — never a proxy or gateway in any data path.</a:t>
+            </a:r>
+          </a:p>
+          <a:p>
+            <a:pPr algn="l">
+              <a:spcAft>
+                <a:spcPts val="1100"/>
+              </a:spcAft>
+            </a:pPr>
+            <a:r>
+              <a:rPr sz="1500" b="0">
+                <a:solidFill>
+                  <a:srgbClr val="1F2430"/>
+                </a:solidFill>
+                <a:latin typeface="Calibri"/>
+              </a:rPr>
+              <a:t>•  Out of MARS-E / IRS 1075 / HIPAA data scope — what stops most vendors at the door.</a:t>
+            </a:r>
+          </a:p>
+        </p:txBody>
+      </p:sp>
+      <p:pic>
+        <p:nvPicPr>
+          <p:cNvPr id="6" name="Picture 5" descr="diagram-architecture.png"/>
+          <p:cNvPicPr>
+            <a:picLocks noChangeAspect="1"/>
+          </p:cNvPicPr>
           <p:nvPr/>
-        </p:nvSpPr>
+        </p:nvPicPr>
+        <p:blipFill>
+          <a:blip r:embed="rId2"/>
+          <a:stretch>
+            <a:fillRect/>
+          </a:stretch>
+        </p:blipFill>
         <p:spPr>
           <a:xfrm>
-            <a:off x="7223760" y="2560320"/>
-            <a:ext cx="4114800" cy="2743200"/>
+            <a:off x="5074920" y="2331720"/>
+            <a:ext cx="6629400" cy="3598817"/>
           </a:xfrm>
           <a:prstGeom prst="rect">
             <a:avLst/>
           </a:prstGeom>
-          <a:solidFill>
-            <a:srgbClr val="E7F1EC"/>
-          </a:solidFill>
           <a:ln w="12700">
             <a:solidFill>
-              <a:srgbClr val="0F6B4F"/>
+              <a:srgbClr val="E1DDD2"/>
             </a:solidFill>
           </a:ln>
-          <a:effectLst/>
         </p:spPr>
-        <p:style>
-          <a:lnRef idx="1">
-            <a:schemeClr val="accent1"/>
-          </a:lnRef>
-          <a:fillRef idx="3">
-            <a:schemeClr val="accent1"/>
-          </a:fillRef>
-          <a:effectRef idx="2">
-            <a:schemeClr val="accent1"/>
-          </a:effectRef>
-          <a:fontRef idx="minor">
-            <a:schemeClr val="lt1"/>
-          </a:fontRef>
-        </p:style>
-        <p:txBody>
-          <a:bodyPr rtlCol="0" anchor="t" wrap="square" lIns="228600" rIns="228600" tIns="164592"/>
-          <a:lstStyle/>
-          <a:p>
-            <a:pPr algn="l">
-              <a:spcAft>
-                <a:spcPts val="800"/>
-              </a:spcAft>
-            </a:pPr>
-            <a:r>
-              <a:rPr sz="1200" b="1">
-                <a:solidFill>
-                  <a:srgbClr val="5C6470"/>
-                </a:solidFill>
-                <a:latin typeface="Calibri"/>
-              </a:rPr>
-              <a:t>WHAT THAT MEANS FOR YOUR REVIEW</a:t>
-            </a:r>
-          </a:p>
-          <a:p>
-            <a:pPr algn="l">
-              <a:spcAft>
-                <a:spcPts val="500"/>
-              </a:spcAft>
-            </a:pPr>
-            <a:r>
-              <a:rPr sz="1350" b="0">
-                <a:solidFill>
-                  <a:srgbClr val="1F2430"/>
-                </a:solidFill>
-                <a:latin typeface="Calibri"/>
-              </a:rPr>
-              <a:t>None of the data MARS-E / ARC-AMPE, IRS Pub 1075, or HIPAA govern ever reaches us.</a:t>
-            </a:r>
-          </a:p>
-          <a:p>
-            <a:pPr algn="l">
-              <a:spcAft>
-                <a:spcPts val="500"/>
-              </a:spcAft>
-            </a:pPr>
-            <a:r>
-              <a:rPr sz="1350" b="0">
-                <a:solidFill>
-                  <a:srgbClr val="1F2430"/>
-                </a:solidFill>
-                <a:latin typeface="Calibri"/>
-              </a:rPr>
-              <a:t>The integration sits OUTSIDE that data scope — which is what stops most vendors at the door.</a:t>
-            </a:r>
-          </a:p>
-        </p:txBody>
-      </p:sp>
+      </p:pic>
     </p:spTree>
   </p:cSld>
   <p:clrMapOvr>
@@ -7308,8 +7262,8 @@
         </p:nvSpPr>
         <p:spPr>
           <a:xfrm>
-            <a:off x="822960" y="2194560"/>
-            <a:ext cx="10515600" cy="1828800"/>
+            <a:off x="822960" y="1920240"/>
+            <a:ext cx="4937760" cy="2743200"/>
           </a:xfrm>
           <a:prstGeom prst="rect">
             <a:avLst/>
@@ -7328,7 +7282,7 @@
               </a:spcAft>
             </a:pPr>
             <a:r>
-              <a:rPr sz="4000" b="1">
+              <a:rPr sz="3400" b="1">
                 <a:solidFill>
                   <a:srgbClr val="FFFFFF"/>
                 </a:solidFill>
@@ -7344,7 +7298,7 @@
               </a:spcAft>
             </a:pPr>
             <a:r>
-              <a:rPr sz="2000" b="0">
+              <a:rPr sz="1800" b="0">
                 <a:solidFill>
                   <a:srgbClr val="DDF0E7"/>
                 </a:solidFill>
@@ -7355,6 +7309,35 @@
           </a:p>
         </p:txBody>
       </p:sp>
+      <p:pic>
+        <p:nvPicPr>
+          <p:cNvPr id="5" name="Picture 4" descr="shot-overview.png"/>
+          <p:cNvPicPr>
+            <a:picLocks noChangeAspect="1"/>
+          </p:cNvPicPr>
+          <p:nvPr/>
+        </p:nvPicPr>
+        <p:blipFill>
+          <a:blip r:embed="rId2"/>
+          <a:stretch>
+            <a:fillRect/>
+          </a:stretch>
+        </p:blipFill>
+        <p:spPr>
+          <a:xfrm>
+            <a:off x="6126480" y="1371600"/>
+            <a:ext cx="5577840" cy="3556883"/>
+          </a:xfrm>
+          <a:prstGeom prst="rect">
+            <a:avLst/>
+          </a:prstGeom>
+          <a:ln w="12700">
+            <a:solidFill>
+              <a:srgbClr val="FFFFFF"/>
+            </a:solidFill>
+          </a:ln>
+        </p:spPr>
+      </p:pic>
     </p:spTree>
   </p:cSld>
   <p:clrMapOvr>
@@ -7464,8 +7447,8 @@
         </p:nvSpPr>
         <p:spPr>
           <a:xfrm>
-            <a:off x="822960" y="1371600"/>
-            <a:ext cx="10515600" cy="3657600"/>
+            <a:off x="822960" y="960120"/>
+            <a:ext cx="10515600" cy="640080"/>
           </a:xfrm>
           <a:prstGeom prst="rect">
             <a:avLst/>
@@ -7480,11 +7463,11 @@
           <a:p>
             <a:pPr algn="l">
               <a:spcAft>
-                <a:spcPts val="1600"/>
-              </a:spcAft>
-            </a:pPr>
-            <a:r>
-              <a:rPr sz="3200" b="1">
+                <a:spcPts val="600"/>
+              </a:spcAft>
+            </a:pPr>
+            <a:r>
+              <a:rPr sz="2700" b="1">
                 <a:solidFill>
                   <a:srgbClr val="1F2430"/>
                 </a:solidFill>
@@ -7493,40 +7476,76 @@
               <a:t>Every dollar, on the roadmap.</a:t>
             </a:r>
           </a:p>
-          <a:p>
-            <a:pPr algn="l">
-              <a:spcAft>
-                <a:spcPts val="1200"/>
-              </a:spcAft>
-            </a:pPr>
-            <a:r>
-              <a:rPr sz="1900" b="0">
+        </p:txBody>
+      </p:sp>
+      <p:sp>
+        <p:nvSpPr>
+          <p:cNvPr id="5" name="TextBox 4"/>
+          <p:cNvSpPr txBox="1"/>
+          <p:nvPr/>
+        </p:nvSpPr>
+        <p:spPr>
+          <a:xfrm>
+            <a:off x="822960" y="1481328"/>
+            <a:ext cx="10515600" cy="365760"/>
+          </a:xfrm>
+          <a:prstGeom prst="rect">
+            <a:avLst/>
+          </a:prstGeom>
+          <a:noFill/>
+        </p:spPr>
+        <p:txBody>
+          <a:bodyPr wrap="square">
+            <a:spAutoFit/>
+          </a:bodyPr>
+          <a:lstStyle/>
+          <a:p>
+            <a:pPr algn="l">
+              <a:spcAft>
+                <a:spcPts val="600"/>
+              </a:spcAft>
+            </a:pPr>
+            <a:r>
+              <a:rPr sz="1400" b="0">
                 <a:solidFill>
                   <a:srgbClr val="5C6470"/>
                 </a:solidFill>
                 <a:latin typeface="Calibri"/>
               </a:rPr>
-              <a:t>Spend by team and cost center, by work type, by ticket, by engineer — with the share that maps to a real work item shown honestly, and the cheapest way to lift it.</a:t>
-            </a:r>
-          </a:p>
-          <a:p>
-            <a:pPr algn="l">
-              <a:spcAft>
-                <a:spcPts val="600"/>
-              </a:spcAft>
-            </a:pPr>
-            <a:r>
-              <a:rPr sz="1600" b="0">
-                <a:solidFill>
-                  <a:srgbClr val="5C6470"/>
-                </a:solidFill>
-                <a:latin typeface="Calibri"/>
-              </a:rPr>
-              <a:t>Showback today; the same data feeds chargeback and your FOCUS-aligned export for the books.</a:t>
-            </a:r>
-          </a:p>
-        </p:txBody>
-      </p:sp>
+              <a:t>By team, work type, ticket, and engineer — with ticket coverage shown honestly.</a:t>
+            </a:r>
+          </a:p>
+        </p:txBody>
+      </p:sp>
+      <p:pic>
+        <p:nvPicPr>
+          <p:cNvPr id="6" name="Picture 5" descr="shot-spend.png"/>
+          <p:cNvPicPr>
+            <a:picLocks noChangeAspect="1"/>
+          </p:cNvPicPr>
+          <p:nvPr/>
+        </p:nvPicPr>
+        <p:blipFill>
+          <a:blip r:embed="rId2"/>
+          <a:stretch>
+            <a:fillRect/>
+          </a:stretch>
+        </p:blipFill>
+        <p:spPr>
+          <a:xfrm>
+            <a:off x="2350008" y="1874519"/>
+            <a:ext cx="7498079" cy="4781384"/>
+          </a:xfrm>
+          <a:prstGeom prst="rect">
+            <a:avLst/>
+          </a:prstGeom>
+          <a:ln w="12700">
+            <a:solidFill>
+              <a:srgbClr val="E1DDD2"/>
+            </a:solidFill>
+          </a:ln>
+        </p:spPr>
+      </p:pic>
     </p:spTree>
   </p:cSld>
   <p:clrMapOvr>
@@ -7636,8 +7655,8 @@
         </p:nvSpPr>
         <p:spPr>
           <a:xfrm>
-            <a:off x="822960" y="1371600"/>
-            <a:ext cx="10515600" cy="3657600"/>
+            <a:off x="822960" y="960120"/>
+            <a:ext cx="10515600" cy="640080"/>
           </a:xfrm>
           <a:prstGeom prst="rect">
             <a:avLst/>
@@ -7652,11 +7671,11 @@
           <a:p>
             <a:pPr algn="l">
               <a:spcAft>
-                <a:spcPts val="1600"/>
-              </a:spcAft>
-            </a:pPr>
-            <a:r>
-              <a:rPr sz="3200" b="1">
+                <a:spcPts val="600"/>
+              </a:spcAft>
+            </a:pPr>
+            <a:r>
+              <a:rPr sz="2700" b="1">
                 <a:solidFill>
                   <a:srgbClr val="1F2430"/>
                 </a:solidFill>
@@ -7665,40 +7684,76 @@
               <a:t>We don't ask you to trust a vendor benchmark.</a:t>
             </a:r>
           </a:p>
-          <a:p>
-            <a:pPr algn="l">
-              <a:spcAft>
-                <a:spcPts val="1200"/>
-              </a:spcAft>
-            </a:pPr>
-            <a:r>
-              <a:rPr sz="1900" b="0">
+        </p:txBody>
+      </p:sp>
+      <p:sp>
+        <p:nvSpPr>
+          <p:cNvPr id="5" name="TextBox 4"/>
+          <p:cNvSpPr txBox="1"/>
+          <p:nvPr/>
+        </p:nvSpPr>
+        <p:spPr>
+          <a:xfrm>
+            <a:off x="822960" y="1481328"/>
+            <a:ext cx="10515600" cy="365760"/>
+          </a:xfrm>
+          <a:prstGeom prst="rect">
+            <a:avLst/>
+          </a:prstGeom>
+          <a:noFill/>
+        </p:spPr>
+        <p:txBody>
+          <a:bodyPr wrap="square">
+            <a:spAutoFit/>
+          </a:bodyPr>
+          <a:lstStyle/>
+          <a:p>
+            <a:pPr algn="l">
+              <a:spcAft>
+                <a:spcPts val="600"/>
+              </a:spcAft>
+            </a:pPr>
+            <a:r>
+              <a:rPr sz="1400" b="0">
                 <a:solidFill>
                   <a:srgbClr val="5C6470"/>
                 </a:solidFill>
                 <a:latin typeface="Calibri"/>
               </a:rPr>
-              <a:t>Outlay back-tests its forecast on your own closed tickets, leave-one-out: hide a ticket, predict it from the rest, compare to what it actually cost.</a:t>
-            </a:r>
-          </a:p>
-          <a:p>
-            <a:pPr algn="l">
-              <a:spcAft>
-                <a:spcPts val="600"/>
-              </a:spcAft>
-            </a:pPr>
-            <a:r>
-              <a:rPr sz="1600" b="0">
-                <a:solidFill>
-                  <a:srgbClr val="5C6470"/>
-                </a:solidFill>
-                <a:latin typeface="Calibri"/>
-              </a:rPr>
-              <a:t>You see the measured error on your data — and we never hide the sample size.</a:t>
-            </a:r>
-          </a:p>
-        </p:txBody>
-      </p:sp>
+              <a:t>Back-tested on your own closed tickets, leave-one-out — the measured error on your data.</a:t>
+            </a:r>
+          </a:p>
+        </p:txBody>
+      </p:sp>
+      <p:pic>
+        <p:nvPicPr>
+          <p:cNvPr id="6" name="Picture 5" descr="shot-accuracy.png"/>
+          <p:cNvPicPr>
+            <a:picLocks noChangeAspect="1"/>
+          </p:cNvPicPr>
+          <p:nvPr/>
+        </p:nvPicPr>
+        <p:blipFill>
+          <a:blip r:embed="rId2"/>
+          <a:stretch>
+            <a:fillRect/>
+          </a:stretch>
+        </p:blipFill>
+        <p:spPr>
+          <a:xfrm>
+            <a:off x="2350008" y="1874519"/>
+            <a:ext cx="7498079" cy="4781384"/>
+          </a:xfrm>
+          <a:prstGeom prst="rect">
+            <a:avLst/>
+          </a:prstGeom>
+          <a:ln w="12700">
+            <a:solidFill>
+              <a:srgbClr val="E1DDD2"/>
+            </a:solidFill>
+          </a:ln>
+        </p:spPr>
+      </p:pic>
     </p:spTree>
   </p:cSld>
   <p:clrMapOvr>
@@ -7808,8 +7863,8 @@
         </p:nvSpPr>
         <p:spPr>
           <a:xfrm>
-            <a:off x="822960" y="1280160"/>
-            <a:ext cx="10515600" cy="914400"/>
+            <a:off x="822960" y="960120"/>
+            <a:ext cx="10515600" cy="640080"/>
           </a:xfrm>
           <a:prstGeom prst="rect">
             <a:avLst/>
@@ -7828,7 +7883,7 @@
               </a:spcAft>
             </a:pPr>
             <a:r>
-              <a:rPr sz="3000" b="1">
+              <a:rPr sz="2700" b="1">
                 <a:solidFill>
                   <a:srgbClr val="1F2430"/>
                 </a:solidFill>
@@ -7847,8 +7902,8 @@
         </p:nvSpPr>
         <p:spPr>
           <a:xfrm>
-            <a:off x="822960" y="2468880"/>
-            <a:ext cx="6035040" cy="3657600"/>
+            <a:off x="822960" y="1481328"/>
+            <a:ext cx="10515600" cy="365760"/>
           </a:xfrm>
           <a:prstGeom prst="rect">
             <a:avLst/>
@@ -7863,128 +7918,50 @@
           <a:p>
             <a:pPr algn="l">
               <a:spcAft>
-                <a:spcPts val="1200"/>
-              </a:spcAft>
-            </a:pPr>
-            <a:r>
-              <a:rPr sz="1700" b="0">
-                <a:solidFill>
-                  <a:srgbClr val="1F2430"/>
+                <a:spcPts val="600"/>
+              </a:spcAft>
+            </a:pPr>
+            <a:r>
+              <a:rPr sz="1400" b="0">
+                <a:solidFill>
+                  <a:srgbClr val="5C6470"/>
                 </a:solidFill>
                 <a:latin typeface="Calibri"/>
               </a:rPr>
-              <a:t>•  Program budgets spanning teams, projects, and work types.</a:t>
-            </a:r>
-          </a:p>
-          <a:p>
-            <a:pPr algn="l">
-              <a:spcAft>
-                <a:spcPts val="1200"/>
-              </a:spcAft>
-            </a:pPr>
-            <a:r>
-              <a:rPr sz="1700" b="0">
-                <a:solidFill>
-                  <a:srgbClr val="1F2430"/>
-                </a:solidFill>
-                <a:latin typeface="Calibri"/>
-              </a:rPr>
-              <a:t>•  Real-time pacing — projected to breach, and the date.</a:t>
-            </a:r>
-          </a:p>
-          <a:p>
-            <a:pPr algn="l">
-              <a:spcAft>
-                <a:spcPts val="1200"/>
-              </a:spcAft>
-            </a:pPr>
-            <a:r>
-              <a:rPr sz="1700" b="0">
-                <a:solidFill>
-                  <a:srgbClr val="1F2430"/>
-                </a:solidFill>
-                <a:latin typeface="Calibri"/>
-              </a:rPr>
-              <a:t>•  Earned-value rating — on track / watch / off track from forecast vs actual on completed work.</a:t>
-            </a:r>
-          </a:p>
-        </p:txBody>
-      </p:sp>
-      <p:sp>
-        <p:nvSpPr>
-          <p:cNvPr id="6" name="Rectangle 5"/>
-          <p:cNvSpPr/>
+              <a:t>Program budgets, projected breach dates, and an on-/off-track earned-value rating.</a:t>
+            </a:r>
+          </a:p>
+        </p:txBody>
+      </p:sp>
+      <p:pic>
+        <p:nvPicPr>
+          <p:cNvPr id="6" name="Picture 5" descr="shot-governance.png"/>
+          <p:cNvPicPr>
+            <a:picLocks noChangeAspect="1"/>
+          </p:cNvPicPr>
           <p:nvPr/>
-        </p:nvSpPr>
+        </p:nvPicPr>
+        <p:blipFill>
+          <a:blip r:embed="rId2"/>
+          <a:stretch>
+            <a:fillRect/>
+          </a:stretch>
+        </p:blipFill>
         <p:spPr>
           <a:xfrm>
-            <a:off x="7223760" y="2468880"/>
-            <a:ext cx="4114800" cy="2560320"/>
+            <a:off x="2350008" y="1874519"/>
+            <a:ext cx="7498079" cy="4781384"/>
           </a:xfrm>
           <a:prstGeom prst="rect">
             <a:avLst/>
           </a:prstGeom>
-          <a:solidFill>
-            <a:srgbClr val="FFFFFF"/>
-          </a:solidFill>
           <a:ln w="12700">
             <a:solidFill>
               <a:srgbClr val="E1DDD2"/>
             </a:solidFill>
           </a:ln>
-          <a:effectLst/>
         </p:spPr>
-        <p:style>
-          <a:lnRef idx="1">
-            <a:schemeClr val="accent1"/>
-          </a:lnRef>
-          <a:fillRef idx="3">
-            <a:schemeClr val="accent1"/>
-          </a:fillRef>
-          <a:effectRef idx="2">
-            <a:schemeClr val="accent1"/>
-          </a:effectRef>
-          <a:fontRef idx="minor">
-            <a:schemeClr val="lt1"/>
-          </a:fontRef>
-        </p:style>
-        <p:txBody>
-          <a:bodyPr rtlCol="0" anchor="t" wrap="square" lIns="228600" rIns="228600" tIns="164592"/>
-          <a:lstStyle/>
-          <a:p>
-            <a:pPr algn="l">
-              <a:spcAft>
-                <a:spcPts val="800"/>
-              </a:spcAft>
-            </a:pPr>
-            <a:r>
-              <a:rPr sz="1200" b="1">
-                <a:solidFill>
-                  <a:srgbClr val="5C6470"/>
-                </a:solidFill>
-                <a:latin typeface="Calibri"/>
-              </a:rPr>
-              <a:t>REACHES YOU PROACTIVELY</a:t>
-            </a:r>
-          </a:p>
-          <a:p>
-            <a:pPr algn="l">
-              <a:spcAft>
-                <a:spcPts val="500"/>
-              </a:spcAft>
-            </a:pPr>
-            <a:r>
-              <a:rPr sz="1350" b="0">
-                <a:solidFill>
-                  <a:srgbClr val="1F2430"/>
-                </a:solidFill>
-                <a:latin typeface="Calibri"/>
-              </a:rPr>
-              <a:t>Off-track programs surface in the weekly digest, the monthly close pack, Slack/Teams, and a webhook to your SIEM — not just in the dashboard.</a:t>
-            </a:r>
-          </a:p>
-        </p:txBody>
-      </p:sp>
+      </p:pic>
     </p:spTree>
   </p:cSld>
   <p:clrMapOvr>

</xml_diff>

<commit_message>
docs: rework MHBE deck layouts to fill the page (less blank space)
Reworked every slide to use the full 16:9 frame: smaller margins, larger type,
bigger images, and restored side-bullets so both halves carry content.
- demo slides: title + 3 talking-point bullets (left) beside a large screenshot.
- architecture: bullets + a bigger data-flow diagram.
- what-it-does: bullets + the Estimate screenshot (6th image).
- security/fit/control-summary: fixed-height cards that fill to the baseline.
- title/moment/ask: headline bands fill the lower third.
Verified: 14 slides, 6 images, notes intact, no shape overflows slide bounds;
PDF regenerated to match (cards min-height) and visually QA'd via pymupdf renders.

Co-Authored-By: Claude Opus 4.8 <noreply@anthropic.com>
Claude-Session: https://claude.ai/code/session_01Mev79UpmJmZS58W3eyakhL
</commit_message>
<xml_diff>
--- a/docs/mhbe-demo-deck.pptx
+++ b/docs/mhbe-demo-deck.pptx
@@ -4688,8 +4688,8 @@
         </p:nvSpPr>
         <p:spPr>
           <a:xfrm>
-            <a:off x="822960" y="640080"/>
-            <a:ext cx="10515600" cy="457200"/>
+            <a:off x="548640" y="457200"/>
+            <a:ext cx="11091672" cy="457200"/>
           </a:xfrm>
           <a:prstGeom prst="rect">
             <a:avLst/>
@@ -4727,8 +4727,8 @@
         </p:nvSpPr>
         <p:spPr>
           <a:xfrm>
-            <a:off x="822960" y="1554480"/>
-            <a:ext cx="10515600" cy="2743200"/>
+            <a:off x="548640" y="1325880"/>
+            <a:ext cx="11091672" cy="2743200"/>
           </a:xfrm>
           <a:prstGeom prst="rect">
             <a:avLst/>
@@ -4747,29 +4747,29 @@
               </a:spcAft>
             </a:pPr>
             <a:r>
-              <a:rPr sz="4000" b="1">
+              <a:rPr sz="4600" b="1">
                 <a:solidFill>
                   <a:srgbClr val="1F2430"/>
                 </a:solidFill>
                 <a:latin typeface="Georgia"/>
               </a:rPr>
-              <a:t>AI spend, mapped to the work that drove it —</a:t>
-            </a:r>
-          </a:p>
-          <a:p>
-            <a:pPr algn="l">
-              <a:spcAft>
-                <a:spcPts val="1400"/>
-              </a:spcAft>
-            </a:pPr>
-            <a:r>
-              <a:rPr sz="4000" b="1">
+              <a:t>AI spend, mapped to the work</a:t>
+            </a:r>
+          </a:p>
+          <a:p>
+            <a:pPr algn="l">
+              <a:spcAft>
+                <a:spcPts val="1600"/>
+              </a:spcAft>
+            </a:pPr>
+            <a:r>
+              <a:rPr sz="4600" b="1">
                 <a:solidFill>
                   <a:srgbClr val="0F6B4F"/>
                 </a:solidFill>
                 <a:latin typeface="Georgia"/>
               </a:rPr>
-              <a:t>and held to budget.</a:t>
+              <a:t>that drove it — and held to budget.</a:t>
             </a:r>
           </a:p>
           <a:p>
@@ -4779,7 +4779,7 @@
               </a:spcAft>
             </a:pPr>
             <a:r>
-              <a:rPr sz="2000" b="0">
+              <a:rPr sz="2200" b="0">
                 <a:solidFill>
                   <a:srgbClr val="5C6470"/>
                 </a:solidFill>
@@ -4792,14 +4792,71 @@
       </p:sp>
       <p:sp>
         <p:nvSpPr>
-          <p:cNvPr id="5" name="TextBox 4"/>
+          <p:cNvPr id="5" name="Rectangle 4"/>
+          <p:cNvSpPr/>
+          <p:nvPr/>
+        </p:nvSpPr>
+        <p:spPr>
+          <a:xfrm>
+            <a:off x="548640" y="5074920"/>
+            <a:ext cx="11091672" cy="822960"/>
+          </a:xfrm>
+          <a:prstGeom prst="rect">
+            <a:avLst/>
+          </a:prstGeom>
+          <a:solidFill>
+            <a:srgbClr val="E7F1EC"/>
+          </a:solidFill>
+          <a:ln>
+            <a:noFill/>
+          </a:ln>
+          <a:effectLst/>
+        </p:spPr>
+        <p:style>
+          <a:lnRef idx="1">
+            <a:schemeClr val="accent1"/>
+          </a:lnRef>
+          <a:fillRef idx="3">
+            <a:schemeClr val="accent1"/>
+          </a:fillRef>
+          <a:effectRef idx="2">
+            <a:schemeClr val="accent1"/>
+          </a:effectRef>
+          <a:fontRef idx="minor">
+            <a:schemeClr val="lt1"/>
+          </a:fontRef>
+        </p:style>
+        <p:txBody>
+          <a:bodyPr rtlCol="0" anchor="ctr"/>
+          <a:lstStyle/>
+          <a:p>
+            <a:pPr algn="ctr">
+              <a:spcAft>
+                <a:spcPts val="600"/>
+              </a:spcAft>
+            </a:pPr>
+            <a:r>
+              <a:rPr sz="2400" b="1">
+                <a:solidFill>
+                  <a:srgbClr val="0B513C"/>
+                </a:solidFill>
+                <a:latin typeface="Georgia"/>
+              </a:rPr>
+              <a:t>Attribute  ·  Forecast  ·  Govern</a:t>
+            </a:r>
+          </a:p>
+        </p:txBody>
+      </p:sp>
+      <p:sp>
+        <p:nvSpPr>
+          <p:cNvPr id="6" name="TextBox 5"/>
           <p:cNvSpPr txBox="1"/>
           <p:nvPr/>
         </p:nvSpPr>
         <p:spPr>
           <a:xfrm>
-            <a:off x="822960" y="6126480"/>
-            <a:ext cx="10515600" cy="457200"/>
+            <a:off x="548640" y="6263640"/>
+            <a:ext cx="11091672" cy="365760"/>
           </a:xfrm>
           <a:prstGeom prst="rect">
             <a:avLst/>
@@ -4899,8 +4956,8 @@
         </p:nvSpPr>
         <p:spPr>
           <a:xfrm>
-            <a:off x="822960" y="640080"/>
-            <a:ext cx="10515600" cy="457200"/>
+            <a:off x="548640" y="457200"/>
+            <a:ext cx="11091672" cy="457200"/>
           </a:xfrm>
           <a:prstGeom prst="rect">
             <a:avLst/>
@@ -4938,8 +4995,8 @@
         </p:nvSpPr>
         <p:spPr>
           <a:xfrm>
-            <a:off x="822960" y="1188720"/>
-            <a:ext cx="10515600" cy="914400"/>
+            <a:off x="548640" y="1005840"/>
+            <a:ext cx="11091672" cy="731520"/>
           </a:xfrm>
           <a:prstGeom prst="rect">
             <a:avLst/>
@@ -4958,7 +5015,7 @@
               </a:spcAft>
             </a:pPr>
             <a:r>
-              <a:rPr sz="3000" b="1">
+              <a:rPr sz="3200" b="1">
                 <a:solidFill>
                   <a:srgbClr val="1F2430"/>
                 </a:solidFill>
@@ -4977,8 +5034,8 @@
         </p:nvSpPr>
         <p:spPr>
           <a:xfrm>
-            <a:off x="822960" y="2377440"/>
-            <a:ext cx="5212080" cy="2651760"/>
+            <a:off x="548640" y="2103120"/>
+            <a:ext cx="5394960" cy="4069080"/>
           </a:xfrm>
           <a:prstGeom prst="rect">
             <a:avLst/>
@@ -4986,7 +5043,7 @@
           <a:solidFill>
             <a:srgbClr val="FFFFFF"/>
           </a:solidFill>
-          <a:ln w="12700">
+          <a:ln w="15875">
             <a:solidFill>
               <a:srgbClr val="0F6B4F"/>
             </a:solidFill>
@@ -5008,16 +5065,16 @@
           </a:fontRef>
         </p:style>
         <p:txBody>
-          <a:bodyPr rtlCol="0" anchor="t" wrap="square" lIns="228600" rIns="228600" tIns="164592"/>
-          <a:lstStyle/>
-          <a:p>
-            <a:pPr algn="l">
-              <a:spcAft>
-                <a:spcPts val="800"/>
-              </a:spcAft>
-            </a:pPr>
-            <a:r>
-              <a:rPr sz="1200" b="1">
+          <a:bodyPr rtlCol="0" anchor="t" wrap="square" lIns="256032" rIns="256032" tIns="201168"/>
+          <a:lstStyle/>
+          <a:p>
+            <a:pPr algn="l">
+              <a:spcAft>
+                <a:spcPts val="1000"/>
+              </a:spcAft>
+            </a:pPr>
+            <a:r>
+              <a:rPr sz="1300" b="1">
                 <a:solidFill>
                   <a:srgbClr val="5C6470"/>
                 </a:solidFill>
@@ -5029,17 +5086,49 @@
           <a:p>
             <a:pPr algn="l">
               <a:spcAft>
-                <a:spcPts val="500"/>
-              </a:spcAft>
-            </a:pPr>
-            <a:r>
-              <a:rPr sz="1350" b="0">
+                <a:spcPts val="1400"/>
+              </a:spcAft>
+            </a:pPr>
+            <a:r>
+              <a:rPr sz="1600" b="0">
                 <a:solidFill>
                   <a:srgbClr val="1F2430"/>
                 </a:solidFill>
                 <a:latin typeface="Calibri"/>
               </a:rPr>
-              <a:t>As you stand up the 2025 AI strategy, be the cost-attribution + budget-guardrail layer from day one — governance-first, like your program.</a:t>
+              <a:t>•  Be the cost-attribution + budget-guardrail layer as you stand up the 2025 AI strategy.</a:t>
+            </a:r>
+          </a:p>
+          <a:p>
+            <a:pPr algn="l">
+              <a:spcAft>
+                <a:spcPts val="1400"/>
+              </a:spcAft>
+            </a:pPr>
+            <a:r>
+              <a:rPr sz="1600" b="0">
+                <a:solidFill>
+                  <a:srgbClr val="1F2430"/>
+                </a:solidFill>
+                <a:latin typeface="Calibri"/>
+              </a:rPr>
+              <a:t>•  Governance-first — matched to how your program is being built.</a:t>
+            </a:r>
+          </a:p>
+          <a:p>
+            <a:pPr algn="l">
+              <a:spcAft>
+                <a:spcPts val="1400"/>
+              </a:spcAft>
+            </a:pPr>
+            <a:r>
+              <a:rPr sz="1600" b="0">
+                <a:solidFill>
+                  <a:srgbClr val="1F2430"/>
+                </a:solidFill>
+                <a:latin typeface="Calibri"/>
+              </a:rPr>
+              <a:t>•  Day-one value with no instrumentation: read-only connections.</a:t>
             </a:r>
           </a:p>
         </p:txBody>
@@ -5052,8 +5141,8 @@
         </p:nvSpPr>
         <p:spPr>
           <a:xfrm>
-            <a:off x="6309360" y="2377440"/>
-            <a:ext cx="5029200" cy="2651760"/>
+            <a:off x="6245352" y="2103120"/>
+            <a:ext cx="5394960" cy="4069080"/>
           </a:xfrm>
           <a:prstGeom prst="rect">
             <a:avLst/>
@@ -5061,7 +5150,7 @@
           <a:solidFill>
             <a:srgbClr val="FFFFFF"/>
           </a:solidFill>
-          <a:ln w="12700">
+          <a:ln w="15875">
             <a:solidFill>
               <a:srgbClr val="0F6B4F"/>
             </a:solidFill>
@@ -5083,16 +5172,16 @@
           </a:fontRef>
         </p:style>
         <p:txBody>
-          <a:bodyPr rtlCol="0" anchor="t" wrap="square" lIns="228600" rIns="228600" tIns="164592"/>
-          <a:lstStyle/>
-          <a:p>
-            <a:pPr algn="l">
-              <a:spcAft>
-                <a:spcPts val="800"/>
-              </a:spcAft>
-            </a:pPr>
-            <a:r>
-              <a:rPr sz="1200" b="1">
+          <a:bodyPr rtlCol="0" anchor="t" wrap="square" lIns="256032" rIns="256032" tIns="201168"/>
+          <a:lstStyle/>
+          <a:p>
+            <a:pPr algn="l">
+              <a:spcAft>
+                <a:spcPts val="1000"/>
+              </a:spcAft>
+            </a:pPr>
+            <a:r>
+              <a:rPr sz="1300" b="1">
                 <a:solidFill>
                   <a:srgbClr val="5C6470"/>
                 </a:solidFill>
@@ -5104,17 +5193,49 @@
           <a:p>
             <a:pPr algn="l">
               <a:spcAft>
-                <a:spcPts val="500"/>
-              </a:spcAft>
-            </a:pPr>
-            <a:r>
-              <a:rPr sz="1350" b="0">
+                <a:spcPts val="1400"/>
+              </a:spcAft>
+            </a:pPr>
+            <a:r>
+              <a:rPr sz="1600" b="0">
                 <a:solidFill>
                   <a:srgbClr val="1F2430"/>
                 </a:solidFill>
                 <a:latin typeface="Calibri"/>
               </a:rPr>
-              <a:t>As the Deloitte / J29 enhancement work adopts AI coding agents, see AI-assisted delivery cost per project — the earned-value view a public agency needs to justify IT spend.</a:t>
+              <a:t>•  As Deloitte / J29 enhancement work adopts AI coding agents, see cost per project.</a:t>
+            </a:r>
+          </a:p>
+          <a:p>
+            <a:pPr algn="l">
+              <a:spcAft>
+                <a:spcPts val="1400"/>
+              </a:spcAft>
+            </a:pPr>
+            <a:r>
+              <a:rPr sz="1600" b="0">
+                <a:solidFill>
+                  <a:srgbClr val="1F2430"/>
+                </a:solidFill>
+                <a:latin typeface="Calibri"/>
+              </a:rPr>
+              <a:t>•  The earned-value view a public agency needs to justify IT spend.</a:t>
+            </a:r>
+          </a:p>
+          <a:p>
+            <a:pPr algn="l">
+              <a:spcAft>
+                <a:spcPts val="1400"/>
+              </a:spcAft>
+            </a:pPr>
+            <a:r>
+              <a:rPr sz="1600" b="0">
+                <a:solidFill>
+                  <a:srgbClr val="1F2430"/>
+                </a:solidFill>
+                <a:latin typeface="Calibri"/>
+              </a:rPr>
+              <a:t>•  Attributes the $12.7M “MHC enhancements” work to the tickets behind it.</a:t>
             </a:r>
           </a:p>
         </p:txBody>
@@ -5189,8 +5310,8 @@
         </p:nvSpPr>
         <p:spPr>
           <a:xfrm>
-            <a:off x="822960" y="640080"/>
-            <a:ext cx="2011680" cy="502920"/>
+            <a:off x="548640" y="457200"/>
+            <a:ext cx="2103120" cy="502920"/>
           </a:xfrm>
           <a:prstGeom prst="rect">
             <a:avLst/>
@@ -5227,7 +5348,7 @@
               </a:spcAft>
             </a:pPr>
             <a:r>
-              <a:rPr sz="1200" b="1">
+              <a:rPr sz="1250" b="1">
                 <a:solidFill>
                   <a:srgbClr val="0B513C"/>
                 </a:solidFill>
@@ -5246,8 +5367,8 @@
         </p:nvSpPr>
         <p:spPr>
           <a:xfrm>
-            <a:off x="822960" y="1371600"/>
-            <a:ext cx="10515600" cy="914400"/>
+            <a:off x="548640" y="1234440"/>
+            <a:ext cx="11091672" cy="822960"/>
           </a:xfrm>
           <a:prstGeom prst="rect">
             <a:avLst/>
@@ -5266,7 +5387,7 @@
               </a:spcAft>
             </a:pPr>
             <a:r>
-              <a:rPr sz="3000" b="1">
+              <a:rPr sz="3200" b="1">
                 <a:solidFill>
                   <a:srgbClr val="1F2430"/>
                 </a:solidFill>
@@ -5285,8 +5406,8 @@
         </p:nvSpPr>
         <p:spPr>
           <a:xfrm>
-            <a:off x="822960" y="2560320"/>
-            <a:ext cx="10515600" cy="2743200"/>
+            <a:off x="548640" y="2514600"/>
+            <a:ext cx="11091672" cy="3108960"/>
           </a:xfrm>
           <a:prstGeom prst="rect">
             <a:avLst/>
@@ -5301,11 +5422,11 @@
           <a:p>
             <a:pPr algn="l">
               <a:spcAft>
-                <a:spcPts val="1200"/>
-              </a:spcAft>
-            </a:pPr>
-            <a:r>
-              <a:rPr sz="1800" b="0">
+                <a:spcPts val="2200"/>
+              </a:spcAft>
+            </a:pPr>
+            <a:r>
+              <a:rPr sz="2000" b="0">
                 <a:solidFill>
                   <a:srgbClr val="1F2430"/>
                 </a:solidFill>
@@ -5317,11 +5438,11 @@
           <a:p>
             <a:pPr algn="l">
               <a:spcAft>
-                <a:spcPts val="1200"/>
-              </a:spcAft>
-            </a:pPr>
-            <a:r>
-              <a:rPr sz="1800" b="0">
+                <a:spcPts val="2200"/>
+              </a:spcAft>
+            </a:pPr>
+            <a:r>
+              <a:rPr sz="2000" b="0">
                 <a:solidFill>
                   <a:srgbClr val="1F2430"/>
                 </a:solidFill>
@@ -5333,11 +5454,11 @@
           <a:p>
             <a:pPr algn="l">
               <a:spcAft>
-                <a:spcPts val="1200"/>
-              </a:spcAft>
-            </a:pPr>
-            <a:r>
-              <a:rPr sz="1800" b="0">
+                <a:spcPts val="2200"/>
+              </a:spcAft>
+            </a:pPr>
+            <a:r>
+              <a:rPr sz="2000" b="0">
                 <a:solidFill>
                   <a:srgbClr val="1F2430"/>
                 </a:solidFill>
@@ -5346,20 +5467,61 @@
               <a:t>•  You walk away with a real number: attribution coverage + a measured forecast accuracy on your work.</a:t>
             </a:r>
           </a:p>
-          <a:p>
-            <a:pPr algn="l">
-              <a:spcAft>
-                <a:spcPts val="0"/>
-              </a:spcAft>
-            </a:pPr>
-            <a:r>
-              <a:rPr sz="1500" b="0">
-                <a:solidFill>
-                  <a:srgbClr val="5C6470"/>
+        </p:txBody>
+      </p:sp>
+      <p:sp>
+        <p:nvSpPr>
+          <p:cNvPr id="6" name="Rectangle 5"/>
+          <p:cNvSpPr/>
+          <p:nvPr/>
+        </p:nvSpPr>
+        <p:spPr>
+          <a:xfrm>
+            <a:off x="548640" y="5440680"/>
+            <a:ext cx="11091672" cy="777240"/>
+          </a:xfrm>
+          <a:prstGeom prst="rect">
+            <a:avLst/>
+          </a:prstGeom>
+          <a:solidFill>
+            <a:srgbClr val="E7F1EC"/>
+          </a:solidFill>
+          <a:ln>
+            <a:noFill/>
+          </a:ln>
+          <a:effectLst/>
+        </p:spPr>
+        <p:style>
+          <a:lnRef idx="1">
+            <a:schemeClr val="accent1"/>
+          </a:lnRef>
+          <a:fillRef idx="3">
+            <a:schemeClr val="accent1"/>
+          </a:fillRef>
+          <a:effectRef idx="2">
+            <a:schemeClr val="accent1"/>
+          </a:effectRef>
+          <a:fontRef idx="minor">
+            <a:schemeClr val="lt1"/>
+          </a:fontRef>
+        </p:style>
+        <p:txBody>
+          <a:bodyPr rtlCol="0" anchor="ctr"/>
+          <a:lstStyle/>
+          <a:p>
+            <a:pPr algn="ctr">
+              <a:spcAft>
+                <a:spcPts val="600"/>
+              </a:spcAft>
+            </a:pPr>
+            <a:r>
+              <a:rPr sz="1600" b="1">
+                <a:solidFill>
+                  <a:srgbClr val="0B513C"/>
                 </a:solidFill>
                 <a:latin typeface="Calibri"/>
               </a:rPr>
-              <a:t>Free during the pilot. We share our SOC 2 timeline and NIST 800-53 control mapping up front.</a:t>
+              <a:t>Free during the pilot · we share our SOC 2 timeline and NIST 800-53 control mapping up front.</a:t>
             </a:r>
           </a:p>
         </p:txBody>
@@ -5434,8 +5596,8 @@
         </p:nvSpPr>
         <p:spPr>
           <a:xfrm>
-            <a:off x="822960" y="640080"/>
-            <a:ext cx="10515600" cy="457200"/>
+            <a:off x="548640" y="457200"/>
+            <a:ext cx="11091672" cy="457200"/>
           </a:xfrm>
           <a:prstGeom prst="rect">
             <a:avLst/>
@@ -5473,8 +5635,8 @@
         </p:nvSpPr>
         <p:spPr>
           <a:xfrm>
-            <a:off x="822960" y="2103120"/>
-            <a:ext cx="10515600" cy="2286000"/>
+            <a:off x="548640" y="1874519"/>
+            <a:ext cx="11091672" cy="1463040"/>
           </a:xfrm>
           <a:prstGeom prst="rect">
             <a:avLst/>
@@ -5489,33 +5651,17 @@
           <a:p>
             <a:pPr algn="l">
               <a:spcAft>
-                <a:spcPts val="1200"/>
-              </a:spcAft>
-            </a:pPr>
-            <a:r>
-              <a:rPr sz="4000" b="1">
+                <a:spcPts val="600"/>
+              </a:spcAft>
+            </a:pPr>
+            <a:r>
+              <a:rPr sz="4600" b="1">
                 <a:solidFill>
                   <a:srgbClr val="FFFFFF"/>
                 </a:solidFill>
                 <a:latin typeface="Georgia"/>
               </a:rPr>
               <a:t>Govern the AI spend before it scales.</a:t>
-            </a:r>
-          </a:p>
-          <a:p>
-            <a:pPr algn="l">
-              <a:spcAft>
-                <a:spcPts val="600"/>
-              </a:spcAft>
-            </a:pPr>
-            <a:r>
-              <a:rPr sz="2000" b="0">
-                <a:solidFill>
-                  <a:srgbClr val="DDF0E7"/>
-                </a:solidFill>
-                <a:latin typeface="Calibri"/>
-              </a:rPr>
-              <a:t>The cheapest time to put AI on a budget is at the start of the curve — which is exactly where Maryland is.</a:t>
             </a:r>
           </a:p>
         </p:txBody>
@@ -5528,8 +5674,47 @@
         </p:nvSpPr>
         <p:spPr>
           <a:xfrm>
-            <a:off x="822960" y="6126480"/>
-            <a:ext cx="10515600" cy="457200"/>
+            <a:off x="548640" y="3611880"/>
+            <a:ext cx="11091672" cy="1463040"/>
+          </a:xfrm>
+          <a:prstGeom prst="rect">
+            <a:avLst/>
+          </a:prstGeom>
+          <a:noFill/>
+        </p:spPr>
+        <p:txBody>
+          <a:bodyPr wrap="square">
+            <a:spAutoFit/>
+          </a:bodyPr>
+          <a:lstStyle/>
+          <a:p>
+            <a:pPr algn="l">
+              <a:spcAft>
+                <a:spcPts val="600"/>
+              </a:spcAft>
+            </a:pPr>
+            <a:r>
+              <a:rPr sz="2200" b="0">
+                <a:solidFill>
+                  <a:srgbClr val="DDF0E7"/>
+                </a:solidFill>
+                <a:latin typeface="Calibri"/>
+              </a:rPr>
+              <a:t>The cheapest time to put AI on a budget is at the start of the curve — which is exactly where Maryland is.</a:t>
+            </a:r>
+          </a:p>
+        </p:txBody>
+      </p:sp>
+      <p:sp>
+        <p:nvSpPr>
+          <p:cNvPr id="6" name="TextBox 5"/>
+          <p:cNvSpPr txBox="1"/>
+          <p:nvPr/>
+        </p:nvSpPr>
+        <p:spPr>
+          <a:xfrm>
+            <a:off x="548640" y="6263640"/>
+            <a:ext cx="11091672" cy="365760"/>
           </a:xfrm>
           <a:prstGeom prst="rect">
             <a:avLst/>
@@ -5629,8 +5814,8 @@
         </p:nvSpPr>
         <p:spPr>
           <a:xfrm>
-            <a:off x="822960" y="640080"/>
-            <a:ext cx="10515600" cy="457200"/>
+            <a:off x="548640" y="457200"/>
+            <a:ext cx="11091672" cy="457200"/>
           </a:xfrm>
           <a:prstGeom prst="rect">
             <a:avLst/>
@@ -5668,8 +5853,8 @@
         </p:nvSpPr>
         <p:spPr>
           <a:xfrm>
-            <a:off x="822960" y="1097280"/>
-            <a:ext cx="10789920" cy="5486400"/>
+            <a:off x="548640" y="1051560"/>
+            <a:ext cx="11091672" cy="5394960"/>
           </a:xfrm>
           <a:prstGeom prst="rect">
             <a:avLst/>
@@ -5684,11 +5869,11 @@
           <a:p>
             <a:pPr algn="l">
               <a:spcAft>
-                <a:spcPts val="200"/>
-              </a:spcAft>
-            </a:pPr>
-            <a:r>
-              <a:rPr sz="1500" b="1">
+                <a:spcPts val="300"/>
+              </a:spcAft>
+            </a:pPr>
+            <a:r>
+              <a:rPr sz="1600" b="1">
                 <a:solidFill>
                   <a:srgbClr val="0F6B4F"/>
                 </a:solidFill>
@@ -5700,11 +5885,11 @@
           <a:p>
             <a:pPr algn="l">
               <a:spcAft>
-                <a:spcPts val="1000"/>
-              </a:spcAft>
-            </a:pPr>
-            <a:r>
-              <a:rPr sz="1350" b="0">
+                <a:spcPts val="1300"/>
+              </a:spcAft>
+            </a:pPr>
+            <a:r>
+              <a:rPr sz="1400" b="0">
                 <a:solidFill>
                   <a:srgbClr val="1F2430"/>
                 </a:solidFill>
@@ -5716,11 +5901,11 @@
           <a:p>
             <a:pPr algn="l">
               <a:spcAft>
-                <a:spcPts val="200"/>
-              </a:spcAft>
-            </a:pPr>
-            <a:r>
-              <a:rPr sz="1500" b="1">
+                <a:spcPts val="300"/>
+              </a:spcAft>
+            </a:pPr>
+            <a:r>
+              <a:rPr sz="1600" b="1">
                 <a:solidFill>
                   <a:srgbClr val="0F6B4F"/>
                 </a:solidFill>
@@ -5732,11 +5917,11 @@
           <a:p>
             <a:pPr algn="l">
               <a:spcAft>
-                <a:spcPts val="1000"/>
-              </a:spcAft>
-            </a:pPr>
-            <a:r>
-              <a:rPr sz="1350" b="0">
+                <a:spcPts val="1300"/>
+              </a:spcAft>
+            </a:pPr>
+            <a:r>
+              <a:rPr sz="1400" b="0">
                 <a:solidFill>
                   <a:srgbClr val="1F2430"/>
                 </a:solidFill>
@@ -5748,11 +5933,11 @@
           <a:p>
             <a:pPr algn="l">
               <a:spcAft>
-                <a:spcPts val="200"/>
-              </a:spcAft>
-            </a:pPr>
-            <a:r>
-              <a:rPr sz="1500" b="1">
+                <a:spcPts val="300"/>
+              </a:spcAft>
+            </a:pPr>
+            <a:r>
+              <a:rPr sz="1600" b="1">
                 <a:solidFill>
                   <a:srgbClr val="0F6B4F"/>
                 </a:solidFill>
@@ -5764,11 +5949,11 @@
           <a:p>
             <a:pPr algn="l">
               <a:spcAft>
-                <a:spcPts val="1000"/>
-              </a:spcAft>
-            </a:pPr>
-            <a:r>
-              <a:rPr sz="1350" b="0">
+                <a:spcPts val="1300"/>
+              </a:spcAft>
+            </a:pPr>
+            <a:r>
+              <a:rPr sz="1400" b="0">
                 <a:solidFill>
                   <a:srgbClr val="1F2430"/>
                 </a:solidFill>
@@ -5780,11 +5965,11 @@
           <a:p>
             <a:pPr algn="l">
               <a:spcAft>
-                <a:spcPts val="200"/>
-              </a:spcAft>
-            </a:pPr>
-            <a:r>
-              <a:rPr sz="1500" b="1">
+                <a:spcPts val="300"/>
+              </a:spcAft>
+            </a:pPr>
+            <a:r>
+              <a:rPr sz="1600" b="1">
                 <a:solidFill>
                   <a:srgbClr val="0F6B4F"/>
                 </a:solidFill>
@@ -5796,11 +5981,11 @@
           <a:p>
             <a:pPr algn="l">
               <a:spcAft>
-                <a:spcPts val="1000"/>
-              </a:spcAft>
-            </a:pPr>
-            <a:r>
-              <a:rPr sz="1350" b="0">
+                <a:spcPts val="1300"/>
+              </a:spcAft>
+            </a:pPr>
+            <a:r>
+              <a:rPr sz="1400" b="0">
                 <a:solidFill>
                   <a:srgbClr val="1F2430"/>
                 </a:solidFill>
@@ -5812,11 +5997,11 @@
           <a:p>
             <a:pPr algn="l">
               <a:spcAft>
-                <a:spcPts val="200"/>
-              </a:spcAft>
-            </a:pPr>
-            <a:r>
-              <a:rPr sz="1500" b="1">
+                <a:spcPts val="300"/>
+              </a:spcAft>
+            </a:pPr>
+            <a:r>
+              <a:rPr sz="1600" b="1">
                 <a:solidFill>
                   <a:srgbClr val="0F6B4F"/>
                 </a:solidFill>
@@ -5828,11 +6013,11 @@
           <a:p>
             <a:pPr algn="l">
               <a:spcAft>
-                <a:spcPts val="1000"/>
-              </a:spcAft>
-            </a:pPr>
-            <a:r>
-              <a:rPr sz="1350" b="0">
+                <a:spcPts val="1300"/>
+              </a:spcAft>
+            </a:pPr>
+            <a:r>
+              <a:rPr sz="1400" b="0">
                 <a:solidFill>
                   <a:srgbClr val="1F2430"/>
                 </a:solidFill>
@@ -5844,11 +6029,11 @@
           <a:p>
             <a:pPr algn="l">
               <a:spcAft>
-                <a:spcPts val="200"/>
-              </a:spcAft>
-            </a:pPr>
-            <a:r>
-              <a:rPr sz="1500" b="1">
+                <a:spcPts val="300"/>
+              </a:spcAft>
+            </a:pPr>
+            <a:r>
+              <a:rPr sz="1600" b="1">
                 <a:solidFill>
                   <a:srgbClr val="0F6B4F"/>
                 </a:solidFill>
@@ -5860,11 +6045,11 @@
           <a:p>
             <a:pPr algn="l">
               <a:spcAft>
-                <a:spcPts val="1000"/>
-              </a:spcAft>
-            </a:pPr>
-            <a:r>
-              <a:rPr sz="1350" b="0">
+                <a:spcPts val="1300"/>
+              </a:spcAft>
+            </a:pPr>
+            <a:r>
+              <a:rPr sz="1400" b="0">
                 <a:solidFill>
                   <a:srgbClr val="1F2430"/>
                 </a:solidFill>
@@ -5945,8 +6130,8 @@
         </p:nvSpPr>
         <p:spPr>
           <a:xfrm>
-            <a:off x="822960" y="640080"/>
-            <a:ext cx="10515600" cy="457200"/>
+            <a:off x="548640" y="457200"/>
+            <a:ext cx="11091672" cy="457200"/>
           </a:xfrm>
           <a:prstGeom prst="rect">
             <a:avLst/>
@@ -5984,8 +6169,8 @@
         </p:nvSpPr>
         <p:spPr>
           <a:xfrm>
-            <a:off x="822960" y="1097280"/>
-            <a:ext cx="10789920" cy="914400"/>
+            <a:off x="548640" y="960120"/>
+            <a:ext cx="11091672" cy="822960"/>
           </a:xfrm>
           <a:prstGeom prst="rect">
             <a:avLst/>
@@ -6004,7 +6189,7 @@
               </a:spcAft>
             </a:pPr>
             <a:r>
-              <a:rPr sz="1800" b="1">
+              <a:rPr sz="1900" b="1">
                 <a:solidFill>
                   <a:srgbClr val="1F2430"/>
                 </a:solidFill>
@@ -6023,8 +6208,8 @@
         </p:nvSpPr>
         <p:spPr>
           <a:xfrm>
-            <a:off x="822960" y="2103120"/>
-            <a:ext cx="5212080" cy="3840480"/>
+            <a:off x="548640" y="1965960"/>
+            <a:ext cx="5394960" cy="4297680"/>
           </a:xfrm>
           <a:prstGeom prst="rect">
             <a:avLst/>
@@ -6032,7 +6217,7 @@
           <a:solidFill>
             <a:srgbClr val="FFFFFF"/>
           </a:solidFill>
-          <a:ln w="12700">
+          <a:ln w="15875">
             <a:solidFill>
               <a:srgbClr val="0F6B4F"/>
             </a:solidFill>
@@ -6054,16 +6239,16 @@
           </a:fontRef>
         </p:style>
         <p:txBody>
-          <a:bodyPr rtlCol="0" anchor="t" wrap="square" lIns="228600" rIns="228600" tIns="164592"/>
-          <a:lstStyle/>
-          <a:p>
-            <a:pPr algn="l">
-              <a:spcAft>
-                <a:spcPts val="800"/>
-              </a:spcAft>
-            </a:pPr>
-            <a:r>
-              <a:rPr sz="1200" b="1">
+          <a:bodyPr rtlCol="0" anchor="t" wrap="square" lIns="256032" rIns="256032" tIns="201168"/>
+          <a:lstStyle/>
+          <a:p>
+            <a:pPr algn="l">
+              <a:spcAft>
+                <a:spcPts val="1000"/>
+              </a:spcAft>
+            </a:pPr>
+            <a:r>
+              <a:rPr sz="1300" b="1">
                 <a:solidFill>
                   <a:srgbClr val="5C6470"/>
                 </a:solidFill>
@@ -6075,7 +6260,7 @@
           <a:p>
             <a:pPr algn="l">
               <a:spcAft>
-                <a:spcPts val="500"/>
+                <a:spcPts val="700"/>
               </a:spcAft>
             </a:pPr>
             <a:r>
@@ -6085,13 +6270,13 @@
                 </a:solidFill>
                 <a:latin typeface="Calibri"/>
               </a:rPr>
-              <a:t>Metadata-only / BYOK / read-only — no PHI/PII/FTI</a:t>
-            </a:r>
-          </a:p>
-          <a:p>
-            <a:pPr algn="l">
-              <a:spcAft>
-                <a:spcPts val="500"/>
+              <a:t>•  Metadata-only / BYOK / read-only — no PHI/PII/FTI</a:t>
+            </a:r>
+          </a:p>
+          <a:p>
+            <a:pPr algn="l">
+              <a:spcAft>
+                <a:spcPts val="700"/>
               </a:spcAft>
             </a:pPr>
             <a:r>
@@ -6101,13 +6286,13 @@
                 </a:solidFill>
                 <a:latin typeface="Calibri"/>
               </a:rPr>
-              <a:t>SSO (OIDC) + SCIM</a:t>
-            </a:r>
-          </a:p>
-          <a:p>
-            <a:pPr algn="l">
-              <a:spcAft>
-                <a:spcPts val="500"/>
+              <a:t>•  SSO (OIDC) + SCIM</a:t>
+            </a:r>
+          </a:p>
+          <a:p>
+            <a:pPr algn="l">
+              <a:spcAft>
+                <a:spcPts val="700"/>
               </a:spcAft>
             </a:pPr>
             <a:r>
@@ -6117,13 +6302,13 @@
                 </a:solidFill>
                 <a:latin typeface="Calibri"/>
               </a:rPr>
-              <a:t>MFA incl. phishing-resistant passkeys (AAL2/3)</a:t>
-            </a:r>
-          </a:p>
-          <a:p>
-            <a:pPr algn="l">
-              <a:spcAft>
-                <a:spcPts val="500"/>
+              <a:t>•  MFA incl. phishing-resistant passkeys (AAL2/3)</a:t>
+            </a:r>
+          </a:p>
+          <a:p>
+            <a:pPr algn="l">
+              <a:spcAft>
+                <a:spcPts val="700"/>
               </a:spcAft>
             </a:pPr>
             <a:r>
@@ -6133,13 +6318,13 @@
                 </a:solidFill>
                 <a:latin typeface="Calibri"/>
               </a:rPr>
-              <a:t>RBAC · audit log + SIEM export (/api/v1/audit)</a:t>
-            </a:r>
-          </a:p>
-          <a:p>
-            <a:pPr algn="l">
-              <a:spcAft>
-                <a:spcPts val="500"/>
+              <a:t>•  RBAC · audit log + SIEM export (/api/v1/audit)</a:t>
+            </a:r>
+          </a:p>
+          <a:p>
+            <a:pPr algn="l">
+              <a:spcAft>
+                <a:spcPts val="700"/>
               </a:spcAft>
             </a:pPr>
             <a:r>
@@ -6149,13 +6334,13 @@
                 </a:solidFill>
                 <a:latin typeface="Calibri"/>
               </a:rPr>
-              <a:t>Session controls: idle/absolute/epoch revocation</a:t>
-            </a:r>
-          </a:p>
-          <a:p>
-            <a:pPr algn="l">
-              <a:spcAft>
-                <a:spcPts val="500"/>
+              <a:t>•  Session controls: idle/absolute/epoch revocation</a:t>
+            </a:r>
+          </a:p>
+          <a:p>
+            <a:pPr algn="l">
+              <a:spcAft>
+                <a:spcPts val="700"/>
               </a:spcAft>
             </a:pPr>
             <a:r>
@@ -6165,13 +6350,13 @@
                 </a:solidFill>
                 <a:latin typeface="Calibri"/>
               </a:rPr>
-              <a:t>Retention + self-serve erasure</a:t>
-            </a:r>
-          </a:p>
-          <a:p>
-            <a:pPr algn="l">
-              <a:spcAft>
-                <a:spcPts val="500"/>
+              <a:t>•  Retention + self-serve erasure</a:t>
+            </a:r>
+          </a:p>
+          <a:p>
+            <a:pPr algn="l">
+              <a:spcAft>
+                <a:spcPts val="700"/>
               </a:spcAft>
             </a:pPr>
             <a:r>
@@ -6181,13 +6366,13 @@
                 </a:solidFill>
                 <a:latin typeface="Calibri"/>
               </a:rPr>
-              <a:t>Encryption at rest + pluggable KMS hook</a:t>
-            </a:r>
-          </a:p>
-          <a:p>
-            <a:pPr algn="l">
-              <a:spcAft>
-                <a:spcPts val="500"/>
+              <a:t>•  Encryption at rest + pluggable KMS hook</a:t>
+            </a:r>
+          </a:p>
+          <a:p>
+            <a:pPr algn="l">
+              <a:spcAft>
+                <a:spcPts val="700"/>
               </a:spcAft>
             </a:pPr>
             <a:r>
@@ -6197,13 +6382,13 @@
                 </a:solidFill>
                 <a:latin typeface="Calibri"/>
               </a:rPr>
-              <a:t>IR plan (MD-SOC 1-hr) + incident webhook</a:t>
-            </a:r>
-          </a:p>
-          <a:p>
-            <a:pPr algn="l">
-              <a:spcAft>
-                <a:spcPts val="500"/>
+              <a:t>•  IR plan (MD-SOC 1-hr) + incident webhook</a:t>
+            </a:r>
+          </a:p>
+          <a:p>
+            <a:pPr algn="l">
+              <a:spcAft>
+                <a:spcPts val="700"/>
               </a:spcAft>
             </a:pPr>
             <a:r>
@@ -6213,7 +6398,7 @@
                 </a:solidFill>
                 <a:latin typeface="Calibri"/>
               </a:rPr>
-              <a:t>WCAG 2.1 AA + automated a11y &amp; security CI scans</a:t>
+              <a:t>•  WCAG 2.1 AA + automated a11y &amp; security CI scans</a:t>
             </a:r>
           </a:p>
         </p:txBody>
@@ -6226,8 +6411,8 @@
         </p:nvSpPr>
         <p:spPr>
           <a:xfrm>
-            <a:off x="6309360" y="2103120"/>
-            <a:ext cx="5029200" cy="3840480"/>
+            <a:off x="6245352" y="1965960"/>
+            <a:ext cx="5394960" cy="4297680"/>
           </a:xfrm>
           <a:prstGeom prst="rect">
             <a:avLst/>
@@ -6235,7 +6420,7 @@
           <a:solidFill>
             <a:srgbClr val="FFFFFF"/>
           </a:solidFill>
-          <a:ln w="12700">
+          <a:ln w="15875">
             <a:solidFill>
               <a:srgbClr val="9A5A18"/>
             </a:solidFill>
@@ -6257,16 +6442,16 @@
           </a:fontRef>
         </p:style>
         <p:txBody>
-          <a:bodyPr rtlCol="0" anchor="t" wrap="square" lIns="228600" rIns="228600" tIns="164592"/>
-          <a:lstStyle/>
-          <a:p>
-            <a:pPr algn="l">
-              <a:spcAft>
-                <a:spcPts val="800"/>
-              </a:spcAft>
-            </a:pPr>
-            <a:r>
-              <a:rPr sz="1200" b="1">
+          <a:bodyPr rtlCol="0" anchor="t" wrap="square" lIns="256032" rIns="256032" tIns="201168"/>
+          <a:lstStyle/>
+          <a:p>
+            <a:pPr algn="l">
+              <a:spcAft>
+                <a:spcPts val="1000"/>
+              </a:spcAft>
+            </a:pPr>
+            <a:r>
+              <a:rPr sz="1300" b="1">
                 <a:solidFill>
                   <a:srgbClr val="5C6470"/>
                 </a:solidFill>
@@ -6278,7 +6463,7 @@
           <a:p>
             <a:pPr algn="l">
               <a:spcAft>
-                <a:spcPts val="500"/>
+                <a:spcPts val="700"/>
               </a:spcAft>
             </a:pPr>
             <a:r>
@@ -6288,13 +6473,13 @@
                 </a:solidFill>
                 <a:latin typeface="Calibri"/>
               </a:rPr>
-              <a:t>SOC 2 Type II — in progress (highest leverage)</a:t>
-            </a:r>
-          </a:p>
-          <a:p>
-            <a:pPr algn="l">
-              <a:spcAft>
-                <a:spcPts val="500"/>
+              <a:t>•  SOC 2 Type II — in progress (highest leverage)</a:t>
+            </a:r>
+          </a:p>
+          <a:p>
+            <a:pPr algn="l">
+              <a:spcAft>
+                <a:spcPts val="700"/>
               </a:spcAft>
             </a:pPr>
             <a:r>
@@ -6304,13 +6489,13 @@
                 </a:solidFill>
                 <a:latin typeface="Calibri"/>
               </a:rPr>
-              <a:t>Annual third-party penetration test</a:t>
-            </a:r>
-          </a:p>
-          <a:p>
-            <a:pPr algn="l">
-              <a:spcAft>
-                <a:spcPts val="500"/>
+              <a:t>•  Annual third-party penetration test</a:t>
+            </a:r>
+          </a:p>
+          <a:p>
+            <a:pPr algn="l">
+              <a:spcAft>
+                <a:spcPts val="700"/>
               </a:spcAft>
             </a:pPr>
             <a:r>
@@ -6320,13 +6505,13 @@
                 </a:solidFill>
                 <a:latin typeface="Calibri"/>
               </a:rPr>
-              <a:t>Monthly vulnerability-scan program + patch SLA</a:t>
-            </a:r>
-          </a:p>
-          <a:p>
-            <a:pPr algn="l">
-              <a:spcAft>
-                <a:spcPts val="500"/>
+              <a:t>•  Monthly vulnerability-scan program + patch SLA</a:t>
+            </a:r>
+          </a:p>
+          <a:p>
+            <a:pPr algn="l">
+              <a:spcAft>
+                <a:spcPts val="700"/>
               </a:spcAft>
             </a:pPr>
             <a:r>
@@ -6336,13 +6521,13 @@
                 </a:solidFill>
                 <a:latin typeface="Calibri"/>
               </a:rPr>
-              <a:t>StateRAMP / GovRAMP (Ready → Authorized)</a:t>
-            </a:r>
-          </a:p>
-          <a:p>
-            <a:pPr algn="l">
-              <a:spcAft>
-                <a:spcPts val="500"/>
+              <a:t>•  StateRAMP / GovRAMP (Ready → Authorized)</a:t>
+            </a:r>
+          </a:p>
+          <a:p>
+            <a:pPr algn="l">
+              <a:spcAft>
+                <a:spcPts val="700"/>
               </a:spcAft>
             </a:pPr>
             <a:r>
@@ -6352,13 +6537,13 @@
                 </a:solidFill>
                 <a:latin typeface="Calibri"/>
               </a:rPr>
-              <a:t>FedRAMP-authorized cloud (AWS GovCloud / Azure Gov)</a:t>
-            </a:r>
-          </a:p>
-          <a:p>
-            <a:pPr algn="l">
-              <a:spcAft>
-                <a:spcPts val="500"/>
+              <a:t>•  FedRAMP-authorized cloud (AWS GovCloud / Azure Gov)</a:t>
+            </a:r>
+          </a:p>
+          <a:p>
+            <a:pPr algn="l">
+              <a:spcAft>
+                <a:spcPts val="700"/>
               </a:spcAft>
             </a:pPr>
             <a:r>
@@ -6368,13 +6553,13 @@
                 </a:solidFill>
                 <a:latin typeface="Calibri"/>
               </a:rPr>
-              <a:t>FIPS 140-validated crypto (IRS 1075)</a:t>
-            </a:r>
-          </a:p>
-          <a:p>
-            <a:pPr algn="l">
-              <a:spcAft>
-                <a:spcPts val="500"/>
+              <a:t>•  FIPS 140-validated crypto (IRS 1075)</a:t>
+            </a:r>
+          </a:p>
+          <a:p>
+            <a:pPr algn="l">
+              <a:spcAft>
+                <a:spcPts val="700"/>
               </a:spcAft>
             </a:pPr>
             <a:r>
@@ -6384,7 +6569,7 @@
                 </a:solidFill>
                 <a:latin typeface="Calibri"/>
               </a:rPr>
-              <a:t>3PAO assessment vs NIST 800-53 Rev 5</a:t>
+              <a:t>•  3PAO assessment vs NIST 800-53 Rev 5</a:t>
             </a:r>
           </a:p>
         </p:txBody>
@@ -6459,8 +6644,8 @@
         </p:nvSpPr>
         <p:spPr>
           <a:xfrm>
-            <a:off x="822960" y="640080"/>
-            <a:ext cx="10515600" cy="457200"/>
+            <a:off x="548640" y="457200"/>
+            <a:ext cx="11091672" cy="457200"/>
           </a:xfrm>
           <a:prstGeom prst="rect">
             <a:avLst/>
@@ -6498,8 +6683,8 @@
         </p:nvSpPr>
         <p:spPr>
           <a:xfrm>
-            <a:off x="822960" y="1371600"/>
-            <a:ext cx="10515600" cy="3657600"/>
+            <a:off x="548640" y="1234440"/>
+            <a:ext cx="11091672" cy="1463040"/>
           </a:xfrm>
           <a:prstGeom prst="rect">
             <a:avLst/>
@@ -6514,11 +6699,11 @@
           <a:p>
             <a:pPr algn="l">
               <a:spcAft>
-                <a:spcPts val="1800"/>
-              </a:spcAft>
-            </a:pPr>
-            <a:r>
-              <a:rPr sz="3200" b="1">
+                <a:spcPts val="600"/>
+              </a:spcAft>
+            </a:pPr>
+            <a:r>
+              <a:rPr sz="3800" b="1">
                 <a:solidFill>
                   <a:srgbClr val="1F2430"/>
                 </a:solidFill>
@@ -6527,14 +6712,37 @@
               <a:t>Maryland is operationalizing its 2025 AI Enablement Strategy.</a:t>
             </a:r>
           </a:p>
-          <a:p>
-            <a:pPr algn="l">
-              <a:spcAft>
-                <a:spcPts val="800"/>
-              </a:spcAft>
-            </a:pPr>
-            <a:r>
-              <a:rPr sz="2000" b="0">
+        </p:txBody>
+      </p:sp>
+      <p:sp>
+        <p:nvSpPr>
+          <p:cNvPr id="5" name="TextBox 4"/>
+          <p:cNvSpPr txBox="1"/>
+          <p:nvPr/>
+        </p:nvSpPr>
+        <p:spPr>
+          <a:xfrm>
+            <a:off x="548640" y="2971800"/>
+            <a:ext cx="11091672" cy="548640"/>
+          </a:xfrm>
+          <a:prstGeom prst="rect">
+            <a:avLst/>
+          </a:prstGeom>
+          <a:noFill/>
+        </p:spPr>
+        <p:txBody>
+          <a:bodyPr wrap="square">
+            <a:spAutoFit/>
+          </a:bodyPr>
+          <a:lstStyle/>
+          <a:p>
+            <a:pPr algn="l">
+              <a:spcAft>
+                <a:spcPts val="600"/>
+              </a:spcAft>
+            </a:pPr>
+            <a:r>
+              <a:rPr sz="2200" b="0">
                 <a:solidFill>
                   <a:srgbClr val="5C6470"/>
                 </a:solidFill>
@@ -6543,22 +6751,86 @@
               <a:t>Right after “is it safe?” comes the question every CFO and CIO asks:</a:t>
             </a:r>
           </a:p>
-          <a:p>
-            <a:pPr algn="l">
-              <a:spcAft>
-                <a:spcPts val="2000"/>
-              </a:spcAft>
-            </a:pPr>
-            <a:r>
-              <a:rPr sz="2400" b="1">
-                <a:solidFill>
-                  <a:srgbClr val="0F6B4F"/>
-                </a:solidFill>
-                <a:latin typeface="Calibri"/>
+        </p:txBody>
+      </p:sp>
+      <p:sp>
+        <p:nvSpPr>
+          <p:cNvPr id="6" name="Rectangle 5"/>
+          <p:cNvSpPr/>
+          <p:nvPr/>
+        </p:nvSpPr>
+        <p:spPr>
+          <a:xfrm>
+            <a:off x="548640" y="3703320"/>
+            <a:ext cx="11091672" cy="1143000"/>
+          </a:xfrm>
+          <a:prstGeom prst="rect">
+            <a:avLst/>
+          </a:prstGeom>
+          <a:solidFill>
+            <a:srgbClr val="E7F1EC"/>
+          </a:solidFill>
+          <a:ln>
+            <a:noFill/>
+          </a:ln>
+          <a:effectLst/>
+        </p:spPr>
+        <p:style>
+          <a:lnRef idx="1">
+            <a:schemeClr val="accent1"/>
+          </a:lnRef>
+          <a:fillRef idx="3">
+            <a:schemeClr val="accent1"/>
+          </a:fillRef>
+          <a:effectRef idx="2">
+            <a:schemeClr val="accent1"/>
+          </a:effectRef>
+          <a:fontRef idx="minor">
+            <a:schemeClr val="lt1"/>
+          </a:fontRef>
+        </p:style>
+        <p:txBody>
+          <a:bodyPr rtlCol="0" anchor="ctr"/>
+          <a:lstStyle/>
+          <a:p>
+            <a:pPr algn="ctr">
+              <a:spcAft>
+                <a:spcPts val="600"/>
+              </a:spcAft>
+            </a:pPr>
+            <a:r>
+              <a:rPr sz="3000" b="1">
+                <a:solidFill>
+                  <a:srgbClr val="0B513C"/>
+                </a:solidFill>
+                <a:latin typeface="Georgia"/>
               </a:rPr>
               <a:t>“What is the AI costing us — per program — and is it on budget?”</a:t>
             </a:r>
           </a:p>
+        </p:txBody>
+      </p:sp>
+      <p:sp>
+        <p:nvSpPr>
+          <p:cNvPr id="7" name="TextBox 6"/>
+          <p:cNvSpPr txBox="1"/>
+          <p:nvPr/>
+        </p:nvSpPr>
+        <p:spPr>
+          <a:xfrm>
+            <a:off x="548640" y="5212080"/>
+            <a:ext cx="11091672" cy="1097280"/>
+          </a:xfrm>
+          <a:prstGeom prst="rect">
+            <a:avLst/>
+          </a:prstGeom>
+          <a:noFill/>
+        </p:spPr>
+        <p:txBody>
+          <a:bodyPr wrap="square">
+            <a:spAutoFit/>
+          </a:bodyPr>
+          <a:lstStyle/>
           <a:p>
             <a:pPr algn="l">
               <a:spcAft>
@@ -6566,7 +6838,7 @@
               </a:spcAft>
             </a:pPr>
             <a:r>
-              <a:rPr sz="1700" b="0">
+              <a:rPr sz="1900" b="0">
                 <a:solidFill>
                   <a:srgbClr val="5C6470"/>
                 </a:solidFill>
@@ -6647,8 +6919,8 @@
         </p:nvSpPr>
         <p:spPr>
           <a:xfrm>
-            <a:off x="822960" y="640080"/>
-            <a:ext cx="10515600" cy="457200"/>
+            <a:off x="548640" y="457200"/>
+            <a:ext cx="11091672" cy="457200"/>
           </a:xfrm>
           <a:prstGeom prst="rect">
             <a:avLst/>
@@ -6686,8 +6958,8 @@
         </p:nvSpPr>
         <p:spPr>
           <a:xfrm>
-            <a:off x="822960" y="1280160"/>
-            <a:ext cx="10515600" cy="914400"/>
+            <a:off x="548640" y="960120"/>
+            <a:ext cx="11091672" cy="731520"/>
           </a:xfrm>
           <a:prstGeom prst="rect">
             <a:avLst/>
@@ -6706,7 +6978,7 @@
               </a:spcAft>
             </a:pPr>
             <a:r>
-              <a:rPr sz="3000" b="1">
+              <a:rPr sz="3200" b="1">
                 <a:solidFill>
                   <a:srgbClr val="1F2430"/>
                 </a:solidFill>
@@ -6725,8 +6997,8 @@
         </p:nvSpPr>
         <p:spPr>
           <a:xfrm>
-            <a:off x="822960" y="2468880"/>
-            <a:ext cx="6035040" cy="3657600"/>
+            <a:off x="548640" y="2148840"/>
+            <a:ext cx="4297680" cy="4023360"/>
           </a:xfrm>
           <a:prstGeom prst="rect">
             <a:avLst/>
@@ -6741,11 +7013,11 @@
           <a:p>
             <a:pPr algn="l">
               <a:spcAft>
-                <a:spcPts val="1200"/>
-              </a:spcAft>
-            </a:pPr>
-            <a:r>
-              <a:rPr sz="1800" b="0">
+                <a:spcPts val="2200"/>
+              </a:spcAft>
+            </a:pPr>
+            <a:r>
+              <a:rPr sz="1900" b="0">
                 <a:solidFill>
                   <a:srgbClr val="1F2430"/>
                 </a:solidFill>
@@ -6757,11 +7029,11 @@
           <a:p>
             <a:pPr algn="l">
               <a:spcAft>
-                <a:spcPts val="1200"/>
-              </a:spcAft>
-            </a:pPr>
-            <a:r>
-              <a:rPr sz="1800" b="0">
+                <a:spcPts val="2200"/>
+              </a:spcAft>
+            </a:pPr>
+            <a:r>
+              <a:rPr sz="1900" b="0">
                 <a:solidFill>
                   <a:srgbClr val="1F2430"/>
                 </a:solidFill>
@@ -6773,11 +7045,11 @@
           <a:p>
             <a:pPr algn="l">
               <a:spcAft>
-                <a:spcPts val="1200"/>
-              </a:spcAft>
-            </a:pPr>
-            <a:r>
-              <a:rPr sz="1800" b="0">
+                <a:spcPts val="2200"/>
+              </a:spcAft>
+            </a:pPr>
+            <a:r>
+              <a:rPr sz="1900" b="0">
                 <a:solidFill>
                   <a:srgbClr val="1F2430"/>
                 </a:solidFill>
@@ -6790,95 +7062,72 @@
       </p:sp>
       <p:sp>
         <p:nvSpPr>
-          <p:cNvPr id="6" name="Rectangle 5"/>
-          <p:cNvSpPr/>
+          <p:cNvPr id="6" name="TextBox 5"/>
+          <p:cNvSpPr txBox="1"/>
           <p:nvPr/>
         </p:nvSpPr>
         <p:spPr>
           <a:xfrm>
-            <a:off x="7223760" y="2468880"/>
-            <a:ext cx="4114800" cy="2377440"/>
+            <a:off x="548640" y="5943600"/>
+            <a:ext cx="4297680" cy="548640"/>
           </a:xfrm>
           <a:prstGeom prst="rect">
             <a:avLst/>
           </a:prstGeom>
-          <a:solidFill>
-            <a:srgbClr val="FFFFFF"/>
-          </a:solidFill>
-          <a:ln w="12700">
+          <a:noFill/>
+        </p:spPr>
+        <p:txBody>
+          <a:bodyPr wrap="square">
+            <a:spAutoFit/>
+          </a:bodyPr>
+          <a:lstStyle/>
+          <a:p>
+            <a:pPr algn="l">
+              <a:spcAft>
+                <a:spcPts val="600"/>
+              </a:spcAft>
+            </a:pPr>
+            <a:r>
+              <a:rPr sz="1300" b="0">
+                <a:solidFill>
+                  <a:srgbClr val="5C6470"/>
+                </a:solidFill>
+                <a:latin typeface="Calibri"/>
+              </a:rPr>
+              <a:t>Read-only links — no agents, nothing in the request path.</a:t>
+            </a:r>
+          </a:p>
+        </p:txBody>
+      </p:sp>
+      <p:pic>
+        <p:nvPicPr>
+          <p:cNvPr id="7" name="Picture 6" descr="shot-estimate.png"/>
+          <p:cNvPicPr>
+            <a:picLocks noChangeAspect="1"/>
+          </p:cNvPicPr>
+          <p:nvPr/>
+        </p:nvPicPr>
+        <p:blipFill>
+          <a:blip r:embed="rId2"/>
+          <a:stretch>
+            <a:fillRect/>
+          </a:stretch>
+        </p:blipFill>
+        <p:spPr>
+          <a:xfrm>
+            <a:off x="5074920" y="1554480"/>
+            <a:ext cx="6583680" cy="4198289"/>
+          </a:xfrm>
+          <a:prstGeom prst="rect">
+            <a:avLst/>
+          </a:prstGeom>
+          <a:ln w="15875">
             <a:solidFill>
               <a:srgbClr val="E1DDD2"/>
             </a:solidFill>
           </a:ln>
-          <a:effectLst/>
-        </p:spPr>
-        <p:style>
-          <a:lnRef idx="1">
-            <a:schemeClr val="accent1"/>
-          </a:lnRef>
-          <a:fillRef idx="3">
-            <a:schemeClr val="accent1"/>
-          </a:fillRef>
-          <a:effectRef idx="2">
-            <a:schemeClr val="accent1"/>
-          </a:effectRef>
-          <a:fontRef idx="minor">
-            <a:schemeClr val="lt1"/>
-          </a:fontRef>
-        </p:style>
-        <p:txBody>
-          <a:bodyPr rtlCol="0" anchor="t" wrap="square" lIns="228600" rIns="228600" tIns="164592"/>
-          <a:lstStyle/>
-          <a:p>
-            <a:pPr algn="l">
-              <a:spcAft>
-                <a:spcPts val="800"/>
-              </a:spcAft>
-            </a:pPr>
-            <a:r>
-              <a:rPr sz="1200" b="1">
-                <a:solidFill>
-                  <a:srgbClr val="5C6470"/>
-                </a:solidFill>
-                <a:latin typeface="Calibri"/>
-              </a:rPr>
-              <a:t>HOW IT CONNECTS</a:t>
-            </a:r>
-          </a:p>
-          <a:p>
-            <a:pPr algn="l">
-              <a:spcAft>
-                <a:spcPts val="500"/>
-              </a:spcAft>
-            </a:pPr>
-            <a:r>
-              <a:rPr sz="1350" b="0">
-                <a:solidFill>
-                  <a:srgbClr val="1F2430"/>
-                </a:solidFill>
-                <a:latin typeface="Calibri"/>
-              </a:rPr>
-              <a:t>Read-only links to your work tracker (Jira / GitHub / Linear) and your AI provider's usage &amp; billing API.</a:t>
-            </a:r>
-          </a:p>
-          <a:p>
-            <a:pPr algn="l">
-              <a:spcAft>
-                <a:spcPts val="500"/>
-              </a:spcAft>
-            </a:pPr>
-            <a:r>
-              <a:rPr sz="1350" b="0">
-                <a:solidFill>
-                  <a:srgbClr val="1F2430"/>
-                </a:solidFill>
-                <a:latin typeface="Calibri"/>
-              </a:rPr>
-              <a:t>No agents installed. Nothing in the request path.</a:t>
-            </a:r>
-          </a:p>
-        </p:txBody>
-      </p:sp>
+        </p:spPr>
+      </p:pic>
     </p:spTree>
   </p:cSld>
   <p:clrMapOvr>
@@ -6949,8 +7198,8 @@
         </p:nvSpPr>
         <p:spPr>
           <a:xfrm>
-            <a:off x="822960" y="640080"/>
-            <a:ext cx="4206240" cy="502920"/>
+            <a:off x="548640" y="457200"/>
+            <a:ext cx="4297680" cy="502920"/>
           </a:xfrm>
           <a:prstGeom prst="rect">
             <a:avLst/>
@@ -6987,7 +7236,7 @@
               </a:spcAft>
             </a:pPr>
             <a:r>
-              <a:rPr sz="1200" b="1">
+              <a:rPr sz="1250" b="1">
                 <a:solidFill>
                   <a:srgbClr val="0B513C"/>
                 </a:solidFill>
@@ -7006,8 +7255,8 @@
         </p:nvSpPr>
         <p:spPr>
           <a:xfrm>
-            <a:off x="822960" y="1325880"/>
-            <a:ext cx="10515600" cy="914400"/>
+            <a:off x="548640" y="1188720"/>
+            <a:ext cx="11091672" cy="822960"/>
           </a:xfrm>
           <a:prstGeom prst="rect">
             <a:avLst/>
@@ -7026,7 +7275,7 @@
               </a:spcAft>
             </a:pPr>
             <a:r>
-              <a:rPr sz="3000" b="1">
+              <a:rPr sz="3200" b="1">
                 <a:solidFill>
                   <a:srgbClr val="1F2430"/>
                 </a:solidFill>
@@ -7045,8 +7294,8 @@
         </p:nvSpPr>
         <p:spPr>
           <a:xfrm>
-            <a:off x="822960" y="2468880"/>
-            <a:ext cx="4114800" cy="3657600"/>
+            <a:off x="548640" y="2240280"/>
+            <a:ext cx="3977639" cy="4023360"/>
           </a:xfrm>
           <a:prstGeom prst="rect">
             <a:avLst/>
@@ -7061,11 +7310,11 @@
           <a:p>
             <a:pPr algn="l">
               <a:spcAft>
-                <a:spcPts val="1100"/>
-              </a:spcAft>
-            </a:pPr>
-            <a:r>
-              <a:rPr sz="1500" b="0">
+                <a:spcPts val="1800"/>
+              </a:spcAft>
+            </a:pPr>
+            <a:r>
+              <a:rPr sz="1600" b="0">
                 <a:solidFill>
                   <a:srgbClr val="1F2430"/>
                 </a:solidFill>
@@ -7077,11 +7326,11 @@
           <a:p>
             <a:pPr algn="l">
               <a:spcAft>
-                <a:spcPts val="1100"/>
-              </a:spcAft>
-            </a:pPr>
-            <a:r>
-              <a:rPr sz="1500" b="0">
+                <a:spcPts val="1800"/>
+              </a:spcAft>
+            </a:pPr>
+            <a:r>
+              <a:rPr sz="1600" b="0">
                 <a:solidFill>
                   <a:srgbClr val="1F2430"/>
                 </a:solidFill>
@@ -7093,11 +7342,11 @@
           <a:p>
             <a:pPr algn="l">
               <a:spcAft>
-                <a:spcPts val="1100"/>
-              </a:spcAft>
-            </a:pPr>
-            <a:r>
-              <a:rPr sz="1500" b="0">
+                <a:spcPts val="1800"/>
+              </a:spcAft>
+            </a:pPr>
+            <a:r>
+              <a:rPr sz="1600" b="0">
                 <a:solidFill>
                   <a:srgbClr val="1F2430"/>
                 </a:solidFill>
@@ -7109,11 +7358,11 @@
           <a:p>
             <a:pPr algn="l">
               <a:spcAft>
-                <a:spcPts val="1100"/>
-              </a:spcAft>
-            </a:pPr>
-            <a:r>
-              <a:rPr sz="1500" b="0">
+                <a:spcPts val="1800"/>
+              </a:spcAft>
+            </a:pPr>
+            <a:r>
+              <a:rPr sz="1600" b="0">
                 <a:solidFill>
                   <a:srgbClr val="1F2430"/>
                 </a:solidFill>
@@ -7140,13 +7389,13 @@
         </p:blipFill>
         <p:spPr>
           <a:xfrm>
-            <a:off x="5074920" y="2331720"/>
-            <a:ext cx="6629400" cy="3598817"/>
+            <a:off x="4709160" y="2148840"/>
+            <a:ext cx="7178040" cy="3896650"/>
           </a:xfrm>
           <a:prstGeom prst="rect">
             <a:avLst/>
           </a:prstGeom>
-          <a:ln w="12700">
+          <a:ln w="15875">
             <a:solidFill>
               <a:srgbClr val="E1DDD2"/>
             </a:solidFill>
@@ -7223,8 +7472,8 @@
         </p:nvSpPr>
         <p:spPr>
           <a:xfrm>
-            <a:off x="822960" y="640080"/>
-            <a:ext cx="10515600" cy="457200"/>
+            <a:off x="548640" y="457200"/>
+            <a:ext cx="11091672" cy="457200"/>
           </a:xfrm>
           <a:prstGeom prst="rect">
             <a:avLst/>
@@ -7262,8 +7511,8 @@
         </p:nvSpPr>
         <p:spPr>
           <a:xfrm>
-            <a:off x="822960" y="1920240"/>
-            <a:ext cx="4937760" cy="2743200"/>
+            <a:off x="548640" y="1737360"/>
+            <a:ext cx="4846320" cy="1371600"/>
           </a:xfrm>
           <a:prstGeom prst="rect">
             <a:avLst/>
@@ -7278,11 +7527,11 @@
           <a:p>
             <a:pPr algn="l">
               <a:spcAft>
-                <a:spcPts val="1200"/>
-              </a:spcAft>
-            </a:pPr>
-            <a:r>
-              <a:rPr sz="3400" b="1">
+                <a:spcPts val="600"/>
+              </a:spcAft>
+            </a:pPr>
+            <a:r>
+              <a:rPr sz="3800" b="1">
                 <a:solidFill>
                   <a:srgbClr val="FFFFFF"/>
                 </a:solidFill>
@@ -7291,6 +7540,29 @@
               <a:t>Let's look at the product.</a:t>
             </a:r>
           </a:p>
+        </p:txBody>
+      </p:sp>
+      <p:sp>
+        <p:nvSpPr>
+          <p:cNvPr id="5" name="TextBox 4"/>
+          <p:cNvSpPr txBox="1"/>
+          <p:nvPr/>
+        </p:nvSpPr>
+        <p:spPr>
+          <a:xfrm>
+            <a:off x="548640" y="3200400"/>
+            <a:ext cx="4754880" cy="2286000"/>
+          </a:xfrm>
+          <a:prstGeom prst="rect">
+            <a:avLst/>
+          </a:prstGeom>
+          <a:noFill/>
+        </p:spPr>
+        <p:txBody>
+          <a:bodyPr wrap="square">
+            <a:spAutoFit/>
+          </a:bodyPr>
+          <a:lstStyle/>
           <a:p>
             <a:pPr algn="l">
               <a:spcAft>
@@ -7298,7 +7570,7 @@
               </a:spcAft>
             </a:pPr>
             <a:r>
-              <a:rPr sz="1800" b="0">
+              <a:rPr sz="1900" b="0">
                 <a:solidFill>
                   <a:srgbClr val="DDF0E7"/>
                 </a:solidFill>
@@ -7311,7 +7583,7 @@
       </p:sp>
       <p:pic>
         <p:nvPicPr>
-          <p:cNvPr id="5" name="Picture 4" descr="shot-overview.png"/>
+          <p:cNvPr id="6" name="Picture 5" descr="shot-overview.png"/>
           <p:cNvPicPr>
             <a:picLocks noChangeAspect="1"/>
           </p:cNvPicPr>
@@ -7325,13 +7597,13 @@
         </p:blipFill>
         <p:spPr>
           <a:xfrm>
-            <a:off x="6126480" y="1371600"/>
-            <a:ext cx="5577840" cy="3556883"/>
+            <a:off x="5715000" y="1371600"/>
+            <a:ext cx="6172200" cy="3935896"/>
           </a:xfrm>
           <a:prstGeom prst="rect">
             <a:avLst/>
           </a:prstGeom>
-          <a:ln w="12700">
+          <a:ln w="15875">
             <a:solidFill>
               <a:srgbClr val="FFFFFF"/>
             </a:solidFill>
@@ -7408,8 +7680,8 @@
         </p:nvSpPr>
         <p:spPr>
           <a:xfrm>
-            <a:off x="822960" y="640080"/>
-            <a:ext cx="10515600" cy="457200"/>
+            <a:off x="548640" y="457200"/>
+            <a:ext cx="11091672" cy="457200"/>
           </a:xfrm>
           <a:prstGeom prst="rect">
             <a:avLst/>
@@ -7447,8 +7719,8 @@
         </p:nvSpPr>
         <p:spPr>
           <a:xfrm>
-            <a:off x="822960" y="960120"/>
-            <a:ext cx="10515600" cy="640080"/>
+            <a:off x="548640" y="960120"/>
+            <a:ext cx="3703320" cy="1371600"/>
           </a:xfrm>
           <a:prstGeom prst="rect">
             <a:avLst/>
@@ -7467,7 +7739,7 @@
               </a:spcAft>
             </a:pPr>
             <a:r>
-              <a:rPr sz="2700" b="1">
+              <a:rPr sz="2600" b="1">
                 <a:solidFill>
                   <a:srgbClr val="1F2430"/>
                 </a:solidFill>
@@ -7486,8 +7758,8 @@
         </p:nvSpPr>
         <p:spPr>
           <a:xfrm>
-            <a:off x="822960" y="1481328"/>
-            <a:ext cx="10515600" cy="365760"/>
+            <a:off x="548640" y="2468880"/>
+            <a:ext cx="3657600" cy="3474720"/>
           </a:xfrm>
           <a:prstGeom prst="rect">
             <a:avLst/>
@@ -7502,17 +7774,49 @@
           <a:p>
             <a:pPr algn="l">
               <a:spcAft>
-                <a:spcPts val="600"/>
-              </a:spcAft>
-            </a:pPr>
-            <a:r>
-              <a:rPr sz="1400" b="0">
-                <a:solidFill>
-                  <a:srgbClr val="5C6470"/>
+                <a:spcPts val="1600"/>
+              </a:spcAft>
+            </a:pPr>
+            <a:r>
+              <a:rPr sz="1500" b="0">
+                <a:solidFill>
+                  <a:srgbClr val="1F2430"/>
                 </a:solidFill>
                 <a:latin typeface="Calibri"/>
               </a:rPr>
-              <a:t>By team, work type, ticket, and engineer — with ticket coverage shown honestly.</a:t>
+              <a:t>•  By team &amp; cost center, work type, ticket, and engineer.</a:t>
+            </a:r>
+          </a:p>
+          <a:p>
+            <a:pPr algn="l">
+              <a:spcAft>
+                <a:spcPts val="1600"/>
+              </a:spcAft>
+            </a:pPr>
+            <a:r>
+              <a:rPr sz="1500" b="0">
+                <a:solidFill>
+                  <a:srgbClr val="1F2430"/>
+                </a:solidFill>
+                <a:latin typeface="Calibri"/>
+              </a:rPr>
+              <a:t>•  Ticket coverage shown honestly — and how to lift it.</a:t>
+            </a:r>
+          </a:p>
+          <a:p>
+            <a:pPr algn="l">
+              <a:spcAft>
+                <a:spcPts val="1600"/>
+              </a:spcAft>
+            </a:pPr>
+            <a:r>
+              <a:rPr sz="1500" b="0">
+                <a:solidFill>
+                  <a:srgbClr val="1F2430"/>
+                </a:solidFill>
+                <a:latin typeface="Calibri"/>
+              </a:rPr>
+              <a:t>•  FOCUS-aligned CSV export for finance.</a:t>
             </a:r>
           </a:p>
         </p:txBody>
@@ -7533,13 +7837,13 @@
         </p:blipFill>
         <p:spPr>
           <a:xfrm>
-            <a:off x="2350008" y="1874519"/>
-            <a:ext cx="7498079" cy="4781384"/>
+            <a:off x="4343400" y="960120"/>
+            <a:ext cx="7589520" cy="4839694"/>
           </a:xfrm>
           <a:prstGeom prst="rect">
             <a:avLst/>
           </a:prstGeom>
-          <a:ln w="12700">
+          <a:ln w="15875">
             <a:solidFill>
               <a:srgbClr val="E1DDD2"/>
             </a:solidFill>
@@ -7616,8 +7920,8 @@
         </p:nvSpPr>
         <p:spPr>
           <a:xfrm>
-            <a:off x="822960" y="640080"/>
-            <a:ext cx="10515600" cy="457200"/>
+            <a:off x="548640" y="457200"/>
+            <a:ext cx="11091672" cy="457200"/>
           </a:xfrm>
           <a:prstGeom prst="rect">
             <a:avLst/>
@@ -7655,8 +7959,8 @@
         </p:nvSpPr>
         <p:spPr>
           <a:xfrm>
-            <a:off x="822960" y="960120"/>
-            <a:ext cx="10515600" cy="640080"/>
+            <a:off x="548640" y="960120"/>
+            <a:ext cx="3703320" cy="1371600"/>
           </a:xfrm>
           <a:prstGeom prst="rect">
             <a:avLst/>
@@ -7675,7 +7979,7 @@
               </a:spcAft>
             </a:pPr>
             <a:r>
-              <a:rPr sz="2700" b="1">
+              <a:rPr sz="2600" b="1">
                 <a:solidFill>
                   <a:srgbClr val="1F2430"/>
                 </a:solidFill>
@@ -7694,8 +7998,8 @@
         </p:nvSpPr>
         <p:spPr>
           <a:xfrm>
-            <a:off x="822960" y="1481328"/>
-            <a:ext cx="10515600" cy="365760"/>
+            <a:off x="548640" y="2468880"/>
+            <a:ext cx="3657600" cy="3474720"/>
           </a:xfrm>
           <a:prstGeom prst="rect">
             <a:avLst/>
@@ -7710,17 +8014,49 @@
           <a:p>
             <a:pPr algn="l">
               <a:spcAft>
-                <a:spcPts val="600"/>
-              </a:spcAft>
-            </a:pPr>
-            <a:r>
-              <a:rPr sz="1400" b="0">
-                <a:solidFill>
-                  <a:srgbClr val="5C6470"/>
+                <a:spcPts val="1600"/>
+              </a:spcAft>
+            </a:pPr>
+            <a:r>
+              <a:rPr sz="1500" b="0">
+                <a:solidFill>
+                  <a:srgbClr val="1F2430"/>
                 </a:solidFill>
                 <a:latin typeface="Calibri"/>
               </a:rPr>
-              <a:t>Back-tested on your own closed tickets, leave-one-out — the measured error on your data.</a:t>
+              <a:t>•  Back-tested on your own closed tickets (leave-one-out).</a:t>
+            </a:r>
+          </a:p>
+          <a:p>
+            <a:pPr algn="l">
+              <a:spcAft>
+                <a:spcPts val="1600"/>
+              </a:spcAft>
+            </a:pPr>
+            <a:r>
+              <a:rPr sz="1500" b="0">
+                <a:solidFill>
+                  <a:srgbClr val="1F2430"/>
+                </a:solidFill>
+                <a:latin typeface="Calibri"/>
+              </a:rPr>
+              <a:t>•  Median error, within-P90, and sample size — never hidden.</a:t>
+            </a:r>
+          </a:p>
+          <a:p>
+            <a:pPr algn="l">
+              <a:spcAft>
+                <a:spcPts val="1600"/>
+              </a:spcAft>
+            </a:pPr>
+            <a:r>
+              <a:rPr sz="1500" b="0">
+                <a:solidFill>
+                  <a:srgbClr val="1F2430"/>
+                </a:solidFill>
+                <a:latin typeface="Calibri"/>
+              </a:rPr>
+              <a:t>•  Per-work-type accuracy with over/under bias.</a:t>
             </a:r>
           </a:p>
         </p:txBody>
@@ -7741,13 +8077,13 @@
         </p:blipFill>
         <p:spPr>
           <a:xfrm>
-            <a:off x="2350008" y="1874519"/>
-            <a:ext cx="7498079" cy="4781384"/>
+            <a:off x="4343400" y="960120"/>
+            <a:ext cx="7589520" cy="4839694"/>
           </a:xfrm>
           <a:prstGeom prst="rect">
             <a:avLst/>
           </a:prstGeom>
-          <a:ln w="12700">
+          <a:ln w="15875">
             <a:solidFill>
               <a:srgbClr val="E1DDD2"/>
             </a:solidFill>
@@ -7824,8 +8160,8 @@
         </p:nvSpPr>
         <p:spPr>
           <a:xfrm>
-            <a:off x="822960" y="640080"/>
-            <a:ext cx="10515600" cy="457200"/>
+            <a:off x="548640" y="457200"/>
+            <a:ext cx="11091672" cy="457200"/>
           </a:xfrm>
           <a:prstGeom prst="rect">
             <a:avLst/>
@@ -7863,8 +8199,8 @@
         </p:nvSpPr>
         <p:spPr>
           <a:xfrm>
-            <a:off x="822960" y="960120"/>
-            <a:ext cx="10515600" cy="640080"/>
+            <a:off x="548640" y="960120"/>
+            <a:ext cx="3703320" cy="1371600"/>
           </a:xfrm>
           <a:prstGeom prst="rect">
             <a:avLst/>
@@ -7883,7 +8219,7 @@
               </a:spcAft>
             </a:pPr>
             <a:r>
-              <a:rPr sz="2700" b="1">
+              <a:rPr sz="2600" b="1">
                 <a:solidFill>
                   <a:srgbClr val="1F2430"/>
                 </a:solidFill>
@@ -7902,8 +8238,8 @@
         </p:nvSpPr>
         <p:spPr>
           <a:xfrm>
-            <a:off x="822960" y="1481328"/>
-            <a:ext cx="10515600" cy="365760"/>
+            <a:off x="548640" y="2468880"/>
+            <a:ext cx="3657600" cy="3474720"/>
           </a:xfrm>
           <a:prstGeom prst="rect">
             <a:avLst/>
@@ -7918,17 +8254,49 @@
           <a:p>
             <a:pPr algn="l">
               <a:spcAft>
-                <a:spcPts val="600"/>
-              </a:spcAft>
-            </a:pPr>
-            <a:r>
-              <a:rPr sz="1400" b="0">
-                <a:solidFill>
-                  <a:srgbClr val="5C6470"/>
+                <a:spcPts val="1600"/>
+              </a:spcAft>
+            </a:pPr>
+            <a:r>
+              <a:rPr sz="1500" b="0">
+                <a:solidFill>
+                  <a:srgbClr val="1F2430"/>
                 </a:solidFill>
                 <a:latin typeface="Calibri"/>
               </a:rPr>
-              <a:t>Program budgets, projected breach dates, and an on-/off-track earned-value rating.</a:t>
+              <a:t>•  Program budgets across teams, projects, and work types.</a:t>
+            </a:r>
+          </a:p>
+          <a:p>
+            <a:pPr algn="l">
+              <a:spcAft>
+                <a:spcPts val="1600"/>
+              </a:spcAft>
+            </a:pPr>
+            <a:r>
+              <a:rPr sz="1500" b="0">
+                <a:solidFill>
+                  <a:srgbClr val="1F2430"/>
+                </a:solidFill>
+                <a:latin typeface="Calibri"/>
+              </a:rPr>
+              <a:t>•  Real-time pacing → the projected breach date.</a:t>
+            </a:r>
+          </a:p>
+          <a:p>
+            <a:pPr algn="l">
+              <a:spcAft>
+                <a:spcPts val="1600"/>
+              </a:spcAft>
+            </a:pPr>
+            <a:r>
+              <a:rPr sz="1500" b="0">
+                <a:solidFill>
+                  <a:srgbClr val="1F2430"/>
+                </a:solidFill>
+                <a:latin typeface="Calibri"/>
+              </a:rPr>
+              <a:t>•  On-/off-track earned-value rating; alerts to your SIEM.</a:t>
             </a:r>
           </a:p>
         </p:txBody>
@@ -7949,13 +8317,13 @@
         </p:blipFill>
         <p:spPr>
           <a:xfrm>
-            <a:off x="2350008" y="1874519"/>
-            <a:ext cx="7498079" cy="4781384"/>
+            <a:off x="4343400" y="960120"/>
+            <a:ext cx="7589520" cy="4839694"/>
           </a:xfrm>
           <a:prstGeom prst="rect">
             <a:avLst/>
           </a:prstGeom>
-          <a:ln w="12700">
+          <a:ln w="15875">
             <a:solidFill>
               <a:srgbClr val="E1DDD2"/>
             </a:solidFill>
@@ -8032,8 +8400,8 @@
         </p:nvSpPr>
         <p:spPr>
           <a:xfrm>
-            <a:off x="822960" y="640080"/>
-            <a:ext cx="10515600" cy="457200"/>
+            <a:off x="548640" y="457200"/>
+            <a:ext cx="11091672" cy="457200"/>
           </a:xfrm>
           <a:prstGeom prst="rect">
             <a:avLst/>
@@ -8071,8 +8439,8 @@
         </p:nvSpPr>
         <p:spPr>
           <a:xfrm>
-            <a:off x="822960" y="1188720"/>
-            <a:ext cx="10515600" cy="914400"/>
+            <a:off x="548640" y="1005840"/>
+            <a:ext cx="11091672" cy="731520"/>
           </a:xfrm>
           <a:prstGeom prst="rect">
             <a:avLst/>
@@ -8091,7 +8459,7 @@
               </a:spcAft>
             </a:pPr>
             <a:r>
-              <a:rPr sz="3000" b="1">
+              <a:rPr sz="3200" b="1">
                 <a:solidFill>
                   <a:srgbClr val="1F2430"/>
                 </a:solidFill>
@@ -8110,8 +8478,8 @@
         </p:nvSpPr>
         <p:spPr>
           <a:xfrm>
-            <a:off x="822960" y="2286000"/>
-            <a:ext cx="5212080" cy="3291840"/>
+            <a:off x="548640" y="2103120"/>
+            <a:ext cx="5394960" cy="4069080"/>
           </a:xfrm>
           <a:prstGeom prst="rect">
             <a:avLst/>
@@ -8119,7 +8487,7 @@
           <a:solidFill>
             <a:srgbClr val="FFFFFF"/>
           </a:solidFill>
-          <a:ln w="12700">
+          <a:ln w="15875">
             <a:solidFill>
               <a:srgbClr val="0F6B4F"/>
             </a:solidFill>
@@ -8141,16 +8509,16 @@
           </a:fontRef>
         </p:style>
         <p:txBody>
-          <a:bodyPr rtlCol="0" anchor="t" wrap="square" lIns="228600" rIns="228600" tIns="164592"/>
-          <a:lstStyle/>
-          <a:p>
-            <a:pPr algn="l">
-              <a:spcAft>
-                <a:spcPts val="800"/>
-              </a:spcAft>
-            </a:pPr>
-            <a:r>
-              <a:rPr sz="1200" b="1">
+          <a:bodyPr rtlCol="0" anchor="t" wrap="square" lIns="256032" rIns="256032" tIns="201168"/>
+          <a:lstStyle/>
+          <a:p>
+            <a:pPr algn="l">
+              <a:spcAft>
+                <a:spcPts val="1000"/>
+              </a:spcAft>
+            </a:pPr>
+            <a:r>
+              <a:rPr sz="1300" b="1">
                 <a:solidFill>
                   <a:srgbClr val="5C6470"/>
                 </a:solidFill>
@@ -8162,97 +8530,97 @@
           <a:p>
             <a:pPr algn="l">
               <a:spcAft>
-                <a:spcPts val="500"/>
-              </a:spcAft>
-            </a:pPr>
-            <a:r>
-              <a:rPr sz="1350" b="0">
+                <a:spcPts val="1100"/>
+              </a:spcAft>
+            </a:pPr>
+            <a:r>
+              <a:rPr sz="1500" b="0">
                 <a:solidFill>
                   <a:srgbClr val="1F2430"/>
                 </a:solidFill>
                 <a:latin typeface="Calibri"/>
               </a:rPr>
-              <a:t>SSO (OIDC) + SCIM provisioning</a:t>
-            </a:r>
-          </a:p>
-          <a:p>
-            <a:pPr algn="l">
-              <a:spcAft>
-                <a:spcPts val="500"/>
-              </a:spcAft>
-            </a:pPr>
-            <a:r>
-              <a:rPr sz="1350" b="0">
+              <a:t>•  SSO (OIDC) + SCIM provisioning</a:t>
+            </a:r>
+          </a:p>
+          <a:p>
+            <a:pPr algn="l">
+              <a:spcAft>
+                <a:spcPts val="1100"/>
+              </a:spcAft>
+            </a:pPr>
+            <a:r>
+              <a:rPr sz="1500" b="0">
                 <a:solidFill>
                   <a:srgbClr val="1F2430"/>
                 </a:solidFill>
                 <a:latin typeface="Calibri"/>
               </a:rPr>
-              <a:t>Phishing-resistant MFA (passkeys)</a:t>
-            </a:r>
-          </a:p>
-          <a:p>
-            <a:pPr algn="l">
-              <a:spcAft>
-                <a:spcPts val="500"/>
-              </a:spcAft>
-            </a:pPr>
-            <a:r>
-              <a:rPr sz="1350" b="0">
+              <a:t>•  Phishing-resistant MFA (passkeys)</a:t>
+            </a:r>
+          </a:p>
+          <a:p>
+            <a:pPr algn="l">
+              <a:spcAft>
+                <a:spcPts val="1100"/>
+              </a:spcAft>
+            </a:pPr>
+            <a:r>
+              <a:rPr sz="1500" b="0">
                 <a:solidFill>
                   <a:srgbClr val="1F2430"/>
                 </a:solidFill>
                 <a:latin typeface="Calibri"/>
               </a:rPr>
-              <a:t>RBAC · audit log → SIEM export</a:t>
-            </a:r>
-          </a:p>
-          <a:p>
-            <a:pPr algn="l">
-              <a:spcAft>
-                <a:spcPts val="500"/>
-              </a:spcAft>
-            </a:pPr>
-            <a:r>
-              <a:rPr sz="1350" b="0">
+              <a:t>•  RBAC · audit log → SIEM export</a:t>
+            </a:r>
+          </a:p>
+          <a:p>
+            <a:pPr algn="l">
+              <a:spcAft>
+                <a:spcPts val="1100"/>
+              </a:spcAft>
+            </a:pPr>
+            <a:r>
+              <a:rPr sz="1500" b="0">
                 <a:solidFill>
                   <a:srgbClr val="1F2430"/>
                 </a:solidFill>
                 <a:latin typeface="Calibri"/>
               </a:rPr>
-              <a:t>Retention + self-serve erasure</a:t>
-            </a:r>
-          </a:p>
-          <a:p>
-            <a:pPr algn="l">
-              <a:spcAft>
-                <a:spcPts val="500"/>
-              </a:spcAft>
-            </a:pPr>
-            <a:r>
-              <a:rPr sz="1350" b="0">
+              <a:t>•  Retention + self-serve erasure</a:t>
+            </a:r>
+          </a:p>
+          <a:p>
+            <a:pPr algn="l">
+              <a:spcAft>
+                <a:spcPts val="1100"/>
+              </a:spcAft>
+            </a:pPr>
+            <a:r>
+              <a:rPr sz="1500" b="0">
                 <a:solidFill>
                   <a:srgbClr val="1F2430"/>
                 </a:solidFill>
                 <a:latin typeface="Calibri"/>
               </a:rPr>
-              <a:t>Encryption at rest + KMS hook</a:t>
-            </a:r>
-          </a:p>
-          <a:p>
-            <a:pPr algn="l">
-              <a:spcAft>
-                <a:spcPts val="500"/>
-              </a:spcAft>
-            </a:pPr>
-            <a:r>
-              <a:rPr sz="1350" b="0">
+              <a:t>•  Encryption at rest + KMS hook</a:t>
+            </a:r>
+          </a:p>
+          <a:p>
+            <a:pPr algn="l">
+              <a:spcAft>
+                <a:spcPts val="1100"/>
+              </a:spcAft>
+            </a:pPr>
+            <a:r>
+              <a:rPr sz="1500" b="0">
                 <a:solidFill>
                   <a:srgbClr val="1F2430"/>
                 </a:solidFill>
                 <a:latin typeface="Calibri"/>
               </a:rPr>
-              <a:t>IR plan · WCAG 2.1 AA · CI security scan</a:t>
+              <a:t>•  IR plan · WCAG 2.1 AA · CI security scan</a:t>
             </a:r>
           </a:p>
         </p:txBody>
@@ -8265,8 +8633,8 @@
         </p:nvSpPr>
         <p:spPr>
           <a:xfrm>
-            <a:off x="6309360" y="2286000"/>
-            <a:ext cx="5029200" cy="3291840"/>
+            <a:off x="6245352" y="2103120"/>
+            <a:ext cx="5394960" cy="4069080"/>
           </a:xfrm>
           <a:prstGeom prst="rect">
             <a:avLst/>
@@ -8274,7 +8642,7 @@
           <a:solidFill>
             <a:srgbClr val="FFFFFF"/>
           </a:solidFill>
-          <a:ln w="12700">
+          <a:ln w="15875">
             <a:solidFill>
               <a:srgbClr val="9A5A18"/>
             </a:solidFill>
@@ -8296,16 +8664,16 @@
           </a:fontRef>
         </p:style>
         <p:txBody>
-          <a:bodyPr rtlCol="0" anchor="t" wrap="square" lIns="228600" rIns="228600" tIns="164592"/>
-          <a:lstStyle/>
-          <a:p>
-            <a:pPr algn="l">
-              <a:spcAft>
-                <a:spcPts val="800"/>
-              </a:spcAft>
-            </a:pPr>
-            <a:r>
-              <a:rPr sz="1200" b="1">
+          <a:bodyPr rtlCol="0" anchor="t" wrap="square" lIns="256032" rIns="256032" tIns="201168"/>
+          <a:lstStyle/>
+          <a:p>
+            <a:pPr algn="l">
+              <a:spcAft>
+                <a:spcPts val="1000"/>
+              </a:spcAft>
+            </a:pPr>
+            <a:r>
+              <a:rPr sz="1300" b="1">
                 <a:solidFill>
                   <a:srgbClr val="5C6470"/>
                 </a:solidFill>
@@ -8317,81 +8685,81 @@
           <a:p>
             <a:pPr algn="l">
               <a:spcAft>
-                <a:spcPts val="500"/>
-              </a:spcAft>
-            </a:pPr>
-            <a:r>
-              <a:rPr sz="1350" b="0">
+                <a:spcPts val="1100"/>
+              </a:spcAft>
+            </a:pPr>
+            <a:r>
+              <a:rPr sz="1500" b="0">
                 <a:solidFill>
                   <a:srgbClr val="1F2430"/>
                 </a:solidFill>
                 <a:latin typeface="Calibri"/>
               </a:rPr>
-              <a:t>SOC 2 Type II — in progress</a:t>
-            </a:r>
-          </a:p>
-          <a:p>
-            <a:pPr algn="l">
-              <a:spcAft>
-                <a:spcPts val="500"/>
-              </a:spcAft>
-            </a:pPr>
-            <a:r>
-              <a:rPr sz="1350" b="0">
+              <a:t>•  SOC 2 Type II — in progress</a:t>
+            </a:r>
+          </a:p>
+          <a:p>
+            <a:pPr algn="l">
+              <a:spcAft>
+                <a:spcPts val="1100"/>
+              </a:spcAft>
+            </a:pPr>
+            <a:r>
+              <a:rPr sz="1500" b="0">
                 <a:solidFill>
                   <a:srgbClr val="1F2430"/>
                 </a:solidFill>
                 <a:latin typeface="Calibri"/>
               </a:rPr>
-              <a:t>Annual pen test — scheduled</a:t>
-            </a:r>
-          </a:p>
-          <a:p>
-            <a:pPr algn="l">
-              <a:spcAft>
-                <a:spcPts val="500"/>
-              </a:spcAft>
-            </a:pPr>
-            <a:r>
-              <a:rPr sz="1350" b="0">
+              <a:t>•  Annual penetration test — scheduled</a:t>
+            </a:r>
+          </a:p>
+          <a:p>
+            <a:pPr algn="l">
+              <a:spcAft>
+                <a:spcPts val="1100"/>
+              </a:spcAft>
+            </a:pPr>
+            <a:r>
+              <a:rPr sz="1500" b="0">
                 <a:solidFill>
                   <a:srgbClr val="1F2430"/>
                 </a:solidFill>
                 <a:latin typeface="Calibri"/>
               </a:rPr>
-              <a:t>StateRAMP / GovRAMP — roadmap</a:t>
-            </a:r>
-          </a:p>
-          <a:p>
-            <a:pPr algn="l">
-              <a:spcAft>
-                <a:spcPts val="500"/>
-              </a:spcAft>
-            </a:pPr>
-            <a:r>
-              <a:rPr sz="1350" b="0">
+              <a:t>•  StateRAMP / GovRAMP — roadmap</a:t>
+            </a:r>
+          </a:p>
+          <a:p>
+            <a:pPr algn="l">
+              <a:spcAft>
+                <a:spcPts val="1100"/>
+              </a:spcAft>
+            </a:pPr>
+            <a:r>
+              <a:rPr sz="1500" b="0">
                 <a:solidFill>
                   <a:srgbClr val="1F2430"/>
                 </a:solidFill>
                 <a:latin typeface="Calibri"/>
               </a:rPr>
-              <a:t>FedRAMP cloud + FIPS crypto — deal-gated</a:t>
-            </a:r>
-          </a:p>
-          <a:p>
-            <a:pPr algn="l">
-              <a:spcAft>
-                <a:spcPts val="500"/>
-              </a:spcAft>
-            </a:pPr>
-            <a:r>
-              <a:rPr sz="1350" b="0">
+              <a:t>•  FedRAMP cloud + FIPS crypto — deal-gated</a:t>
+            </a:r>
+          </a:p>
+          <a:p>
+            <a:pPr algn="l">
+              <a:spcAft>
+                <a:spcPts val="1100"/>
+              </a:spcAft>
+            </a:pPr>
+            <a:r>
+              <a:rPr sz="1500" b="0">
                 <a:solidFill>
                   <a:srgbClr val="1F2430"/>
                 </a:solidFill>
                 <a:latin typeface="Calibri"/>
               </a:rPr>
-              <a:t>Metadata-only keeps most of these out of scope for the data we touch.</a:t>
+              <a:t>•  Metadata-only keeps most of these out of scope for the data we touch.</a:t>
             </a:r>
           </a:p>
         </p:txBody>

</xml_diff>

<commit_message>
docs: rework MHBE deck layouts to fill the page (less blank space) (#248)
Reworked every slide to use the full 16:9 frame: smaller margins, larger type,
bigger images, and restored side-bullets so both halves carry content.
- demo slides: title + 3 talking-point bullets (left) beside a large screenshot.
- architecture: bullets + a bigger data-flow diagram.
- what-it-does: bullets + the Estimate screenshot (6th image).
- security/fit/control-summary: fixed-height cards that fill to the baseline.
- title/moment/ask: headline bands fill the lower third.
Verified: 14 slides, 6 images, notes intact, no shape overflows slide bounds;
PDF regenerated to match (cards min-height) and visually QA'd via pymupdf renders.


Claude-Session: https://claude.ai/code/session_01Mev79UpmJmZS58W3eyakhL

Co-authored-by: Claude <noreply@anthropic.com>
</commit_message>
<xml_diff>
--- a/docs/mhbe-demo-deck.pptx
+++ b/docs/mhbe-demo-deck.pptx
@@ -4688,8 +4688,8 @@
         </p:nvSpPr>
         <p:spPr>
           <a:xfrm>
-            <a:off x="822960" y="640080"/>
-            <a:ext cx="10515600" cy="457200"/>
+            <a:off x="548640" y="457200"/>
+            <a:ext cx="11091672" cy="457200"/>
           </a:xfrm>
           <a:prstGeom prst="rect">
             <a:avLst/>
@@ -4727,8 +4727,8 @@
         </p:nvSpPr>
         <p:spPr>
           <a:xfrm>
-            <a:off x="822960" y="1554480"/>
-            <a:ext cx="10515600" cy="2743200"/>
+            <a:off x="548640" y="1325880"/>
+            <a:ext cx="11091672" cy="2743200"/>
           </a:xfrm>
           <a:prstGeom prst="rect">
             <a:avLst/>
@@ -4747,29 +4747,29 @@
               </a:spcAft>
             </a:pPr>
             <a:r>
-              <a:rPr sz="4000" b="1">
+              <a:rPr sz="4600" b="1">
                 <a:solidFill>
                   <a:srgbClr val="1F2430"/>
                 </a:solidFill>
                 <a:latin typeface="Georgia"/>
               </a:rPr>
-              <a:t>AI spend, mapped to the work that drove it —</a:t>
-            </a:r>
-          </a:p>
-          <a:p>
-            <a:pPr algn="l">
-              <a:spcAft>
-                <a:spcPts val="1400"/>
-              </a:spcAft>
-            </a:pPr>
-            <a:r>
-              <a:rPr sz="4000" b="1">
+              <a:t>AI spend, mapped to the work</a:t>
+            </a:r>
+          </a:p>
+          <a:p>
+            <a:pPr algn="l">
+              <a:spcAft>
+                <a:spcPts val="1600"/>
+              </a:spcAft>
+            </a:pPr>
+            <a:r>
+              <a:rPr sz="4600" b="1">
                 <a:solidFill>
                   <a:srgbClr val="0F6B4F"/>
                 </a:solidFill>
                 <a:latin typeface="Georgia"/>
               </a:rPr>
-              <a:t>and held to budget.</a:t>
+              <a:t>that drove it — and held to budget.</a:t>
             </a:r>
           </a:p>
           <a:p>
@@ -4779,7 +4779,7 @@
               </a:spcAft>
             </a:pPr>
             <a:r>
-              <a:rPr sz="2000" b="0">
+              <a:rPr sz="2200" b="0">
                 <a:solidFill>
                   <a:srgbClr val="5C6470"/>
                 </a:solidFill>
@@ -4792,14 +4792,71 @@
       </p:sp>
       <p:sp>
         <p:nvSpPr>
-          <p:cNvPr id="5" name="TextBox 4"/>
+          <p:cNvPr id="5" name="Rectangle 4"/>
+          <p:cNvSpPr/>
+          <p:nvPr/>
+        </p:nvSpPr>
+        <p:spPr>
+          <a:xfrm>
+            <a:off x="548640" y="5074920"/>
+            <a:ext cx="11091672" cy="822960"/>
+          </a:xfrm>
+          <a:prstGeom prst="rect">
+            <a:avLst/>
+          </a:prstGeom>
+          <a:solidFill>
+            <a:srgbClr val="E7F1EC"/>
+          </a:solidFill>
+          <a:ln>
+            <a:noFill/>
+          </a:ln>
+          <a:effectLst/>
+        </p:spPr>
+        <p:style>
+          <a:lnRef idx="1">
+            <a:schemeClr val="accent1"/>
+          </a:lnRef>
+          <a:fillRef idx="3">
+            <a:schemeClr val="accent1"/>
+          </a:fillRef>
+          <a:effectRef idx="2">
+            <a:schemeClr val="accent1"/>
+          </a:effectRef>
+          <a:fontRef idx="minor">
+            <a:schemeClr val="lt1"/>
+          </a:fontRef>
+        </p:style>
+        <p:txBody>
+          <a:bodyPr rtlCol="0" anchor="ctr"/>
+          <a:lstStyle/>
+          <a:p>
+            <a:pPr algn="ctr">
+              <a:spcAft>
+                <a:spcPts val="600"/>
+              </a:spcAft>
+            </a:pPr>
+            <a:r>
+              <a:rPr sz="2400" b="1">
+                <a:solidFill>
+                  <a:srgbClr val="0B513C"/>
+                </a:solidFill>
+                <a:latin typeface="Georgia"/>
+              </a:rPr>
+              <a:t>Attribute  ·  Forecast  ·  Govern</a:t>
+            </a:r>
+          </a:p>
+        </p:txBody>
+      </p:sp>
+      <p:sp>
+        <p:nvSpPr>
+          <p:cNvPr id="6" name="TextBox 5"/>
           <p:cNvSpPr txBox="1"/>
           <p:nvPr/>
         </p:nvSpPr>
         <p:spPr>
           <a:xfrm>
-            <a:off x="822960" y="6126480"/>
-            <a:ext cx="10515600" cy="457200"/>
+            <a:off x="548640" y="6263640"/>
+            <a:ext cx="11091672" cy="365760"/>
           </a:xfrm>
           <a:prstGeom prst="rect">
             <a:avLst/>
@@ -4899,8 +4956,8 @@
         </p:nvSpPr>
         <p:spPr>
           <a:xfrm>
-            <a:off x="822960" y="640080"/>
-            <a:ext cx="10515600" cy="457200"/>
+            <a:off x="548640" y="457200"/>
+            <a:ext cx="11091672" cy="457200"/>
           </a:xfrm>
           <a:prstGeom prst="rect">
             <a:avLst/>
@@ -4938,8 +4995,8 @@
         </p:nvSpPr>
         <p:spPr>
           <a:xfrm>
-            <a:off x="822960" y="1188720"/>
-            <a:ext cx="10515600" cy="914400"/>
+            <a:off x="548640" y="1005840"/>
+            <a:ext cx="11091672" cy="731520"/>
           </a:xfrm>
           <a:prstGeom prst="rect">
             <a:avLst/>
@@ -4958,7 +5015,7 @@
               </a:spcAft>
             </a:pPr>
             <a:r>
-              <a:rPr sz="3000" b="1">
+              <a:rPr sz="3200" b="1">
                 <a:solidFill>
                   <a:srgbClr val="1F2430"/>
                 </a:solidFill>
@@ -4977,8 +5034,8 @@
         </p:nvSpPr>
         <p:spPr>
           <a:xfrm>
-            <a:off x="822960" y="2377440"/>
-            <a:ext cx="5212080" cy="2651760"/>
+            <a:off x="548640" y="2103120"/>
+            <a:ext cx="5394960" cy="4069080"/>
           </a:xfrm>
           <a:prstGeom prst="rect">
             <a:avLst/>
@@ -4986,7 +5043,7 @@
           <a:solidFill>
             <a:srgbClr val="FFFFFF"/>
           </a:solidFill>
-          <a:ln w="12700">
+          <a:ln w="15875">
             <a:solidFill>
               <a:srgbClr val="0F6B4F"/>
             </a:solidFill>
@@ -5008,16 +5065,16 @@
           </a:fontRef>
         </p:style>
         <p:txBody>
-          <a:bodyPr rtlCol="0" anchor="t" wrap="square" lIns="228600" rIns="228600" tIns="164592"/>
-          <a:lstStyle/>
-          <a:p>
-            <a:pPr algn="l">
-              <a:spcAft>
-                <a:spcPts val="800"/>
-              </a:spcAft>
-            </a:pPr>
-            <a:r>
-              <a:rPr sz="1200" b="1">
+          <a:bodyPr rtlCol="0" anchor="t" wrap="square" lIns="256032" rIns="256032" tIns="201168"/>
+          <a:lstStyle/>
+          <a:p>
+            <a:pPr algn="l">
+              <a:spcAft>
+                <a:spcPts val="1000"/>
+              </a:spcAft>
+            </a:pPr>
+            <a:r>
+              <a:rPr sz="1300" b="1">
                 <a:solidFill>
                   <a:srgbClr val="5C6470"/>
                 </a:solidFill>
@@ -5029,17 +5086,49 @@
           <a:p>
             <a:pPr algn="l">
               <a:spcAft>
-                <a:spcPts val="500"/>
-              </a:spcAft>
-            </a:pPr>
-            <a:r>
-              <a:rPr sz="1350" b="0">
+                <a:spcPts val="1400"/>
+              </a:spcAft>
+            </a:pPr>
+            <a:r>
+              <a:rPr sz="1600" b="0">
                 <a:solidFill>
                   <a:srgbClr val="1F2430"/>
                 </a:solidFill>
                 <a:latin typeface="Calibri"/>
               </a:rPr>
-              <a:t>As you stand up the 2025 AI strategy, be the cost-attribution + budget-guardrail layer from day one — governance-first, like your program.</a:t>
+              <a:t>•  Be the cost-attribution + budget-guardrail layer as you stand up the 2025 AI strategy.</a:t>
+            </a:r>
+          </a:p>
+          <a:p>
+            <a:pPr algn="l">
+              <a:spcAft>
+                <a:spcPts val="1400"/>
+              </a:spcAft>
+            </a:pPr>
+            <a:r>
+              <a:rPr sz="1600" b="0">
+                <a:solidFill>
+                  <a:srgbClr val="1F2430"/>
+                </a:solidFill>
+                <a:latin typeface="Calibri"/>
+              </a:rPr>
+              <a:t>•  Governance-first — matched to how your program is being built.</a:t>
+            </a:r>
+          </a:p>
+          <a:p>
+            <a:pPr algn="l">
+              <a:spcAft>
+                <a:spcPts val="1400"/>
+              </a:spcAft>
+            </a:pPr>
+            <a:r>
+              <a:rPr sz="1600" b="0">
+                <a:solidFill>
+                  <a:srgbClr val="1F2430"/>
+                </a:solidFill>
+                <a:latin typeface="Calibri"/>
+              </a:rPr>
+              <a:t>•  Day-one value with no instrumentation: read-only connections.</a:t>
             </a:r>
           </a:p>
         </p:txBody>
@@ -5052,8 +5141,8 @@
         </p:nvSpPr>
         <p:spPr>
           <a:xfrm>
-            <a:off x="6309360" y="2377440"/>
-            <a:ext cx="5029200" cy="2651760"/>
+            <a:off x="6245352" y="2103120"/>
+            <a:ext cx="5394960" cy="4069080"/>
           </a:xfrm>
           <a:prstGeom prst="rect">
             <a:avLst/>
@@ -5061,7 +5150,7 @@
           <a:solidFill>
             <a:srgbClr val="FFFFFF"/>
           </a:solidFill>
-          <a:ln w="12700">
+          <a:ln w="15875">
             <a:solidFill>
               <a:srgbClr val="0F6B4F"/>
             </a:solidFill>
@@ -5083,16 +5172,16 @@
           </a:fontRef>
         </p:style>
         <p:txBody>
-          <a:bodyPr rtlCol="0" anchor="t" wrap="square" lIns="228600" rIns="228600" tIns="164592"/>
-          <a:lstStyle/>
-          <a:p>
-            <a:pPr algn="l">
-              <a:spcAft>
-                <a:spcPts val="800"/>
-              </a:spcAft>
-            </a:pPr>
-            <a:r>
-              <a:rPr sz="1200" b="1">
+          <a:bodyPr rtlCol="0" anchor="t" wrap="square" lIns="256032" rIns="256032" tIns="201168"/>
+          <a:lstStyle/>
+          <a:p>
+            <a:pPr algn="l">
+              <a:spcAft>
+                <a:spcPts val="1000"/>
+              </a:spcAft>
+            </a:pPr>
+            <a:r>
+              <a:rPr sz="1300" b="1">
                 <a:solidFill>
                   <a:srgbClr val="5C6470"/>
                 </a:solidFill>
@@ -5104,17 +5193,49 @@
           <a:p>
             <a:pPr algn="l">
               <a:spcAft>
-                <a:spcPts val="500"/>
-              </a:spcAft>
-            </a:pPr>
-            <a:r>
-              <a:rPr sz="1350" b="0">
+                <a:spcPts val="1400"/>
+              </a:spcAft>
+            </a:pPr>
+            <a:r>
+              <a:rPr sz="1600" b="0">
                 <a:solidFill>
                   <a:srgbClr val="1F2430"/>
                 </a:solidFill>
                 <a:latin typeface="Calibri"/>
               </a:rPr>
-              <a:t>As the Deloitte / J29 enhancement work adopts AI coding agents, see AI-assisted delivery cost per project — the earned-value view a public agency needs to justify IT spend.</a:t>
+              <a:t>•  As Deloitte / J29 enhancement work adopts AI coding agents, see cost per project.</a:t>
+            </a:r>
+          </a:p>
+          <a:p>
+            <a:pPr algn="l">
+              <a:spcAft>
+                <a:spcPts val="1400"/>
+              </a:spcAft>
+            </a:pPr>
+            <a:r>
+              <a:rPr sz="1600" b="0">
+                <a:solidFill>
+                  <a:srgbClr val="1F2430"/>
+                </a:solidFill>
+                <a:latin typeface="Calibri"/>
+              </a:rPr>
+              <a:t>•  The earned-value view a public agency needs to justify IT spend.</a:t>
+            </a:r>
+          </a:p>
+          <a:p>
+            <a:pPr algn="l">
+              <a:spcAft>
+                <a:spcPts val="1400"/>
+              </a:spcAft>
+            </a:pPr>
+            <a:r>
+              <a:rPr sz="1600" b="0">
+                <a:solidFill>
+                  <a:srgbClr val="1F2430"/>
+                </a:solidFill>
+                <a:latin typeface="Calibri"/>
+              </a:rPr>
+              <a:t>•  Attributes the $12.7M “MHC enhancements” work to the tickets behind it.</a:t>
             </a:r>
           </a:p>
         </p:txBody>
@@ -5189,8 +5310,8 @@
         </p:nvSpPr>
         <p:spPr>
           <a:xfrm>
-            <a:off x="822960" y="640080"/>
-            <a:ext cx="2011680" cy="502920"/>
+            <a:off x="548640" y="457200"/>
+            <a:ext cx="2103120" cy="502920"/>
           </a:xfrm>
           <a:prstGeom prst="rect">
             <a:avLst/>
@@ -5227,7 +5348,7 @@
               </a:spcAft>
             </a:pPr>
             <a:r>
-              <a:rPr sz="1200" b="1">
+              <a:rPr sz="1250" b="1">
                 <a:solidFill>
                   <a:srgbClr val="0B513C"/>
                 </a:solidFill>
@@ -5246,8 +5367,8 @@
         </p:nvSpPr>
         <p:spPr>
           <a:xfrm>
-            <a:off x="822960" y="1371600"/>
-            <a:ext cx="10515600" cy="914400"/>
+            <a:off x="548640" y="1234440"/>
+            <a:ext cx="11091672" cy="822960"/>
           </a:xfrm>
           <a:prstGeom prst="rect">
             <a:avLst/>
@@ -5266,7 +5387,7 @@
               </a:spcAft>
             </a:pPr>
             <a:r>
-              <a:rPr sz="3000" b="1">
+              <a:rPr sz="3200" b="1">
                 <a:solidFill>
                   <a:srgbClr val="1F2430"/>
                 </a:solidFill>
@@ -5285,8 +5406,8 @@
         </p:nvSpPr>
         <p:spPr>
           <a:xfrm>
-            <a:off x="822960" y="2560320"/>
-            <a:ext cx="10515600" cy="2743200"/>
+            <a:off x="548640" y="2514600"/>
+            <a:ext cx="11091672" cy="3108960"/>
           </a:xfrm>
           <a:prstGeom prst="rect">
             <a:avLst/>
@@ -5301,11 +5422,11 @@
           <a:p>
             <a:pPr algn="l">
               <a:spcAft>
-                <a:spcPts val="1200"/>
-              </a:spcAft>
-            </a:pPr>
-            <a:r>
-              <a:rPr sz="1800" b="0">
+                <a:spcPts val="2200"/>
+              </a:spcAft>
+            </a:pPr>
+            <a:r>
+              <a:rPr sz="2000" b="0">
                 <a:solidFill>
                   <a:srgbClr val="1F2430"/>
                 </a:solidFill>
@@ -5317,11 +5438,11 @@
           <a:p>
             <a:pPr algn="l">
               <a:spcAft>
-                <a:spcPts val="1200"/>
-              </a:spcAft>
-            </a:pPr>
-            <a:r>
-              <a:rPr sz="1800" b="0">
+                <a:spcPts val="2200"/>
+              </a:spcAft>
+            </a:pPr>
+            <a:r>
+              <a:rPr sz="2000" b="0">
                 <a:solidFill>
                   <a:srgbClr val="1F2430"/>
                 </a:solidFill>
@@ -5333,11 +5454,11 @@
           <a:p>
             <a:pPr algn="l">
               <a:spcAft>
-                <a:spcPts val="1200"/>
-              </a:spcAft>
-            </a:pPr>
-            <a:r>
-              <a:rPr sz="1800" b="0">
+                <a:spcPts val="2200"/>
+              </a:spcAft>
+            </a:pPr>
+            <a:r>
+              <a:rPr sz="2000" b="0">
                 <a:solidFill>
                   <a:srgbClr val="1F2430"/>
                 </a:solidFill>
@@ -5346,20 +5467,61 @@
               <a:t>•  You walk away with a real number: attribution coverage + a measured forecast accuracy on your work.</a:t>
             </a:r>
           </a:p>
-          <a:p>
-            <a:pPr algn="l">
-              <a:spcAft>
-                <a:spcPts val="0"/>
-              </a:spcAft>
-            </a:pPr>
-            <a:r>
-              <a:rPr sz="1500" b="0">
-                <a:solidFill>
-                  <a:srgbClr val="5C6470"/>
+        </p:txBody>
+      </p:sp>
+      <p:sp>
+        <p:nvSpPr>
+          <p:cNvPr id="6" name="Rectangle 5"/>
+          <p:cNvSpPr/>
+          <p:nvPr/>
+        </p:nvSpPr>
+        <p:spPr>
+          <a:xfrm>
+            <a:off x="548640" y="5440680"/>
+            <a:ext cx="11091672" cy="777240"/>
+          </a:xfrm>
+          <a:prstGeom prst="rect">
+            <a:avLst/>
+          </a:prstGeom>
+          <a:solidFill>
+            <a:srgbClr val="E7F1EC"/>
+          </a:solidFill>
+          <a:ln>
+            <a:noFill/>
+          </a:ln>
+          <a:effectLst/>
+        </p:spPr>
+        <p:style>
+          <a:lnRef idx="1">
+            <a:schemeClr val="accent1"/>
+          </a:lnRef>
+          <a:fillRef idx="3">
+            <a:schemeClr val="accent1"/>
+          </a:fillRef>
+          <a:effectRef idx="2">
+            <a:schemeClr val="accent1"/>
+          </a:effectRef>
+          <a:fontRef idx="minor">
+            <a:schemeClr val="lt1"/>
+          </a:fontRef>
+        </p:style>
+        <p:txBody>
+          <a:bodyPr rtlCol="0" anchor="ctr"/>
+          <a:lstStyle/>
+          <a:p>
+            <a:pPr algn="ctr">
+              <a:spcAft>
+                <a:spcPts val="600"/>
+              </a:spcAft>
+            </a:pPr>
+            <a:r>
+              <a:rPr sz="1600" b="1">
+                <a:solidFill>
+                  <a:srgbClr val="0B513C"/>
                 </a:solidFill>
                 <a:latin typeface="Calibri"/>
               </a:rPr>
-              <a:t>Free during the pilot. We share our SOC 2 timeline and NIST 800-53 control mapping up front.</a:t>
+              <a:t>Free during the pilot · we share our SOC 2 timeline and NIST 800-53 control mapping up front.</a:t>
             </a:r>
           </a:p>
         </p:txBody>
@@ -5434,8 +5596,8 @@
         </p:nvSpPr>
         <p:spPr>
           <a:xfrm>
-            <a:off x="822960" y="640080"/>
-            <a:ext cx="10515600" cy="457200"/>
+            <a:off x="548640" y="457200"/>
+            <a:ext cx="11091672" cy="457200"/>
           </a:xfrm>
           <a:prstGeom prst="rect">
             <a:avLst/>
@@ -5473,8 +5635,8 @@
         </p:nvSpPr>
         <p:spPr>
           <a:xfrm>
-            <a:off x="822960" y="2103120"/>
-            <a:ext cx="10515600" cy="2286000"/>
+            <a:off x="548640" y="1874519"/>
+            <a:ext cx="11091672" cy="1463040"/>
           </a:xfrm>
           <a:prstGeom prst="rect">
             <a:avLst/>
@@ -5489,33 +5651,17 @@
           <a:p>
             <a:pPr algn="l">
               <a:spcAft>
-                <a:spcPts val="1200"/>
-              </a:spcAft>
-            </a:pPr>
-            <a:r>
-              <a:rPr sz="4000" b="1">
+                <a:spcPts val="600"/>
+              </a:spcAft>
+            </a:pPr>
+            <a:r>
+              <a:rPr sz="4600" b="1">
                 <a:solidFill>
                   <a:srgbClr val="FFFFFF"/>
                 </a:solidFill>
                 <a:latin typeface="Georgia"/>
               </a:rPr>
               <a:t>Govern the AI spend before it scales.</a:t>
-            </a:r>
-          </a:p>
-          <a:p>
-            <a:pPr algn="l">
-              <a:spcAft>
-                <a:spcPts val="600"/>
-              </a:spcAft>
-            </a:pPr>
-            <a:r>
-              <a:rPr sz="2000" b="0">
-                <a:solidFill>
-                  <a:srgbClr val="DDF0E7"/>
-                </a:solidFill>
-                <a:latin typeface="Calibri"/>
-              </a:rPr>
-              <a:t>The cheapest time to put AI on a budget is at the start of the curve — which is exactly where Maryland is.</a:t>
             </a:r>
           </a:p>
         </p:txBody>
@@ -5528,8 +5674,47 @@
         </p:nvSpPr>
         <p:spPr>
           <a:xfrm>
-            <a:off x="822960" y="6126480"/>
-            <a:ext cx="10515600" cy="457200"/>
+            <a:off x="548640" y="3611880"/>
+            <a:ext cx="11091672" cy="1463040"/>
+          </a:xfrm>
+          <a:prstGeom prst="rect">
+            <a:avLst/>
+          </a:prstGeom>
+          <a:noFill/>
+        </p:spPr>
+        <p:txBody>
+          <a:bodyPr wrap="square">
+            <a:spAutoFit/>
+          </a:bodyPr>
+          <a:lstStyle/>
+          <a:p>
+            <a:pPr algn="l">
+              <a:spcAft>
+                <a:spcPts val="600"/>
+              </a:spcAft>
+            </a:pPr>
+            <a:r>
+              <a:rPr sz="2200" b="0">
+                <a:solidFill>
+                  <a:srgbClr val="DDF0E7"/>
+                </a:solidFill>
+                <a:latin typeface="Calibri"/>
+              </a:rPr>
+              <a:t>The cheapest time to put AI on a budget is at the start of the curve — which is exactly where Maryland is.</a:t>
+            </a:r>
+          </a:p>
+        </p:txBody>
+      </p:sp>
+      <p:sp>
+        <p:nvSpPr>
+          <p:cNvPr id="6" name="TextBox 5"/>
+          <p:cNvSpPr txBox="1"/>
+          <p:nvPr/>
+        </p:nvSpPr>
+        <p:spPr>
+          <a:xfrm>
+            <a:off x="548640" y="6263640"/>
+            <a:ext cx="11091672" cy="365760"/>
           </a:xfrm>
           <a:prstGeom prst="rect">
             <a:avLst/>
@@ -5629,8 +5814,8 @@
         </p:nvSpPr>
         <p:spPr>
           <a:xfrm>
-            <a:off x="822960" y="640080"/>
-            <a:ext cx="10515600" cy="457200"/>
+            <a:off x="548640" y="457200"/>
+            <a:ext cx="11091672" cy="457200"/>
           </a:xfrm>
           <a:prstGeom prst="rect">
             <a:avLst/>
@@ -5668,8 +5853,8 @@
         </p:nvSpPr>
         <p:spPr>
           <a:xfrm>
-            <a:off x="822960" y="1097280"/>
-            <a:ext cx="10789920" cy="5486400"/>
+            <a:off x="548640" y="1051560"/>
+            <a:ext cx="11091672" cy="5394960"/>
           </a:xfrm>
           <a:prstGeom prst="rect">
             <a:avLst/>
@@ -5684,11 +5869,11 @@
           <a:p>
             <a:pPr algn="l">
               <a:spcAft>
-                <a:spcPts val="200"/>
-              </a:spcAft>
-            </a:pPr>
-            <a:r>
-              <a:rPr sz="1500" b="1">
+                <a:spcPts val="300"/>
+              </a:spcAft>
+            </a:pPr>
+            <a:r>
+              <a:rPr sz="1600" b="1">
                 <a:solidFill>
                   <a:srgbClr val="0F6B4F"/>
                 </a:solidFill>
@@ -5700,11 +5885,11 @@
           <a:p>
             <a:pPr algn="l">
               <a:spcAft>
-                <a:spcPts val="1000"/>
-              </a:spcAft>
-            </a:pPr>
-            <a:r>
-              <a:rPr sz="1350" b="0">
+                <a:spcPts val="1300"/>
+              </a:spcAft>
+            </a:pPr>
+            <a:r>
+              <a:rPr sz="1400" b="0">
                 <a:solidFill>
                   <a:srgbClr val="1F2430"/>
                 </a:solidFill>
@@ -5716,11 +5901,11 @@
           <a:p>
             <a:pPr algn="l">
               <a:spcAft>
-                <a:spcPts val="200"/>
-              </a:spcAft>
-            </a:pPr>
-            <a:r>
-              <a:rPr sz="1500" b="1">
+                <a:spcPts val="300"/>
+              </a:spcAft>
+            </a:pPr>
+            <a:r>
+              <a:rPr sz="1600" b="1">
                 <a:solidFill>
                   <a:srgbClr val="0F6B4F"/>
                 </a:solidFill>
@@ -5732,11 +5917,11 @@
           <a:p>
             <a:pPr algn="l">
               <a:spcAft>
-                <a:spcPts val="1000"/>
-              </a:spcAft>
-            </a:pPr>
-            <a:r>
-              <a:rPr sz="1350" b="0">
+                <a:spcPts val="1300"/>
+              </a:spcAft>
+            </a:pPr>
+            <a:r>
+              <a:rPr sz="1400" b="0">
                 <a:solidFill>
                   <a:srgbClr val="1F2430"/>
                 </a:solidFill>
@@ -5748,11 +5933,11 @@
           <a:p>
             <a:pPr algn="l">
               <a:spcAft>
-                <a:spcPts val="200"/>
-              </a:spcAft>
-            </a:pPr>
-            <a:r>
-              <a:rPr sz="1500" b="1">
+                <a:spcPts val="300"/>
+              </a:spcAft>
+            </a:pPr>
+            <a:r>
+              <a:rPr sz="1600" b="1">
                 <a:solidFill>
                   <a:srgbClr val="0F6B4F"/>
                 </a:solidFill>
@@ -5764,11 +5949,11 @@
           <a:p>
             <a:pPr algn="l">
               <a:spcAft>
-                <a:spcPts val="1000"/>
-              </a:spcAft>
-            </a:pPr>
-            <a:r>
-              <a:rPr sz="1350" b="0">
+                <a:spcPts val="1300"/>
+              </a:spcAft>
+            </a:pPr>
+            <a:r>
+              <a:rPr sz="1400" b="0">
                 <a:solidFill>
                   <a:srgbClr val="1F2430"/>
                 </a:solidFill>
@@ -5780,11 +5965,11 @@
           <a:p>
             <a:pPr algn="l">
               <a:spcAft>
-                <a:spcPts val="200"/>
-              </a:spcAft>
-            </a:pPr>
-            <a:r>
-              <a:rPr sz="1500" b="1">
+                <a:spcPts val="300"/>
+              </a:spcAft>
+            </a:pPr>
+            <a:r>
+              <a:rPr sz="1600" b="1">
                 <a:solidFill>
                   <a:srgbClr val="0F6B4F"/>
                 </a:solidFill>
@@ -5796,11 +5981,11 @@
           <a:p>
             <a:pPr algn="l">
               <a:spcAft>
-                <a:spcPts val="1000"/>
-              </a:spcAft>
-            </a:pPr>
-            <a:r>
-              <a:rPr sz="1350" b="0">
+                <a:spcPts val="1300"/>
+              </a:spcAft>
+            </a:pPr>
+            <a:r>
+              <a:rPr sz="1400" b="0">
                 <a:solidFill>
                   <a:srgbClr val="1F2430"/>
                 </a:solidFill>
@@ -5812,11 +5997,11 @@
           <a:p>
             <a:pPr algn="l">
               <a:spcAft>
-                <a:spcPts val="200"/>
-              </a:spcAft>
-            </a:pPr>
-            <a:r>
-              <a:rPr sz="1500" b="1">
+                <a:spcPts val="300"/>
+              </a:spcAft>
+            </a:pPr>
+            <a:r>
+              <a:rPr sz="1600" b="1">
                 <a:solidFill>
                   <a:srgbClr val="0F6B4F"/>
                 </a:solidFill>
@@ -5828,11 +6013,11 @@
           <a:p>
             <a:pPr algn="l">
               <a:spcAft>
-                <a:spcPts val="1000"/>
-              </a:spcAft>
-            </a:pPr>
-            <a:r>
-              <a:rPr sz="1350" b="0">
+                <a:spcPts val="1300"/>
+              </a:spcAft>
+            </a:pPr>
+            <a:r>
+              <a:rPr sz="1400" b="0">
                 <a:solidFill>
                   <a:srgbClr val="1F2430"/>
                 </a:solidFill>
@@ -5844,11 +6029,11 @@
           <a:p>
             <a:pPr algn="l">
               <a:spcAft>
-                <a:spcPts val="200"/>
-              </a:spcAft>
-            </a:pPr>
-            <a:r>
-              <a:rPr sz="1500" b="1">
+                <a:spcPts val="300"/>
+              </a:spcAft>
+            </a:pPr>
+            <a:r>
+              <a:rPr sz="1600" b="1">
                 <a:solidFill>
                   <a:srgbClr val="0F6B4F"/>
                 </a:solidFill>
@@ -5860,11 +6045,11 @@
           <a:p>
             <a:pPr algn="l">
               <a:spcAft>
-                <a:spcPts val="1000"/>
-              </a:spcAft>
-            </a:pPr>
-            <a:r>
-              <a:rPr sz="1350" b="0">
+                <a:spcPts val="1300"/>
+              </a:spcAft>
+            </a:pPr>
+            <a:r>
+              <a:rPr sz="1400" b="0">
                 <a:solidFill>
                   <a:srgbClr val="1F2430"/>
                 </a:solidFill>
@@ -5945,8 +6130,8 @@
         </p:nvSpPr>
         <p:spPr>
           <a:xfrm>
-            <a:off x="822960" y="640080"/>
-            <a:ext cx="10515600" cy="457200"/>
+            <a:off x="548640" y="457200"/>
+            <a:ext cx="11091672" cy="457200"/>
           </a:xfrm>
           <a:prstGeom prst="rect">
             <a:avLst/>
@@ -5984,8 +6169,8 @@
         </p:nvSpPr>
         <p:spPr>
           <a:xfrm>
-            <a:off x="822960" y="1097280"/>
-            <a:ext cx="10789920" cy="914400"/>
+            <a:off x="548640" y="960120"/>
+            <a:ext cx="11091672" cy="822960"/>
           </a:xfrm>
           <a:prstGeom prst="rect">
             <a:avLst/>
@@ -6004,7 +6189,7 @@
               </a:spcAft>
             </a:pPr>
             <a:r>
-              <a:rPr sz="1800" b="1">
+              <a:rPr sz="1900" b="1">
                 <a:solidFill>
                   <a:srgbClr val="1F2430"/>
                 </a:solidFill>
@@ -6023,8 +6208,8 @@
         </p:nvSpPr>
         <p:spPr>
           <a:xfrm>
-            <a:off x="822960" y="2103120"/>
-            <a:ext cx="5212080" cy="3840480"/>
+            <a:off x="548640" y="1965960"/>
+            <a:ext cx="5394960" cy="4297680"/>
           </a:xfrm>
           <a:prstGeom prst="rect">
             <a:avLst/>
@@ -6032,7 +6217,7 @@
           <a:solidFill>
             <a:srgbClr val="FFFFFF"/>
           </a:solidFill>
-          <a:ln w="12700">
+          <a:ln w="15875">
             <a:solidFill>
               <a:srgbClr val="0F6B4F"/>
             </a:solidFill>
@@ -6054,16 +6239,16 @@
           </a:fontRef>
         </p:style>
         <p:txBody>
-          <a:bodyPr rtlCol="0" anchor="t" wrap="square" lIns="228600" rIns="228600" tIns="164592"/>
-          <a:lstStyle/>
-          <a:p>
-            <a:pPr algn="l">
-              <a:spcAft>
-                <a:spcPts val="800"/>
-              </a:spcAft>
-            </a:pPr>
-            <a:r>
-              <a:rPr sz="1200" b="1">
+          <a:bodyPr rtlCol="0" anchor="t" wrap="square" lIns="256032" rIns="256032" tIns="201168"/>
+          <a:lstStyle/>
+          <a:p>
+            <a:pPr algn="l">
+              <a:spcAft>
+                <a:spcPts val="1000"/>
+              </a:spcAft>
+            </a:pPr>
+            <a:r>
+              <a:rPr sz="1300" b="1">
                 <a:solidFill>
                   <a:srgbClr val="5C6470"/>
                 </a:solidFill>
@@ -6075,7 +6260,7 @@
           <a:p>
             <a:pPr algn="l">
               <a:spcAft>
-                <a:spcPts val="500"/>
+                <a:spcPts val="700"/>
               </a:spcAft>
             </a:pPr>
             <a:r>
@@ -6085,13 +6270,13 @@
                 </a:solidFill>
                 <a:latin typeface="Calibri"/>
               </a:rPr>
-              <a:t>Metadata-only / BYOK / read-only — no PHI/PII/FTI</a:t>
-            </a:r>
-          </a:p>
-          <a:p>
-            <a:pPr algn="l">
-              <a:spcAft>
-                <a:spcPts val="500"/>
+              <a:t>•  Metadata-only / BYOK / read-only — no PHI/PII/FTI</a:t>
+            </a:r>
+          </a:p>
+          <a:p>
+            <a:pPr algn="l">
+              <a:spcAft>
+                <a:spcPts val="700"/>
               </a:spcAft>
             </a:pPr>
             <a:r>
@@ -6101,13 +6286,13 @@
                 </a:solidFill>
                 <a:latin typeface="Calibri"/>
               </a:rPr>
-              <a:t>SSO (OIDC) + SCIM</a:t>
-            </a:r>
-          </a:p>
-          <a:p>
-            <a:pPr algn="l">
-              <a:spcAft>
-                <a:spcPts val="500"/>
+              <a:t>•  SSO (OIDC) + SCIM</a:t>
+            </a:r>
+          </a:p>
+          <a:p>
+            <a:pPr algn="l">
+              <a:spcAft>
+                <a:spcPts val="700"/>
               </a:spcAft>
             </a:pPr>
             <a:r>
@@ -6117,13 +6302,13 @@
                 </a:solidFill>
                 <a:latin typeface="Calibri"/>
               </a:rPr>
-              <a:t>MFA incl. phishing-resistant passkeys (AAL2/3)</a:t>
-            </a:r>
-          </a:p>
-          <a:p>
-            <a:pPr algn="l">
-              <a:spcAft>
-                <a:spcPts val="500"/>
+              <a:t>•  MFA incl. phishing-resistant passkeys (AAL2/3)</a:t>
+            </a:r>
+          </a:p>
+          <a:p>
+            <a:pPr algn="l">
+              <a:spcAft>
+                <a:spcPts val="700"/>
               </a:spcAft>
             </a:pPr>
             <a:r>
@@ -6133,13 +6318,13 @@
                 </a:solidFill>
                 <a:latin typeface="Calibri"/>
               </a:rPr>
-              <a:t>RBAC · audit log + SIEM export (/api/v1/audit)</a:t>
-            </a:r>
-          </a:p>
-          <a:p>
-            <a:pPr algn="l">
-              <a:spcAft>
-                <a:spcPts val="500"/>
+              <a:t>•  RBAC · audit log + SIEM export (/api/v1/audit)</a:t>
+            </a:r>
+          </a:p>
+          <a:p>
+            <a:pPr algn="l">
+              <a:spcAft>
+                <a:spcPts val="700"/>
               </a:spcAft>
             </a:pPr>
             <a:r>
@@ -6149,13 +6334,13 @@
                 </a:solidFill>
                 <a:latin typeface="Calibri"/>
               </a:rPr>
-              <a:t>Session controls: idle/absolute/epoch revocation</a:t>
-            </a:r>
-          </a:p>
-          <a:p>
-            <a:pPr algn="l">
-              <a:spcAft>
-                <a:spcPts val="500"/>
+              <a:t>•  Session controls: idle/absolute/epoch revocation</a:t>
+            </a:r>
+          </a:p>
+          <a:p>
+            <a:pPr algn="l">
+              <a:spcAft>
+                <a:spcPts val="700"/>
               </a:spcAft>
             </a:pPr>
             <a:r>
@@ -6165,13 +6350,13 @@
                 </a:solidFill>
                 <a:latin typeface="Calibri"/>
               </a:rPr>
-              <a:t>Retention + self-serve erasure</a:t>
-            </a:r>
-          </a:p>
-          <a:p>
-            <a:pPr algn="l">
-              <a:spcAft>
-                <a:spcPts val="500"/>
+              <a:t>•  Retention + self-serve erasure</a:t>
+            </a:r>
+          </a:p>
+          <a:p>
+            <a:pPr algn="l">
+              <a:spcAft>
+                <a:spcPts val="700"/>
               </a:spcAft>
             </a:pPr>
             <a:r>
@@ -6181,13 +6366,13 @@
                 </a:solidFill>
                 <a:latin typeface="Calibri"/>
               </a:rPr>
-              <a:t>Encryption at rest + pluggable KMS hook</a:t>
-            </a:r>
-          </a:p>
-          <a:p>
-            <a:pPr algn="l">
-              <a:spcAft>
-                <a:spcPts val="500"/>
+              <a:t>•  Encryption at rest + pluggable KMS hook</a:t>
+            </a:r>
+          </a:p>
+          <a:p>
+            <a:pPr algn="l">
+              <a:spcAft>
+                <a:spcPts val="700"/>
               </a:spcAft>
             </a:pPr>
             <a:r>
@@ -6197,13 +6382,13 @@
                 </a:solidFill>
                 <a:latin typeface="Calibri"/>
               </a:rPr>
-              <a:t>IR plan (MD-SOC 1-hr) + incident webhook</a:t>
-            </a:r>
-          </a:p>
-          <a:p>
-            <a:pPr algn="l">
-              <a:spcAft>
-                <a:spcPts val="500"/>
+              <a:t>•  IR plan (MD-SOC 1-hr) + incident webhook</a:t>
+            </a:r>
+          </a:p>
+          <a:p>
+            <a:pPr algn="l">
+              <a:spcAft>
+                <a:spcPts val="700"/>
               </a:spcAft>
             </a:pPr>
             <a:r>
@@ -6213,7 +6398,7 @@
                 </a:solidFill>
                 <a:latin typeface="Calibri"/>
               </a:rPr>
-              <a:t>WCAG 2.1 AA + automated a11y &amp; security CI scans</a:t>
+              <a:t>•  WCAG 2.1 AA + automated a11y &amp; security CI scans</a:t>
             </a:r>
           </a:p>
         </p:txBody>
@@ -6226,8 +6411,8 @@
         </p:nvSpPr>
         <p:spPr>
           <a:xfrm>
-            <a:off x="6309360" y="2103120"/>
-            <a:ext cx="5029200" cy="3840480"/>
+            <a:off x="6245352" y="1965960"/>
+            <a:ext cx="5394960" cy="4297680"/>
           </a:xfrm>
           <a:prstGeom prst="rect">
             <a:avLst/>
@@ -6235,7 +6420,7 @@
           <a:solidFill>
             <a:srgbClr val="FFFFFF"/>
           </a:solidFill>
-          <a:ln w="12700">
+          <a:ln w="15875">
             <a:solidFill>
               <a:srgbClr val="9A5A18"/>
             </a:solidFill>
@@ -6257,16 +6442,16 @@
           </a:fontRef>
         </p:style>
         <p:txBody>
-          <a:bodyPr rtlCol="0" anchor="t" wrap="square" lIns="228600" rIns="228600" tIns="164592"/>
-          <a:lstStyle/>
-          <a:p>
-            <a:pPr algn="l">
-              <a:spcAft>
-                <a:spcPts val="800"/>
-              </a:spcAft>
-            </a:pPr>
-            <a:r>
-              <a:rPr sz="1200" b="1">
+          <a:bodyPr rtlCol="0" anchor="t" wrap="square" lIns="256032" rIns="256032" tIns="201168"/>
+          <a:lstStyle/>
+          <a:p>
+            <a:pPr algn="l">
+              <a:spcAft>
+                <a:spcPts val="1000"/>
+              </a:spcAft>
+            </a:pPr>
+            <a:r>
+              <a:rPr sz="1300" b="1">
                 <a:solidFill>
                   <a:srgbClr val="5C6470"/>
                 </a:solidFill>
@@ -6278,7 +6463,7 @@
           <a:p>
             <a:pPr algn="l">
               <a:spcAft>
-                <a:spcPts val="500"/>
+                <a:spcPts val="700"/>
               </a:spcAft>
             </a:pPr>
             <a:r>
@@ -6288,13 +6473,13 @@
                 </a:solidFill>
                 <a:latin typeface="Calibri"/>
               </a:rPr>
-              <a:t>SOC 2 Type II — in progress (highest leverage)</a:t>
-            </a:r>
-          </a:p>
-          <a:p>
-            <a:pPr algn="l">
-              <a:spcAft>
-                <a:spcPts val="500"/>
+              <a:t>•  SOC 2 Type II — in progress (highest leverage)</a:t>
+            </a:r>
+          </a:p>
+          <a:p>
+            <a:pPr algn="l">
+              <a:spcAft>
+                <a:spcPts val="700"/>
               </a:spcAft>
             </a:pPr>
             <a:r>
@@ -6304,13 +6489,13 @@
                 </a:solidFill>
                 <a:latin typeface="Calibri"/>
               </a:rPr>
-              <a:t>Annual third-party penetration test</a:t>
-            </a:r>
-          </a:p>
-          <a:p>
-            <a:pPr algn="l">
-              <a:spcAft>
-                <a:spcPts val="500"/>
+              <a:t>•  Annual third-party penetration test</a:t>
+            </a:r>
+          </a:p>
+          <a:p>
+            <a:pPr algn="l">
+              <a:spcAft>
+                <a:spcPts val="700"/>
               </a:spcAft>
             </a:pPr>
             <a:r>
@@ -6320,13 +6505,13 @@
                 </a:solidFill>
                 <a:latin typeface="Calibri"/>
               </a:rPr>
-              <a:t>Monthly vulnerability-scan program + patch SLA</a:t>
-            </a:r>
-          </a:p>
-          <a:p>
-            <a:pPr algn="l">
-              <a:spcAft>
-                <a:spcPts val="500"/>
+              <a:t>•  Monthly vulnerability-scan program + patch SLA</a:t>
+            </a:r>
+          </a:p>
+          <a:p>
+            <a:pPr algn="l">
+              <a:spcAft>
+                <a:spcPts val="700"/>
               </a:spcAft>
             </a:pPr>
             <a:r>
@@ -6336,13 +6521,13 @@
                 </a:solidFill>
                 <a:latin typeface="Calibri"/>
               </a:rPr>
-              <a:t>StateRAMP / GovRAMP (Ready → Authorized)</a:t>
-            </a:r>
-          </a:p>
-          <a:p>
-            <a:pPr algn="l">
-              <a:spcAft>
-                <a:spcPts val="500"/>
+              <a:t>•  StateRAMP / GovRAMP (Ready → Authorized)</a:t>
+            </a:r>
+          </a:p>
+          <a:p>
+            <a:pPr algn="l">
+              <a:spcAft>
+                <a:spcPts val="700"/>
               </a:spcAft>
             </a:pPr>
             <a:r>
@@ -6352,13 +6537,13 @@
                 </a:solidFill>
                 <a:latin typeface="Calibri"/>
               </a:rPr>
-              <a:t>FedRAMP-authorized cloud (AWS GovCloud / Azure Gov)</a:t>
-            </a:r>
-          </a:p>
-          <a:p>
-            <a:pPr algn="l">
-              <a:spcAft>
-                <a:spcPts val="500"/>
+              <a:t>•  FedRAMP-authorized cloud (AWS GovCloud / Azure Gov)</a:t>
+            </a:r>
+          </a:p>
+          <a:p>
+            <a:pPr algn="l">
+              <a:spcAft>
+                <a:spcPts val="700"/>
               </a:spcAft>
             </a:pPr>
             <a:r>
@@ -6368,13 +6553,13 @@
                 </a:solidFill>
                 <a:latin typeface="Calibri"/>
               </a:rPr>
-              <a:t>FIPS 140-validated crypto (IRS 1075)</a:t>
-            </a:r>
-          </a:p>
-          <a:p>
-            <a:pPr algn="l">
-              <a:spcAft>
-                <a:spcPts val="500"/>
+              <a:t>•  FIPS 140-validated crypto (IRS 1075)</a:t>
+            </a:r>
+          </a:p>
+          <a:p>
+            <a:pPr algn="l">
+              <a:spcAft>
+                <a:spcPts val="700"/>
               </a:spcAft>
             </a:pPr>
             <a:r>
@@ -6384,7 +6569,7 @@
                 </a:solidFill>
                 <a:latin typeface="Calibri"/>
               </a:rPr>
-              <a:t>3PAO assessment vs NIST 800-53 Rev 5</a:t>
+              <a:t>•  3PAO assessment vs NIST 800-53 Rev 5</a:t>
             </a:r>
           </a:p>
         </p:txBody>
@@ -6459,8 +6644,8 @@
         </p:nvSpPr>
         <p:spPr>
           <a:xfrm>
-            <a:off x="822960" y="640080"/>
-            <a:ext cx="10515600" cy="457200"/>
+            <a:off x="548640" y="457200"/>
+            <a:ext cx="11091672" cy="457200"/>
           </a:xfrm>
           <a:prstGeom prst="rect">
             <a:avLst/>
@@ -6498,8 +6683,8 @@
         </p:nvSpPr>
         <p:spPr>
           <a:xfrm>
-            <a:off x="822960" y="1371600"/>
-            <a:ext cx="10515600" cy="3657600"/>
+            <a:off x="548640" y="1234440"/>
+            <a:ext cx="11091672" cy="1463040"/>
           </a:xfrm>
           <a:prstGeom prst="rect">
             <a:avLst/>
@@ -6514,11 +6699,11 @@
           <a:p>
             <a:pPr algn="l">
               <a:spcAft>
-                <a:spcPts val="1800"/>
-              </a:spcAft>
-            </a:pPr>
-            <a:r>
-              <a:rPr sz="3200" b="1">
+                <a:spcPts val="600"/>
+              </a:spcAft>
+            </a:pPr>
+            <a:r>
+              <a:rPr sz="3800" b="1">
                 <a:solidFill>
                   <a:srgbClr val="1F2430"/>
                 </a:solidFill>
@@ -6527,14 +6712,37 @@
               <a:t>Maryland is operationalizing its 2025 AI Enablement Strategy.</a:t>
             </a:r>
           </a:p>
-          <a:p>
-            <a:pPr algn="l">
-              <a:spcAft>
-                <a:spcPts val="800"/>
-              </a:spcAft>
-            </a:pPr>
-            <a:r>
-              <a:rPr sz="2000" b="0">
+        </p:txBody>
+      </p:sp>
+      <p:sp>
+        <p:nvSpPr>
+          <p:cNvPr id="5" name="TextBox 4"/>
+          <p:cNvSpPr txBox="1"/>
+          <p:nvPr/>
+        </p:nvSpPr>
+        <p:spPr>
+          <a:xfrm>
+            <a:off x="548640" y="2971800"/>
+            <a:ext cx="11091672" cy="548640"/>
+          </a:xfrm>
+          <a:prstGeom prst="rect">
+            <a:avLst/>
+          </a:prstGeom>
+          <a:noFill/>
+        </p:spPr>
+        <p:txBody>
+          <a:bodyPr wrap="square">
+            <a:spAutoFit/>
+          </a:bodyPr>
+          <a:lstStyle/>
+          <a:p>
+            <a:pPr algn="l">
+              <a:spcAft>
+                <a:spcPts val="600"/>
+              </a:spcAft>
+            </a:pPr>
+            <a:r>
+              <a:rPr sz="2200" b="0">
                 <a:solidFill>
                   <a:srgbClr val="5C6470"/>
                 </a:solidFill>
@@ -6543,22 +6751,86 @@
               <a:t>Right after “is it safe?” comes the question every CFO and CIO asks:</a:t>
             </a:r>
           </a:p>
-          <a:p>
-            <a:pPr algn="l">
-              <a:spcAft>
-                <a:spcPts val="2000"/>
-              </a:spcAft>
-            </a:pPr>
-            <a:r>
-              <a:rPr sz="2400" b="1">
-                <a:solidFill>
-                  <a:srgbClr val="0F6B4F"/>
-                </a:solidFill>
-                <a:latin typeface="Calibri"/>
+        </p:txBody>
+      </p:sp>
+      <p:sp>
+        <p:nvSpPr>
+          <p:cNvPr id="6" name="Rectangle 5"/>
+          <p:cNvSpPr/>
+          <p:nvPr/>
+        </p:nvSpPr>
+        <p:spPr>
+          <a:xfrm>
+            <a:off x="548640" y="3703320"/>
+            <a:ext cx="11091672" cy="1143000"/>
+          </a:xfrm>
+          <a:prstGeom prst="rect">
+            <a:avLst/>
+          </a:prstGeom>
+          <a:solidFill>
+            <a:srgbClr val="E7F1EC"/>
+          </a:solidFill>
+          <a:ln>
+            <a:noFill/>
+          </a:ln>
+          <a:effectLst/>
+        </p:spPr>
+        <p:style>
+          <a:lnRef idx="1">
+            <a:schemeClr val="accent1"/>
+          </a:lnRef>
+          <a:fillRef idx="3">
+            <a:schemeClr val="accent1"/>
+          </a:fillRef>
+          <a:effectRef idx="2">
+            <a:schemeClr val="accent1"/>
+          </a:effectRef>
+          <a:fontRef idx="minor">
+            <a:schemeClr val="lt1"/>
+          </a:fontRef>
+        </p:style>
+        <p:txBody>
+          <a:bodyPr rtlCol="0" anchor="ctr"/>
+          <a:lstStyle/>
+          <a:p>
+            <a:pPr algn="ctr">
+              <a:spcAft>
+                <a:spcPts val="600"/>
+              </a:spcAft>
+            </a:pPr>
+            <a:r>
+              <a:rPr sz="3000" b="1">
+                <a:solidFill>
+                  <a:srgbClr val="0B513C"/>
+                </a:solidFill>
+                <a:latin typeface="Georgia"/>
               </a:rPr>
               <a:t>“What is the AI costing us — per program — and is it on budget?”</a:t>
             </a:r>
           </a:p>
+        </p:txBody>
+      </p:sp>
+      <p:sp>
+        <p:nvSpPr>
+          <p:cNvPr id="7" name="TextBox 6"/>
+          <p:cNvSpPr txBox="1"/>
+          <p:nvPr/>
+        </p:nvSpPr>
+        <p:spPr>
+          <a:xfrm>
+            <a:off x="548640" y="5212080"/>
+            <a:ext cx="11091672" cy="1097280"/>
+          </a:xfrm>
+          <a:prstGeom prst="rect">
+            <a:avLst/>
+          </a:prstGeom>
+          <a:noFill/>
+        </p:spPr>
+        <p:txBody>
+          <a:bodyPr wrap="square">
+            <a:spAutoFit/>
+          </a:bodyPr>
+          <a:lstStyle/>
           <a:p>
             <a:pPr algn="l">
               <a:spcAft>
@@ -6566,7 +6838,7 @@
               </a:spcAft>
             </a:pPr>
             <a:r>
-              <a:rPr sz="1700" b="0">
+              <a:rPr sz="1900" b="0">
                 <a:solidFill>
                   <a:srgbClr val="5C6470"/>
                 </a:solidFill>
@@ -6647,8 +6919,8 @@
         </p:nvSpPr>
         <p:spPr>
           <a:xfrm>
-            <a:off x="822960" y="640080"/>
-            <a:ext cx="10515600" cy="457200"/>
+            <a:off x="548640" y="457200"/>
+            <a:ext cx="11091672" cy="457200"/>
           </a:xfrm>
           <a:prstGeom prst="rect">
             <a:avLst/>
@@ -6686,8 +6958,8 @@
         </p:nvSpPr>
         <p:spPr>
           <a:xfrm>
-            <a:off x="822960" y="1280160"/>
-            <a:ext cx="10515600" cy="914400"/>
+            <a:off x="548640" y="960120"/>
+            <a:ext cx="11091672" cy="731520"/>
           </a:xfrm>
           <a:prstGeom prst="rect">
             <a:avLst/>
@@ -6706,7 +6978,7 @@
               </a:spcAft>
             </a:pPr>
             <a:r>
-              <a:rPr sz="3000" b="1">
+              <a:rPr sz="3200" b="1">
                 <a:solidFill>
                   <a:srgbClr val="1F2430"/>
                 </a:solidFill>
@@ -6725,8 +6997,8 @@
         </p:nvSpPr>
         <p:spPr>
           <a:xfrm>
-            <a:off x="822960" y="2468880"/>
-            <a:ext cx="6035040" cy="3657600"/>
+            <a:off x="548640" y="2148840"/>
+            <a:ext cx="4297680" cy="4023360"/>
           </a:xfrm>
           <a:prstGeom prst="rect">
             <a:avLst/>
@@ -6741,11 +7013,11 @@
           <a:p>
             <a:pPr algn="l">
               <a:spcAft>
-                <a:spcPts val="1200"/>
-              </a:spcAft>
-            </a:pPr>
-            <a:r>
-              <a:rPr sz="1800" b="0">
+                <a:spcPts val="2200"/>
+              </a:spcAft>
+            </a:pPr>
+            <a:r>
+              <a:rPr sz="1900" b="0">
                 <a:solidFill>
                   <a:srgbClr val="1F2430"/>
                 </a:solidFill>
@@ -6757,11 +7029,11 @@
           <a:p>
             <a:pPr algn="l">
               <a:spcAft>
-                <a:spcPts val="1200"/>
-              </a:spcAft>
-            </a:pPr>
-            <a:r>
-              <a:rPr sz="1800" b="0">
+                <a:spcPts val="2200"/>
+              </a:spcAft>
+            </a:pPr>
+            <a:r>
+              <a:rPr sz="1900" b="0">
                 <a:solidFill>
                   <a:srgbClr val="1F2430"/>
                 </a:solidFill>
@@ -6773,11 +7045,11 @@
           <a:p>
             <a:pPr algn="l">
               <a:spcAft>
-                <a:spcPts val="1200"/>
-              </a:spcAft>
-            </a:pPr>
-            <a:r>
-              <a:rPr sz="1800" b="0">
+                <a:spcPts val="2200"/>
+              </a:spcAft>
+            </a:pPr>
+            <a:r>
+              <a:rPr sz="1900" b="0">
                 <a:solidFill>
                   <a:srgbClr val="1F2430"/>
                 </a:solidFill>
@@ -6790,95 +7062,72 @@
       </p:sp>
       <p:sp>
         <p:nvSpPr>
-          <p:cNvPr id="6" name="Rectangle 5"/>
-          <p:cNvSpPr/>
+          <p:cNvPr id="6" name="TextBox 5"/>
+          <p:cNvSpPr txBox="1"/>
           <p:nvPr/>
         </p:nvSpPr>
         <p:spPr>
           <a:xfrm>
-            <a:off x="7223760" y="2468880"/>
-            <a:ext cx="4114800" cy="2377440"/>
+            <a:off x="548640" y="5943600"/>
+            <a:ext cx="4297680" cy="548640"/>
           </a:xfrm>
           <a:prstGeom prst="rect">
             <a:avLst/>
           </a:prstGeom>
-          <a:solidFill>
-            <a:srgbClr val="FFFFFF"/>
-          </a:solidFill>
-          <a:ln w="12700">
+          <a:noFill/>
+        </p:spPr>
+        <p:txBody>
+          <a:bodyPr wrap="square">
+            <a:spAutoFit/>
+          </a:bodyPr>
+          <a:lstStyle/>
+          <a:p>
+            <a:pPr algn="l">
+              <a:spcAft>
+                <a:spcPts val="600"/>
+              </a:spcAft>
+            </a:pPr>
+            <a:r>
+              <a:rPr sz="1300" b="0">
+                <a:solidFill>
+                  <a:srgbClr val="5C6470"/>
+                </a:solidFill>
+                <a:latin typeface="Calibri"/>
+              </a:rPr>
+              <a:t>Read-only links — no agents, nothing in the request path.</a:t>
+            </a:r>
+          </a:p>
+        </p:txBody>
+      </p:sp>
+      <p:pic>
+        <p:nvPicPr>
+          <p:cNvPr id="7" name="Picture 6" descr="shot-estimate.png"/>
+          <p:cNvPicPr>
+            <a:picLocks noChangeAspect="1"/>
+          </p:cNvPicPr>
+          <p:nvPr/>
+        </p:nvPicPr>
+        <p:blipFill>
+          <a:blip r:embed="rId2"/>
+          <a:stretch>
+            <a:fillRect/>
+          </a:stretch>
+        </p:blipFill>
+        <p:spPr>
+          <a:xfrm>
+            <a:off x="5074920" y="1554480"/>
+            <a:ext cx="6583680" cy="4198289"/>
+          </a:xfrm>
+          <a:prstGeom prst="rect">
+            <a:avLst/>
+          </a:prstGeom>
+          <a:ln w="15875">
             <a:solidFill>
               <a:srgbClr val="E1DDD2"/>
             </a:solidFill>
           </a:ln>
-          <a:effectLst/>
-        </p:spPr>
-        <p:style>
-          <a:lnRef idx="1">
-            <a:schemeClr val="accent1"/>
-          </a:lnRef>
-          <a:fillRef idx="3">
-            <a:schemeClr val="accent1"/>
-          </a:fillRef>
-          <a:effectRef idx="2">
-            <a:schemeClr val="accent1"/>
-          </a:effectRef>
-          <a:fontRef idx="minor">
-            <a:schemeClr val="lt1"/>
-          </a:fontRef>
-        </p:style>
-        <p:txBody>
-          <a:bodyPr rtlCol="0" anchor="t" wrap="square" lIns="228600" rIns="228600" tIns="164592"/>
-          <a:lstStyle/>
-          <a:p>
-            <a:pPr algn="l">
-              <a:spcAft>
-                <a:spcPts val="800"/>
-              </a:spcAft>
-            </a:pPr>
-            <a:r>
-              <a:rPr sz="1200" b="1">
-                <a:solidFill>
-                  <a:srgbClr val="5C6470"/>
-                </a:solidFill>
-                <a:latin typeface="Calibri"/>
-              </a:rPr>
-              <a:t>HOW IT CONNECTS</a:t>
-            </a:r>
-          </a:p>
-          <a:p>
-            <a:pPr algn="l">
-              <a:spcAft>
-                <a:spcPts val="500"/>
-              </a:spcAft>
-            </a:pPr>
-            <a:r>
-              <a:rPr sz="1350" b="0">
-                <a:solidFill>
-                  <a:srgbClr val="1F2430"/>
-                </a:solidFill>
-                <a:latin typeface="Calibri"/>
-              </a:rPr>
-              <a:t>Read-only links to your work tracker (Jira / GitHub / Linear) and your AI provider's usage &amp; billing API.</a:t>
-            </a:r>
-          </a:p>
-          <a:p>
-            <a:pPr algn="l">
-              <a:spcAft>
-                <a:spcPts val="500"/>
-              </a:spcAft>
-            </a:pPr>
-            <a:r>
-              <a:rPr sz="1350" b="0">
-                <a:solidFill>
-                  <a:srgbClr val="1F2430"/>
-                </a:solidFill>
-                <a:latin typeface="Calibri"/>
-              </a:rPr>
-              <a:t>No agents installed. Nothing in the request path.</a:t>
-            </a:r>
-          </a:p>
-        </p:txBody>
-      </p:sp>
+        </p:spPr>
+      </p:pic>
     </p:spTree>
   </p:cSld>
   <p:clrMapOvr>
@@ -6949,8 +7198,8 @@
         </p:nvSpPr>
         <p:spPr>
           <a:xfrm>
-            <a:off x="822960" y="640080"/>
-            <a:ext cx="4206240" cy="502920"/>
+            <a:off x="548640" y="457200"/>
+            <a:ext cx="4297680" cy="502920"/>
           </a:xfrm>
           <a:prstGeom prst="rect">
             <a:avLst/>
@@ -6987,7 +7236,7 @@
               </a:spcAft>
             </a:pPr>
             <a:r>
-              <a:rPr sz="1200" b="1">
+              <a:rPr sz="1250" b="1">
                 <a:solidFill>
                   <a:srgbClr val="0B513C"/>
                 </a:solidFill>
@@ -7006,8 +7255,8 @@
         </p:nvSpPr>
         <p:spPr>
           <a:xfrm>
-            <a:off x="822960" y="1325880"/>
-            <a:ext cx="10515600" cy="914400"/>
+            <a:off x="548640" y="1188720"/>
+            <a:ext cx="11091672" cy="822960"/>
           </a:xfrm>
           <a:prstGeom prst="rect">
             <a:avLst/>
@@ -7026,7 +7275,7 @@
               </a:spcAft>
             </a:pPr>
             <a:r>
-              <a:rPr sz="3000" b="1">
+              <a:rPr sz="3200" b="1">
                 <a:solidFill>
                   <a:srgbClr val="1F2430"/>
                 </a:solidFill>
@@ -7045,8 +7294,8 @@
         </p:nvSpPr>
         <p:spPr>
           <a:xfrm>
-            <a:off x="822960" y="2468880"/>
-            <a:ext cx="4114800" cy="3657600"/>
+            <a:off x="548640" y="2240280"/>
+            <a:ext cx="3977639" cy="4023360"/>
           </a:xfrm>
           <a:prstGeom prst="rect">
             <a:avLst/>
@@ -7061,11 +7310,11 @@
           <a:p>
             <a:pPr algn="l">
               <a:spcAft>
-                <a:spcPts val="1100"/>
-              </a:spcAft>
-            </a:pPr>
-            <a:r>
-              <a:rPr sz="1500" b="0">
+                <a:spcPts val="1800"/>
+              </a:spcAft>
+            </a:pPr>
+            <a:r>
+              <a:rPr sz="1600" b="0">
                 <a:solidFill>
                   <a:srgbClr val="1F2430"/>
                 </a:solidFill>
@@ -7077,11 +7326,11 @@
           <a:p>
             <a:pPr algn="l">
               <a:spcAft>
-                <a:spcPts val="1100"/>
-              </a:spcAft>
-            </a:pPr>
-            <a:r>
-              <a:rPr sz="1500" b="0">
+                <a:spcPts val="1800"/>
+              </a:spcAft>
+            </a:pPr>
+            <a:r>
+              <a:rPr sz="1600" b="0">
                 <a:solidFill>
                   <a:srgbClr val="1F2430"/>
                 </a:solidFill>
@@ -7093,11 +7342,11 @@
           <a:p>
             <a:pPr algn="l">
               <a:spcAft>
-                <a:spcPts val="1100"/>
-              </a:spcAft>
-            </a:pPr>
-            <a:r>
-              <a:rPr sz="1500" b="0">
+                <a:spcPts val="1800"/>
+              </a:spcAft>
+            </a:pPr>
+            <a:r>
+              <a:rPr sz="1600" b="0">
                 <a:solidFill>
                   <a:srgbClr val="1F2430"/>
                 </a:solidFill>
@@ -7109,11 +7358,11 @@
           <a:p>
             <a:pPr algn="l">
               <a:spcAft>
-                <a:spcPts val="1100"/>
-              </a:spcAft>
-            </a:pPr>
-            <a:r>
-              <a:rPr sz="1500" b="0">
+                <a:spcPts val="1800"/>
+              </a:spcAft>
+            </a:pPr>
+            <a:r>
+              <a:rPr sz="1600" b="0">
                 <a:solidFill>
                   <a:srgbClr val="1F2430"/>
                 </a:solidFill>
@@ -7140,13 +7389,13 @@
         </p:blipFill>
         <p:spPr>
           <a:xfrm>
-            <a:off x="5074920" y="2331720"/>
-            <a:ext cx="6629400" cy="3598817"/>
+            <a:off x="4709160" y="2148840"/>
+            <a:ext cx="7178040" cy="3896650"/>
           </a:xfrm>
           <a:prstGeom prst="rect">
             <a:avLst/>
           </a:prstGeom>
-          <a:ln w="12700">
+          <a:ln w="15875">
             <a:solidFill>
               <a:srgbClr val="E1DDD2"/>
             </a:solidFill>
@@ -7223,8 +7472,8 @@
         </p:nvSpPr>
         <p:spPr>
           <a:xfrm>
-            <a:off x="822960" y="640080"/>
-            <a:ext cx="10515600" cy="457200"/>
+            <a:off x="548640" y="457200"/>
+            <a:ext cx="11091672" cy="457200"/>
           </a:xfrm>
           <a:prstGeom prst="rect">
             <a:avLst/>
@@ -7262,8 +7511,8 @@
         </p:nvSpPr>
         <p:spPr>
           <a:xfrm>
-            <a:off x="822960" y="1920240"/>
-            <a:ext cx="4937760" cy="2743200"/>
+            <a:off x="548640" y="1737360"/>
+            <a:ext cx="4846320" cy="1371600"/>
           </a:xfrm>
           <a:prstGeom prst="rect">
             <a:avLst/>
@@ -7278,11 +7527,11 @@
           <a:p>
             <a:pPr algn="l">
               <a:spcAft>
-                <a:spcPts val="1200"/>
-              </a:spcAft>
-            </a:pPr>
-            <a:r>
-              <a:rPr sz="3400" b="1">
+                <a:spcPts val="600"/>
+              </a:spcAft>
+            </a:pPr>
+            <a:r>
+              <a:rPr sz="3800" b="1">
                 <a:solidFill>
                   <a:srgbClr val="FFFFFF"/>
                 </a:solidFill>
@@ -7291,6 +7540,29 @@
               <a:t>Let's look at the product.</a:t>
             </a:r>
           </a:p>
+        </p:txBody>
+      </p:sp>
+      <p:sp>
+        <p:nvSpPr>
+          <p:cNvPr id="5" name="TextBox 4"/>
+          <p:cNvSpPr txBox="1"/>
+          <p:nvPr/>
+        </p:nvSpPr>
+        <p:spPr>
+          <a:xfrm>
+            <a:off x="548640" y="3200400"/>
+            <a:ext cx="4754880" cy="2286000"/>
+          </a:xfrm>
+          <a:prstGeom prst="rect">
+            <a:avLst/>
+          </a:prstGeom>
+          <a:noFill/>
+        </p:spPr>
+        <p:txBody>
+          <a:bodyPr wrap="square">
+            <a:spAutoFit/>
+          </a:bodyPr>
+          <a:lstStyle/>
           <a:p>
             <a:pPr algn="l">
               <a:spcAft>
@@ -7298,7 +7570,7 @@
               </a:spcAft>
             </a:pPr>
             <a:r>
-              <a:rPr sz="1800" b="0">
+              <a:rPr sz="1900" b="0">
                 <a:solidFill>
                   <a:srgbClr val="DDF0E7"/>
                 </a:solidFill>
@@ -7311,7 +7583,7 @@
       </p:sp>
       <p:pic>
         <p:nvPicPr>
-          <p:cNvPr id="5" name="Picture 4" descr="shot-overview.png"/>
+          <p:cNvPr id="6" name="Picture 5" descr="shot-overview.png"/>
           <p:cNvPicPr>
             <a:picLocks noChangeAspect="1"/>
           </p:cNvPicPr>
@@ -7325,13 +7597,13 @@
         </p:blipFill>
         <p:spPr>
           <a:xfrm>
-            <a:off x="6126480" y="1371600"/>
-            <a:ext cx="5577840" cy="3556883"/>
+            <a:off x="5715000" y="1371600"/>
+            <a:ext cx="6172200" cy="3935896"/>
           </a:xfrm>
           <a:prstGeom prst="rect">
             <a:avLst/>
           </a:prstGeom>
-          <a:ln w="12700">
+          <a:ln w="15875">
             <a:solidFill>
               <a:srgbClr val="FFFFFF"/>
             </a:solidFill>
@@ -7408,8 +7680,8 @@
         </p:nvSpPr>
         <p:spPr>
           <a:xfrm>
-            <a:off x="822960" y="640080"/>
-            <a:ext cx="10515600" cy="457200"/>
+            <a:off x="548640" y="457200"/>
+            <a:ext cx="11091672" cy="457200"/>
           </a:xfrm>
           <a:prstGeom prst="rect">
             <a:avLst/>
@@ -7447,8 +7719,8 @@
         </p:nvSpPr>
         <p:spPr>
           <a:xfrm>
-            <a:off x="822960" y="960120"/>
-            <a:ext cx="10515600" cy="640080"/>
+            <a:off x="548640" y="960120"/>
+            <a:ext cx="3703320" cy="1371600"/>
           </a:xfrm>
           <a:prstGeom prst="rect">
             <a:avLst/>
@@ -7467,7 +7739,7 @@
               </a:spcAft>
             </a:pPr>
             <a:r>
-              <a:rPr sz="2700" b="1">
+              <a:rPr sz="2600" b="1">
                 <a:solidFill>
                   <a:srgbClr val="1F2430"/>
                 </a:solidFill>
@@ -7486,8 +7758,8 @@
         </p:nvSpPr>
         <p:spPr>
           <a:xfrm>
-            <a:off x="822960" y="1481328"/>
-            <a:ext cx="10515600" cy="365760"/>
+            <a:off x="548640" y="2468880"/>
+            <a:ext cx="3657600" cy="3474720"/>
           </a:xfrm>
           <a:prstGeom prst="rect">
             <a:avLst/>
@@ -7502,17 +7774,49 @@
           <a:p>
             <a:pPr algn="l">
               <a:spcAft>
-                <a:spcPts val="600"/>
-              </a:spcAft>
-            </a:pPr>
-            <a:r>
-              <a:rPr sz="1400" b="0">
-                <a:solidFill>
-                  <a:srgbClr val="5C6470"/>
+                <a:spcPts val="1600"/>
+              </a:spcAft>
+            </a:pPr>
+            <a:r>
+              <a:rPr sz="1500" b="0">
+                <a:solidFill>
+                  <a:srgbClr val="1F2430"/>
                 </a:solidFill>
                 <a:latin typeface="Calibri"/>
               </a:rPr>
-              <a:t>By team, work type, ticket, and engineer — with ticket coverage shown honestly.</a:t>
+              <a:t>•  By team &amp; cost center, work type, ticket, and engineer.</a:t>
+            </a:r>
+          </a:p>
+          <a:p>
+            <a:pPr algn="l">
+              <a:spcAft>
+                <a:spcPts val="1600"/>
+              </a:spcAft>
+            </a:pPr>
+            <a:r>
+              <a:rPr sz="1500" b="0">
+                <a:solidFill>
+                  <a:srgbClr val="1F2430"/>
+                </a:solidFill>
+                <a:latin typeface="Calibri"/>
+              </a:rPr>
+              <a:t>•  Ticket coverage shown honestly — and how to lift it.</a:t>
+            </a:r>
+          </a:p>
+          <a:p>
+            <a:pPr algn="l">
+              <a:spcAft>
+                <a:spcPts val="1600"/>
+              </a:spcAft>
+            </a:pPr>
+            <a:r>
+              <a:rPr sz="1500" b="0">
+                <a:solidFill>
+                  <a:srgbClr val="1F2430"/>
+                </a:solidFill>
+                <a:latin typeface="Calibri"/>
+              </a:rPr>
+              <a:t>•  FOCUS-aligned CSV export for finance.</a:t>
             </a:r>
           </a:p>
         </p:txBody>
@@ -7533,13 +7837,13 @@
         </p:blipFill>
         <p:spPr>
           <a:xfrm>
-            <a:off x="2350008" y="1874519"/>
-            <a:ext cx="7498079" cy="4781384"/>
+            <a:off x="4343400" y="960120"/>
+            <a:ext cx="7589520" cy="4839694"/>
           </a:xfrm>
           <a:prstGeom prst="rect">
             <a:avLst/>
           </a:prstGeom>
-          <a:ln w="12700">
+          <a:ln w="15875">
             <a:solidFill>
               <a:srgbClr val="E1DDD2"/>
             </a:solidFill>
@@ -7616,8 +7920,8 @@
         </p:nvSpPr>
         <p:spPr>
           <a:xfrm>
-            <a:off x="822960" y="640080"/>
-            <a:ext cx="10515600" cy="457200"/>
+            <a:off x="548640" y="457200"/>
+            <a:ext cx="11091672" cy="457200"/>
           </a:xfrm>
           <a:prstGeom prst="rect">
             <a:avLst/>
@@ -7655,8 +7959,8 @@
         </p:nvSpPr>
         <p:spPr>
           <a:xfrm>
-            <a:off x="822960" y="960120"/>
-            <a:ext cx="10515600" cy="640080"/>
+            <a:off x="548640" y="960120"/>
+            <a:ext cx="3703320" cy="1371600"/>
           </a:xfrm>
           <a:prstGeom prst="rect">
             <a:avLst/>
@@ -7675,7 +7979,7 @@
               </a:spcAft>
             </a:pPr>
             <a:r>
-              <a:rPr sz="2700" b="1">
+              <a:rPr sz="2600" b="1">
                 <a:solidFill>
                   <a:srgbClr val="1F2430"/>
                 </a:solidFill>
@@ -7694,8 +7998,8 @@
         </p:nvSpPr>
         <p:spPr>
           <a:xfrm>
-            <a:off x="822960" y="1481328"/>
-            <a:ext cx="10515600" cy="365760"/>
+            <a:off x="548640" y="2468880"/>
+            <a:ext cx="3657600" cy="3474720"/>
           </a:xfrm>
           <a:prstGeom prst="rect">
             <a:avLst/>
@@ -7710,17 +8014,49 @@
           <a:p>
             <a:pPr algn="l">
               <a:spcAft>
-                <a:spcPts val="600"/>
-              </a:spcAft>
-            </a:pPr>
-            <a:r>
-              <a:rPr sz="1400" b="0">
-                <a:solidFill>
-                  <a:srgbClr val="5C6470"/>
+                <a:spcPts val="1600"/>
+              </a:spcAft>
+            </a:pPr>
+            <a:r>
+              <a:rPr sz="1500" b="0">
+                <a:solidFill>
+                  <a:srgbClr val="1F2430"/>
                 </a:solidFill>
                 <a:latin typeface="Calibri"/>
               </a:rPr>
-              <a:t>Back-tested on your own closed tickets, leave-one-out — the measured error on your data.</a:t>
+              <a:t>•  Back-tested on your own closed tickets (leave-one-out).</a:t>
+            </a:r>
+          </a:p>
+          <a:p>
+            <a:pPr algn="l">
+              <a:spcAft>
+                <a:spcPts val="1600"/>
+              </a:spcAft>
+            </a:pPr>
+            <a:r>
+              <a:rPr sz="1500" b="0">
+                <a:solidFill>
+                  <a:srgbClr val="1F2430"/>
+                </a:solidFill>
+                <a:latin typeface="Calibri"/>
+              </a:rPr>
+              <a:t>•  Median error, within-P90, and sample size — never hidden.</a:t>
+            </a:r>
+          </a:p>
+          <a:p>
+            <a:pPr algn="l">
+              <a:spcAft>
+                <a:spcPts val="1600"/>
+              </a:spcAft>
+            </a:pPr>
+            <a:r>
+              <a:rPr sz="1500" b="0">
+                <a:solidFill>
+                  <a:srgbClr val="1F2430"/>
+                </a:solidFill>
+                <a:latin typeface="Calibri"/>
+              </a:rPr>
+              <a:t>•  Per-work-type accuracy with over/under bias.</a:t>
             </a:r>
           </a:p>
         </p:txBody>
@@ -7741,13 +8077,13 @@
         </p:blipFill>
         <p:spPr>
           <a:xfrm>
-            <a:off x="2350008" y="1874519"/>
-            <a:ext cx="7498079" cy="4781384"/>
+            <a:off x="4343400" y="960120"/>
+            <a:ext cx="7589520" cy="4839694"/>
           </a:xfrm>
           <a:prstGeom prst="rect">
             <a:avLst/>
           </a:prstGeom>
-          <a:ln w="12700">
+          <a:ln w="15875">
             <a:solidFill>
               <a:srgbClr val="E1DDD2"/>
             </a:solidFill>
@@ -7824,8 +8160,8 @@
         </p:nvSpPr>
         <p:spPr>
           <a:xfrm>
-            <a:off x="822960" y="640080"/>
-            <a:ext cx="10515600" cy="457200"/>
+            <a:off x="548640" y="457200"/>
+            <a:ext cx="11091672" cy="457200"/>
           </a:xfrm>
           <a:prstGeom prst="rect">
             <a:avLst/>
@@ -7863,8 +8199,8 @@
         </p:nvSpPr>
         <p:spPr>
           <a:xfrm>
-            <a:off x="822960" y="960120"/>
-            <a:ext cx="10515600" cy="640080"/>
+            <a:off x="548640" y="960120"/>
+            <a:ext cx="3703320" cy="1371600"/>
           </a:xfrm>
           <a:prstGeom prst="rect">
             <a:avLst/>
@@ -7883,7 +8219,7 @@
               </a:spcAft>
             </a:pPr>
             <a:r>
-              <a:rPr sz="2700" b="1">
+              <a:rPr sz="2600" b="1">
                 <a:solidFill>
                   <a:srgbClr val="1F2430"/>
                 </a:solidFill>
@@ -7902,8 +8238,8 @@
         </p:nvSpPr>
         <p:spPr>
           <a:xfrm>
-            <a:off x="822960" y="1481328"/>
-            <a:ext cx="10515600" cy="365760"/>
+            <a:off x="548640" y="2468880"/>
+            <a:ext cx="3657600" cy="3474720"/>
           </a:xfrm>
           <a:prstGeom prst="rect">
             <a:avLst/>
@@ -7918,17 +8254,49 @@
           <a:p>
             <a:pPr algn="l">
               <a:spcAft>
-                <a:spcPts val="600"/>
-              </a:spcAft>
-            </a:pPr>
-            <a:r>
-              <a:rPr sz="1400" b="0">
-                <a:solidFill>
-                  <a:srgbClr val="5C6470"/>
+                <a:spcPts val="1600"/>
+              </a:spcAft>
+            </a:pPr>
+            <a:r>
+              <a:rPr sz="1500" b="0">
+                <a:solidFill>
+                  <a:srgbClr val="1F2430"/>
                 </a:solidFill>
                 <a:latin typeface="Calibri"/>
               </a:rPr>
-              <a:t>Program budgets, projected breach dates, and an on-/off-track earned-value rating.</a:t>
+              <a:t>•  Program budgets across teams, projects, and work types.</a:t>
+            </a:r>
+          </a:p>
+          <a:p>
+            <a:pPr algn="l">
+              <a:spcAft>
+                <a:spcPts val="1600"/>
+              </a:spcAft>
+            </a:pPr>
+            <a:r>
+              <a:rPr sz="1500" b="0">
+                <a:solidFill>
+                  <a:srgbClr val="1F2430"/>
+                </a:solidFill>
+                <a:latin typeface="Calibri"/>
+              </a:rPr>
+              <a:t>•  Real-time pacing → the projected breach date.</a:t>
+            </a:r>
+          </a:p>
+          <a:p>
+            <a:pPr algn="l">
+              <a:spcAft>
+                <a:spcPts val="1600"/>
+              </a:spcAft>
+            </a:pPr>
+            <a:r>
+              <a:rPr sz="1500" b="0">
+                <a:solidFill>
+                  <a:srgbClr val="1F2430"/>
+                </a:solidFill>
+                <a:latin typeface="Calibri"/>
+              </a:rPr>
+              <a:t>•  On-/off-track earned-value rating; alerts to your SIEM.</a:t>
             </a:r>
           </a:p>
         </p:txBody>
@@ -7949,13 +8317,13 @@
         </p:blipFill>
         <p:spPr>
           <a:xfrm>
-            <a:off x="2350008" y="1874519"/>
-            <a:ext cx="7498079" cy="4781384"/>
+            <a:off x="4343400" y="960120"/>
+            <a:ext cx="7589520" cy="4839694"/>
           </a:xfrm>
           <a:prstGeom prst="rect">
             <a:avLst/>
           </a:prstGeom>
-          <a:ln w="12700">
+          <a:ln w="15875">
             <a:solidFill>
               <a:srgbClr val="E1DDD2"/>
             </a:solidFill>
@@ -8032,8 +8400,8 @@
         </p:nvSpPr>
         <p:spPr>
           <a:xfrm>
-            <a:off x="822960" y="640080"/>
-            <a:ext cx="10515600" cy="457200"/>
+            <a:off x="548640" y="457200"/>
+            <a:ext cx="11091672" cy="457200"/>
           </a:xfrm>
           <a:prstGeom prst="rect">
             <a:avLst/>
@@ -8071,8 +8439,8 @@
         </p:nvSpPr>
         <p:spPr>
           <a:xfrm>
-            <a:off x="822960" y="1188720"/>
-            <a:ext cx="10515600" cy="914400"/>
+            <a:off x="548640" y="1005840"/>
+            <a:ext cx="11091672" cy="731520"/>
           </a:xfrm>
           <a:prstGeom prst="rect">
             <a:avLst/>
@@ -8091,7 +8459,7 @@
               </a:spcAft>
             </a:pPr>
             <a:r>
-              <a:rPr sz="3000" b="1">
+              <a:rPr sz="3200" b="1">
                 <a:solidFill>
                   <a:srgbClr val="1F2430"/>
                 </a:solidFill>
@@ -8110,8 +8478,8 @@
         </p:nvSpPr>
         <p:spPr>
           <a:xfrm>
-            <a:off x="822960" y="2286000"/>
-            <a:ext cx="5212080" cy="3291840"/>
+            <a:off x="548640" y="2103120"/>
+            <a:ext cx="5394960" cy="4069080"/>
           </a:xfrm>
           <a:prstGeom prst="rect">
             <a:avLst/>
@@ -8119,7 +8487,7 @@
           <a:solidFill>
             <a:srgbClr val="FFFFFF"/>
           </a:solidFill>
-          <a:ln w="12700">
+          <a:ln w="15875">
             <a:solidFill>
               <a:srgbClr val="0F6B4F"/>
             </a:solidFill>
@@ -8141,16 +8509,16 @@
           </a:fontRef>
         </p:style>
         <p:txBody>
-          <a:bodyPr rtlCol="0" anchor="t" wrap="square" lIns="228600" rIns="228600" tIns="164592"/>
-          <a:lstStyle/>
-          <a:p>
-            <a:pPr algn="l">
-              <a:spcAft>
-                <a:spcPts val="800"/>
-              </a:spcAft>
-            </a:pPr>
-            <a:r>
-              <a:rPr sz="1200" b="1">
+          <a:bodyPr rtlCol="0" anchor="t" wrap="square" lIns="256032" rIns="256032" tIns="201168"/>
+          <a:lstStyle/>
+          <a:p>
+            <a:pPr algn="l">
+              <a:spcAft>
+                <a:spcPts val="1000"/>
+              </a:spcAft>
+            </a:pPr>
+            <a:r>
+              <a:rPr sz="1300" b="1">
                 <a:solidFill>
                   <a:srgbClr val="5C6470"/>
                 </a:solidFill>
@@ -8162,97 +8530,97 @@
           <a:p>
             <a:pPr algn="l">
               <a:spcAft>
-                <a:spcPts val="500"/>
-              </a:spcAft>
-            </a:pPr>
-            <a:r>
-              <a:rPr sz="1350" b="0">
+                <a:spcPts val="1100"/>
+              </a:spcAft>
+            </a:pPr>
+            <a:r>
+              <a:rPr sz="1500" b="0">
                 <a:solidFill>
                   <a:srgbClr val="1F2430"/>
                 </a:solidFill>
                 <a:latin typeface="Calibri"/>
               </a:rPr>
-              <a:t>SSO (OIDC) + SCIM provisioning</a:t>
-            </a:r>
-          </a:p>
-          <a:p>
-            <a:pPr algn="l">
-              <a:spcAft>
-                <a:spcPts val="500"/>
-              </a:spcAft>
-            </a:pPr>
-            <a:r>
-              <a:rPr sz="1350" b="0">
+              <a:t>•  SSO (OIDC) + SCIM provisioning</a:t>
+            </a:r>
+          </a:p>
+          <a:p>
+            <a:pPr algn="l">
+              <a:spcAft>
+                <a:spcPts val="1100"/>
+              </a:spcAft>
+            </a:pPr>
+            <a:r>
+              <a:rPr sz="1500" b="0">
                 <a:solidFill>
                   <a:srgbClr val="1F2430"/>
                 </a:solidFill>
                 <a:latin typeface="Calibri"/>
               </a:rPr>
-              <a:t>Phishing-resistant MFA (passkeys)</a:t>
-            </a:r>
-          </a:p>
-          <a:p>
-            <a:pPr algn="l">
-              <a:spcAft>
-                <a:spcPts val="500"/>
-              </a:spcAft>
-            </a:pPr>
-            <a:r>
-              <a:rPr sz="1350" b="0">
+              <a:t>•  Phishing-resistant MFA (passkeys)</a:t>
+            </a:r>
+          </a:p>
+          <a:p>
+            <a:pPr algn="l">
+              <a:spcAft>
+                <a:spcPts val="1100"/>
+              </a:spcAft>
+            </a:pPr>
+            <a:r>
+              <a:rPr sz="1500" b="0">
                 <a:solidFill>
                   <a:srgbClr val="1F2430"/>
                 </a:solidFill>
                 <a:latin typeface="Calibri"/>
               </a:rPr>
-              <a:t>RBAC · audit log → SIEM export</a:t>
-            </a:r>
-          </a:p>
-          <a:p>
-            <a:pPr algn="l">
-              <a:spcAft>
-                <a:spcPts val="500"/>
-              </a:spcAft>
-            </a:pPr>
-            <a:r>
-              <a:rPr sz="1350" b="0">
+              <a:t>•  RBAC · audit log → SIEM export</a:t>
+            </a:r>
+          </a:p>
+          <a:p>
+            <a:pPr algn="l">
+              <a:spcAft>
+                <a:spcPts val="1100"/>
+              </a:spcAft>
+            </a:pPr>
+            <a:r>
+              <a:rPr sz="1500" b="0">
                 <a:solidFill>
                   <a:srgbClr val="1F2430"/>
                 </a:solidFill>
                 <a:latin typeface="Calibri"/>
               </a:rPr>
-              <a:t>Retention + self-serve erasure</a:t>
-            </a:r>
-          </a:p>
-          <a:p>
-            <a:pPr algn="l">
-              <a:spcAft>
-                <a:spcPts val="500"/>
-              </a:spcAft>
-            </a:pPr>
-            <a:r>
-              <a:rPr sz="1350" b="0">
+              <a:t>•  Retention + self-serve erasure</a:t>
+            </a:r>
+          </a:p>
+          <a:p>
+            <a:pPr algn="l">
+              <a:spcAft>
+                <a:spcPts val="1100"/>
+              </a:spcAft>
+            </a:pPr>
+            <a:r>
+              <a:rPr sz="1500" b="0">
                 <a:solidFill>
                   <a:srgbClr val="1F2430"/>
                 </a:solidFill>
                 <a:latin typeface="Calibri"/>
               </a:rPr>
-              <a:t>Encryption at rest + KMS hook</a:t>
-            </a:r>
-          </a:p>
-          <a:p>
-            <a:pPr algn="l">
-              <a:spcAft>
-                <a:spcPts val="500"/>
-              </a:spcAft>
-            </a:pPr>
-            <a:r>
-              <a:rPr sz="1350" b="0">
+              <a:t>•  Encryption at rest + KMS hook</a:t>
+            </a:r>
+          </a:p>
+          <a:p>
+            <a:pPr algn="l">
+              <a:spcAft>
+                <a:spcPts val="1100"/>
+              </a:spcAft>
+            </a:pPr>
+            <a:r>
+              <a:rPr sz="1500" b="0">
                 <a:solidFill>
                   <a:srgbClr val="1F2430"/>
                 </a:solidFill>
                 <a:latin typeface="Calibri"/>
               </a:rPr>
-              <a:t>IR plan · WCAG 2.1 AA · CI security scan</a:t>
+              <a:t>•  IR plan · WCAG 2.1 AA · CI security scan</a:t>
             </a:r>
           </a:p>
         </p:txBody>
@@ -8265,8 +8633,8 @@
         </p:nvSpPr>
         <p:spPr>
           <a:xfrm>
-            <a:off x="6309360" y="2286000"/>
-            <a:ext cx="5029200" cy="3291840"/>
+            <a:off x="6245352" y="2103120"/>
+            <a:ext cx="5394960" cy="4069080"/>
           </a:xfrm>
           <a:prstGeom prst="rect">
             <a:avLst/>
@@ -8274,7 +8642,7 @@
           <a:solidFill>
             <a:srgbClr val="FFFFFF"/>
           </a:solidFill>
-          <a:ln w="12700">
+          <a:ln w="15875">
             <a:solidFill>
               <a:srgbClr val="9A5A18"/>
             </a:solidFill>
@@ -8296,16 +8664,16 @@
           </a:fontRef>
         </p:style>
         <p:txBody>
-          <a:bodyPr rtlCol="0" anchor="t" wrap="square" lIns="228600" rIns="228600" tIns="164592"/>
-          <a:lstStyle/>
-          <a:p>
-            <a:pPr algn="l">
-              <a:spcAft>
-                <a:spcPts val="800"/>
-              </a:spcAft>
-            </a:pPr>
-            <a:r>
-              <a:rPr sz="1200" b="1">
+          <a:bodyPr rtlCol="0" anchor="t" wrap="square" lIns="256032" rIns="256032" tIns="201168"/>
+          <a:lstStyle/>
+          <a:p>
+            <a:pPr algn="l">
+              <a:spcAft>
+                <a:spcPts val="1000"/>
+              </a:spcAft>
+            </a:pPr>
+            <a:r>
+              <a:rPr sz="1300" b="1">
                 <a:solidFill>
                   <a:srgbClr val="5C6470"/>
                 </a:solidFill>
@@ -8317,81 +8685,81 @@
           <a:p>
             <a:pPr algn="l">
               <a:spcAft>
-                <a:spcPts val="500"/>
-              </a:spcAft>
-            </a:pPr>
-            <a:r>
-              <a:rPr sz="1350" b="0">
+                <a:spcPts val="1100"/>
+              </a:spcAft>
+            </a:pPr>
+            <a:r>
+              <a:rPr sz="1500" b="0">
                 <a:solidFill>
                   <a:srgbClr val="1F2430"/>
                 </a:solidFill>
                 <a:latin typeface="Calibri"/>
               </a:rPr>
-              <a:t>SOC 2 Type II — in progress</a:t>
-            </a:r>
-          </a:p>
-          <a:p>
-            <a:pPr algn="l">
-              <a:spcAft>
-                <a:spcPts val="500"/>
-              </a:spcAft>
-            </a:pPr>
-            <a:r>
-              <a:rPr sz="1350" b="0">
+              <a:t>•  SOC 2 Type II — in progress</a:t>
+            </a:r>
+          </a:p>
+          <a:p>
+            <a:pPr algn="l">
+              <a:spcAft>
+                <a:spcPts val="1100"/>
+              </a:spcAft>
+            </a:pPr>
+            <a:r>
+              <a:rPr sz="1500" b="0">
                 <a:solidFill>
                   <a:srgbClr val="1F2430"/>
                 </a:solidFill>
                 <a:latin typeface="Calibri"/>
               </a:rPr>
-              <a:t>Annual pen test — scheduled</a:t>
-            </a:r>
-          </a:p>
-          <a:p>
-            <a:pPr algn="l">
-              <a:spcAft>
-                <a:spcPts val="500"/>
-              </a:spcAft>
-            </a:pPr>
-            <a:r>
-              <a:rPr sz="1350" b="0">
+              <a:t>•  Annual penetration test — scheduled</a:t>
+            </a:r>
+          </a:p>
+          <a:p>
+            <a:pPr algn="l">
+              <a:spcAft>
+                <a:spcPts val="1100"/>
+              </a:spcAft>
+            </a:pPr>
+            <a:r>
+              <a:rPr sz="1500" b="0">
                 <a:solidFill>
                   <a:srgbClr val="1F2430"/>
                 </a:solidFill>
                 <a:latin typeface="Calibri"/>
               </a:rPr>
-              <a:t>StateRAMP / GovRAMP — roadmap</a:t>
-            </a:r>
-          </a:p>
-          <a:p>
-            <a:pPr algn="l">
-              <a:spcAft>
-                <a:spcPts val="500"/>
-              </a:spcAft>
-            </a:pPr>
-            <a:r>
-              <a:rPr sz="1350" b="0">
+              <a:t>•  StateRAMP / GovRAMP — roadmap</a:t>
+            </a:r>
+          </a:p>
+          <a:p>
+            <a:pPr algn="l">
+              <a:spcAft>
+                <a:spcPts val="1100"/>
+              </a:spcAft>
+            </a:pPr>
+            <a:r>
+              <a:rPr sz="1500" b="0">
                 <a:solidFill>
                   <a:srgbClr val="1F2430"/>
                 </a:solidFill>
                 <a:latin typeface="Calibri"/>
               </a:rPr>
-              <a:t>FedRAMP cloud + FIPS crypto — deal-gated</a:t>
-            </a:r>
-          </a:p>
-          <a:p>
-            <a:pPr algn="l">
-              <a:spcAft>
-                <a:spcPts val="500"/>
-              </a:spcAft>
-            </a:pPr>
-            <a:r>
-              <a:rPr sz="1350" b="0">
+              <a:t>•  FedRAMP cloud + FIPS crypto — deal-gated</a:t>
+            </a:r>
+          </a:p>
+          <a:p>
+            <a:pPr algn="l">
+              <a:spcAft>
+                <a:spcPts val="1100"/>
+              </a:spcAft>
+            </a:pPr>
+            <a:r>
+              <a:rPr sz="1500" b="0">
                 <a:solidFill>
                   <a:srgbClr val="1F2430"/>
                 </a:solidFill>
                 <a:latin typeface="Calibri"/>
               </a:rPr>
-              <a:t>Metadata-only keeps most of these out of scope for the data we touch.</a:t>
+              <a:t>•  Metadata-only keeps most of these out of scope for the data we touch.</a:t>
             </a:r>
           </a:p>
         </p:txBody>

</xml_diff>

<commit_message>
docs: fill MHBE about-me + presenter details (Krethikram Gowrisankar)
- About-me slide: KG monogram + real bio from the founder's resume — 4 bullets
  tuned to a CIO/CFO/Compliance room (Amazon Smart TDR scale + zero safety
  incidents; $40M+ savings / $50M+ investment / $100M+ NPV; 0→1 builder + patent;
  CS @ UW–Madison → Outlay's financial rigor for AI spend).
- Filled presenter placeholders deck-wide (cover, value-prop footer, close footer)
  with "Krethikram Gowrisankar · Founder · krethikram@gmail.com".
- No on-slide placeholders remain; PDF regenerated to match + QA'd.

Co-Authored-By: Claude Opus 4.8 <noreply@anthropic.com>
Claude-Session: https://claude.ai/code/session_01Mev79UpmJmZS58W3eyakhL
</commit_message>
<xml_diff>
--- a/docs/mhbe-demo-deck.pptx
+++ b/docs/mhbe-demo-deck.pptx
@@ -527,7 +527,7 @@
           </a:p>
           <a:p>
             <a:r>
-              <a:t>before the pitch. Fill the [ Presenter name ] / [ Title ] placeholders.</a:t>
+              <a:t>before the pitch.</a:t>
             </a:r>
           </a:p>
         </p:txBody>
@@ -1187,22 +1187,22 @@
           <a:lstStyle/>
           <a:p>
             <a:r>
-              <a:t>About me — 30-45 seconds. Establish why you're credible to a CIO / CFO / Compliance room,</a:t>
-            </a:r>
-          </a:p>
-          <a:p>
-            <a:r>
-              <a:t>then land the one-line founding insight. Replace every [ bracketed ] placeholder with your real</a:t>
-            </a:r>
-          </a:p>
-          <a:p>
-            <a:r>
-              <a:t>background; drop a headshot into the green circle (or leave the monogram). Keep it tight — this is</a:t>
-            </a:r>
-          </a:p>
-          <a:p>
-            <a:r>
-              <a:t>trust-building, not a resume.</a:t>
+              <a:t>About me — 30-45 seconds. The throughline to land: "I spent years at Amazon owning</a:t>
+            </a:r>
+          </a:p>
+          <a:p>
+            <a:r>
+              <a:t>safety-critical autonomous systems and the financial models behind them — $40M+ saved, $100M+ NPV</a:t>
+            </a:r>
+          </a:p>
+          <a:p>
+            <a:r>
+              <a:t>programs. Outlay brings that same cost-governance rigor to AI spend." Establishes you're credible on</a:t>
+            </a:r>
+          </a:p>
+          <a:p>
+            <a:r>
+              <a:t>BOTH scale/safety (matters to a gov buyer) and financial discipline (matters to the CFO).</a:t>
             </a:r>
           </a:p>
         </p:txBody>
@@ -5046,7 +5046,7 @@
                 </a:solidFill>
                 <a:latin typeface="Calibri"/>
               </a:rPr>
-              <a:t>[ Presenter name ]  ·  [ Title ], Outlay</a:t>
+              <a:t>Krethikram Gowrisankar  ·  Founder, Outlay</a:t>
             </a:r>
           </a:p>
           <a:p>
@@ -6594,7 +6594,7 @@
                 </a:solidFill>
                 <a:latin typeface="Calibri"/>
               </a:rPr>
-              <a:t>[presenter] · [email] · outlay-ai.com</a:t>
+              <a:t>Krethikram Gowrisankar · krethikram@gmail.com · outlay-ai.com</a:t>
             </a:r>
           </a:p>
         </p:txBody>
@@ -7578,13 +7578,13 @@
               </a:spcAft>
             </a:pPr>
             <a:r>
-              <a:rPr sz="1800" b="1">
+              <a:rPr sz="4000" b="1">
                 <a:solidFill>
                   <a:srgbClr val="DDF0E7"/>
                 </a:solidFill>
-                <a:latin typeface="Calibri"/>
-              </a:rPr>
-              <a:t>[ photo ]</a:t>
+                <a:latin typeface="Georgia"/>
+              </a:rPr>
+              <a:t>KG</a:t>
             </a:r>
           </a:p>
         </p:txBody>
@@ -7623,7 +7623,7 @@
                 </a:solidFill>
                 <a:latin typeface="Calibri"/>
               </a:rPr>
-              <a:t>↑ drop in a headshot</a:t>
+              <a:t>San Francisco, CA</a:t>
             </a:r>
           </a:p>
         </p:txBody>
@@ -7636,8 +7636,8 @@
         </p:nvSpPr>
         <p:spPr>
           <a:xfrm>
-            <a:off x="3566160" y="1417320"/>
-            <a:ext cx="8046720" cy="822960"/>
+            <a:off x="3566160" y="1371600"/>
+            <a:ext cx="8092440" cy="731520"/>
           </a:xfrm>
           <a:prstGeom prst="rect">
             <a:avLst/>
@@ -7656,13 +7656,13 @@
               </a:spcAft>
             </a:pPr>
             <a:r>
-              <a:rPr sz="3200" b="1">
+              <a:rPr sz="3100" b="1">
                 <a:solidFill>
                   <a:srgbClr val="1F2430"/>
                 </a:solidFill>
                 <a:latin typeface="Georgia"/>
               </a:rPr>
-              <a:t>[ Your name ]</a:t>
+              <a:t>Krethikram Gowrisankar</a:t>
             </a:r>
           </a:p>
         </p:txBody>
@@ -7675,8 +7675,8 @@
         </p:nvSpPr>
         <p:spPr>
           <a:xfrm>
-            <a:off x="3566160" y="2240280"/>
-            <a:ext cx="8046720" cy="457200"/>
+            <a:off x="3566160" y="2148840"/>
+            <a:ext cx="8092440" cy="457200"/>
           </a:xfrm>
           <a:prstGeom prst="rect">
             <a:avLst/>
@@ -7695,13 +7695,13 @@
               </a:spcAft>
             </a:pPr>
             <a:r>
-              <a:rPr sz="1800" b="1">
+              <a:rPr sz="1700" b="1">
                 <a:solidFill>
                   <a:srgbClr val="0F6B4F"/>
                 </a:solidFill>
                 <a:latin typeface="Calibri"/>
               </a:rPr>
-              <a:t>[ Title ] · Founder, Outlay</a:t>
+              <a:t>Founder, Outlay  ·  ex-Amazon (Senior PM, Tech)</a:t>
             </a:r>
           </a:p>
         </p:txBody>
@@ -7714,8 +7714,8 @@
         </p:nvSpPr>
         <p:spPr>
           <a:xfrm>
-            <a:off x="3566160" y="2880360"/>
-            <a:ext cx="8092440" cy="2926080"/>
+            <a:off x="3566160" y="2743200"/>
+            <a:ext cx="8092440" cy="3108960"/>
           </a:xfrm>
           <a:prstGeom prst="rect">
             <a:avLst/>
@@ -7730,65 +7730,65 @@
           <a:p>
             <a:pPr algn="l">
               <a:spcAft>
-                <a:spcPts val="1500"/>
-              </a:spcAft>
-            </a:pPr>
-            <a:r>
-              <a:rPr sz="1600" b="0">
+                <a:spcPts val="1100"/>
+              </a:spcAft>
+            </a:pPr>
+            <a:r>
+              <a:rPr sz="1400" b="0">
                 <a:solidFill>
                   <a:srgbClr val="1F2430"/>
                 </a:solidFill>
                 <a:latin typeface="Calibri"/>
               </a:rPr>
-              <a:t>•  [ Background — prior roles / companies, and what you led there ]</a:t>
-            </a:r>
-          </a:p>
-          <a:p>
-            <a:pPr algn="l">
-              <a:spcAft>
-                <a:spcPts val="1500"/>
-              </a:spcAft>
-            </a:pPr>
-            <a:r>
-              <a:rPr sz="1600" b="0">
+              <a:t>•  Senior PM (Tech) at Amazon — led Smart TDR, an autonomous docking system scaled to ~50% of the middle-mile network in 12 months: 1M+ automated cycles, zero safety incidents.</a:t>
+            </a:r>
+          </a:p>
+          <a:p>
+            <a:pPr algn="l">
+              <a:spcAft>
+                <a:spcPts val="1100"/>
+              </a:spcAft>
+            </a:pPr>
+            <a:r>
+              <a:rPr sz="1400" b="0">
                 <a:solidFill>
                   <a:srgbClr val="1F2430"/>
                 </a:solidFill>
                 <a:latin typeface="Calibri"/>
               </a:rPr>
-              <a:t>•  [ Domain expertise — FinOps · AI infrastructure · healthcare · government · security ]</a:t>
-            </a:r>
-          </a:p>
-          <a:p>
-            <a:pPr algn="l">
-              <a:spcAft>
-                <a:spcPts val="1500"/>
-              </a:spcAft>
-            </a:pPr>
-            <a:r>
-              <a:rPr sz="1600" b="0">
+              <a:t>•  Delivered $40M+ annual savings and owned $50M+ annual investment / $100M+ NPV programs — cost governance and capital allocation at scale.</a:t>
+            </a:r>
+          </a:p>
+          <a:p>
+            <a:pPr algn="l">
+              <a:spcAft>
+                <a:spcPts val="1100"/>
+              </a:spcAft>
+            </a:pPr>
+            <a:r>
+              <a:rPr sz="1400" b="0">
                 <a:solidFill>
                   <a:srgbClr val="1F2430"/>
                 </a:solidFill>
                 <a:latin typeface="Calibri"/>
               </a:rPr>
-              <a:t>•  [ Notable — scale you've operated at, a credential, or a prior exit ]</a:t>
-            </a:r>
-          </a:p>
-          <a:p>
-            <a:pPr algn="l">
-              <a:spcAft>
-                <a:spcPts val="1500"/>
-              </a:spcAft>
-            </a:pPr>
-            <a:r>
-              <a:rPr sz="1600" b="0">
+              <a:t>•  Repeat 0→1 builder across hardware, software, and operations; filed a provisional patent and cold-pitched Amazon leadership into a full-time PM role.</a:t>
+            </a:r>
+          </a:p>
+          <a:p>
+            <a:pPr algn="l">
+              <a:spcAft>
+                <a:spcPts val="1100"/>
+              </a:spcAft>
+            </a:pPr>
+            <a:r>
+              <a:rPr sz="1400" b="0">
                 <a:solidFill>
                   <a:srgbClr val="1F2430"/>
                 </a:solidFill>
                 <a:latin typeface="Calibri"/>
               </a:rPr>
-              <a:t>•  [ Why Outlay — the founding insight that made you build this ]</a:t>
+              <a:t>•  B.S. Computer Science, UW–Madison — built Outlay to bring that same financial rigor to AI/LLM spend.</a:t>
             </a:r>
           </a:p>
         </p:txBody>
@@ -7801,7 +7801,7 @@
         </p:nvSpPr>
         <p:spPr>
           <a:xfrm>
-            <a:off x="3566160" y="5989320"/>
+            <a:off x="3566160" y="6053328"/>
             <a:ext cx="8092440" cy="457200"/>
           </a:xfrm>
           <a:prstGeom prst="rect">
@@ -7821,7 +7821,7 @@
               </a:spcAft>
             </a:pPr>
             <a:r>
-              <a:rPr sz="1400" b="1">
+              <a:rPr sz="1300" b="1">
                 <a:solidFill>
                   <a:srgbClr val="5C6470"/>
                 </a:solidFill>
@@ -8095,7 +8095,7 @@
                 </a:solidFill>
                 <a:latin typeface="Calibri"/>
               </a:rPr>
-              <a:t>Outlay.ai   ·   Demo · June 26, 2026 · [presenter]</a:t>
+              <a:t>Outlay.ai   ·   Demo · June 26, 2026 · Krethikram Gowrisankar</a:t>
             </a:r>
           </a:p>
         </p:txBody>

</xml_diff>

<commit_message>
docs: fill MHBE about-me + presenter details (Krethikram Gowrisankar) (#250)
- About-me slide: KG monogram + real bio from the founder's resume — 4 bullets
  tuned to a CIO/CFO/Compliance room (Amazon Smart TDR scale + zero safety
  incidents; $40M+ savings / $50M+ investment / $100M+ NPV; 0→1 builder + patent;
  CS @ UW–Madison → Outlay's financial rigor for AI spend).
- Filled presenter placeholders deck-wide (cover, value-prop footer, close footer)
  with "Krethikram Gowrisankar · Founder · krethikram@gmail.com".
- No on-slide placeholders remain; PDF regenerated to match + QA'd.


Claude-Session: https://claude.ai/code/session_01Mev79UpmJmZS58W3eyakhL

Co-authored-by: Claude <noreply@anthropic.com>
</commit_message>
<xml_diff>
--- a/docs/mhbe-demo-deck.pptx
+++ b/docs/mhbe-demo-deck.pptx
@@ -527,7 +527,7 @@
           </a:p>
           <a:p>
             <a:r>
-              <a:t>before the pitch. Fill the [ Presenter name ] / [ Title ] placeholders.</a:t>
+              <a:t>before the pitch.</a:t>
             </a:r>
           </a:p>
         </p:txBody>
@@ -1187,22 +1187,22 @@
           <a:lstStyle/>
           <a:p>
             <a:r>
-              <a:t>About me — 30-45 seconds. Establish why you're credible to a CIO / CFO / Compliance room,</a:t>
-            </a:r>
-          </a:p>
-          <a:p>
-            <a:r>
-              <a:t>then land the one-line founding insight. Replace every [ bracketed ] placeholder with your real</a:t>
-            </a:r>
-          </a:p>
-          <a:p>
-            <a:r>
-              <a:t>background; drop a headshot into the green circle (or leave the monogram). Keep it tight — this is</a:t>
-            </a:r>
-          </a:p>
-          <a:p>
-            <a:r>
-              <a:t>trust-building, not a resume.</a:t>
+              <a:t>About me — 30-45 seconds. The throughline to land: "I spent years at Amazon owning</a:t>
+            </a:r>
+          </a:p>
+          <a:p>
+            <a:r>
+              <a:t>safety-critical autonomous systems and the financial models behind them — $40M+ saved, $100M+ NPV</a:t>
+            </a:r>
+          </a:p>
+          <a:p>
+            <a:r>
+              <a:t>programs. Outlay brings that same cost-governance rigor to AI spend." Establishes you're credible on</a:t>
+            </a:r>
+          </a:p>
+          <a:p>
+            <a:r>
+              <a:t>BOTH scale/safety (matters to a gov buyer) and financial discipline (matters to the CFO).</a:t>
             </a:r>
           </a:p>
         </p:txBody>
@@ -5046,7 +5046,7 @@
                 </a:solidFill>
                 <a:latin typeface="Calibri"/>
               </a:rPr>
-              <a:t>[ Presenter name ]  ·  [ Title ], Outlay</a:t>
+              <a:t>Krethikram Gowrisankar  ·  Founder, Outlay</a:t>
             </a:r>
           </a:p>
           <a:p>
@@ -6594,7 +6594,7 @@
                 </a:solidFill>
                 <a:latin typeface="Calibri"/>
               </a:rPr>
-              <a:t>[presenter] · [email] · outlay-ai.com</a:t>
+              <a:t>Krethikram Gowrisankar · krethikram@gmail.com · outlay-ai.com</a:t>
             </a:r>
           </a:p>
         </p:txBody>
@@ -7578,13 +7578,13 @@
               </a:spcAft>
             </a:pPr>
             <a:r>
-              <a:rPr sz="1800" b="1">
+              <a:rPr sz="4000" b="1">
                 <a:solidFill>
                   <a:srgbClr val="DDF0E7"/>
                 </a:solidFill>
-                <a:latin typeface="Calibri"/>
-              </a:rPr>
-              <a:t>[ photo ]</a:t>
+                <a:latin typeface="Georgia"/>
+              </a:rPr>
+              <a:t>KG</a:t>
             </a:r>
           </a:p>
         </p:txBody>
@@ -7623,7 +7623,7 @@
                 </a:solidFill>
                 <a:latin typeface="Calibri"/>
               </a:rPr>
-              <a:t>↑ drop in a headshot</a:t>
+              <a:t>San Francisco, CA</a:t>
             </a:r>
           </a:p>
         </p:txBody>
@@ -7636,8 +7636,8 @@
         </p:nvSpPr>
         <p:spPr>
           <a:xfrm>
-            <a:off x="3566160" y="1417320"/>
-            <a:ext cx="8046720" cy="822960"/>
+            <a:off x="3566160" y="1371600"/>
+            <a:ext cx="8092440" cy="731520"/>
           </a:xfrm>
           <a:prstGeom prst="rect">
             <a:avLst/>
@@ -7656,13 +7656,13 @@
               </a:spcAft>
             </a:pPr>
             <a:r>
-              <a:rPr sz="3200" b="1">
+              <a:rPr sz="3100" b="1">
                 <a:solidFill>
                   <a:srgbClr val="1F2430"/>
                 </a:solidFill>
                 <a:latin typeface="Georgia"/>
               </a:rPr>
-              <a:t>[ Your name ]</a:t>
+              <a:t>Krethikram Gowrisankar</a:t>
             </a:r>
           </a:p>
         </p:txBody>
@@ -7675,8 +7675,8 @@
         </p:nvSpPr>
         <p:spPr>
           <a:xfrm>
-            <a:off x="3566160" y="2240280"/>
-            <a:ext cx="8046720" cy="457200"/>
+            <a:off x="3566160" y="2148840"/>
+            <a:ext cx="8092440" cy="457200"/>
           </a:xfrm>
           <a:prstGeom prst="rect">
             <a:avLst/>
@@ -7695,13 +7695,13 @@
               </a:spcAft>
             </a:pPr>
             <a:r>
-              <a:rPr sz="1800" b="1">
+              <a:rPr sz="1700" b="1">
                 <a:solidFill>
                   <a:srgbClr val="0F6B4F"/>
                 </a:solidFill>
                 <a:latin typeface="Calibri"/>
               </a:rPr>
-              <a:t>[ Title ] · Founder, Outlay</a:t>
+              <a:t>Founder, Outlay  ·  ex-Amazon (Senior PM, Tech)</a:t>
             </a:r>
           </a:p>
         </p:txBody>
@@ -7714,8 +7714,8 @@
         </p:nvSpPr>
         <p:spPr>
           <a:xfrm>
-            <a:off x="3566160" y="2880360"/>
-            <a:ext cx="8092440" cy="2926080"/>
+            <a:off x="3566160" y="2743200"/>
+            <a:ext cx="8092440" cy="3108960"/>
           </a:xfrm>
           <a:prstGeom prst="rect">
             <a:avLst/>
@@ -7730,65 +7730,65 @@
           <a:p>
             <a:pPr algn="l">
               <a:spcAft>
-                <a:spcPts val="1500"/>
-              </a:spcAft>
-            </a:pPr>
-            <a:r>
-              <a:rPr sz="1600" b="0">
+                <a:spcPts val="1100"/>
+              </a:spcAft>
+            </a:pPr>
+            <a:r>
+              <a:rPr sz="1400" b="0">
                 <a:solidFill>
                   <a:srgbClr val="1F2430"/>
                 </a:solidFill>
                 <a:latin typeface="Calibri"/>
               </a:rPr>
-              <a:t>•  [ Background — prior roles / companies, and what you led there ]</a:t>
-            </a:r>
-          </a:p>
-          <a:p>
-            <a:pPr algn="l">
-              <a:spcAft>
-                <a:spcPts val="1500"/>
-              </a:spcAft>
-            </a:pPr>
-            <a:r>
-              <a:rPr sz="1600" b="0">
+              <a:t>•  Senior PM (Tech) at Amazon — led Smart TDR, an autonomous docking system scaled to ~50% of the middle-mile network in 12 months: 1M+ automated cycles, zero safety incidents.</a:t>
+            </a:r>
+          </a:p>
+          <a:p>
+            <a:pPr algn="l">
+              <a:spcAft>
+                <a:spcPts val="1100"/>
+              </a:spcAft>
+            </a:pPr>
+            <a:r>
+              <a:rPr sz="1400" b="0">
                 <a:solidFill>
                   <a:srgbClr val="1F2430"/>
                 </a:solidFill>
                 <a:latin typeface="Calibri"/>
               </a:rPr>
-              <a:t>•  [ Domain expertise — FinOps · AI infrastructure · healthcare · government · security ]</a:t>
-            </a:r>
-          </a:p>
-          <a:p>
-            <a:pPr algn="l">
-              <a:spcAft>
-                <a:spcPts val="1500"/>
-              </a:spcAft>
-            </a:pPr>
-            <a:r>
-              <a:rPr sz="1600" b="0">
+              <a:t>•  Delivered $40M+ annual savings and owned $50M+ annual investment / $100M+ NPV programs — cost governance and capital allocation at scale.</a:t>
+            </a:r>
+          </a:p>
+          <a:p>
+            <a:pPr algn="l">
+              <a:spcAft>
+                <a:spcPts val="1100"/>
+              </a:spcAft>
+            </a:pPr>
+            <a:r>
+              <a:rPr sz="1400" b="0">
                 <a:solidFill>
                   <a:srgbClr val="1F2430"/>
                 </a:solidFill>
                 <a:latin typeface="Calibri"/>
               </a:rPr>
-              <a:t>•  [ Notable — scale you've operated at, a credential, or a prior exit ]</a:t>
-            </a:r>
-          </a:p>
-          <a:p>
-            <a:pPr algn="l">
-              <a:spcAft>
-                <a:spcPts val="1500"/>
-              </a:spcAft>
-            </a:pPr>
-            <a:r>
-              <a:rPr sz="1600" b="0">
+              <a:t>•  Repeat 0→1 builder across hardware, software, and operations; filed a provisional patent and cold-pitched Amazon leadership into a full-time PM role.</a:t>
+            </a:r>
+          </a:p>
+          <a:p>
+            <a:pPr algn="l">
+              <a:spcAft>
+                <a:spcPts val="1100"/>
+              </a:spcAft>
+            </a:pPr>
+            <a:r>
+              <a:rPr sz="1400" b="0">
                 <a:solidFill>
                   <a:srgbClr val="1F2430"/>
                 </a:solidFill>
                 <a:latin typeface="Calibri"/>
               </a:rPr>
-              <a:t>•  [ Why Outlay — the founding insight that made you build this ]</a:t>
+              <a:t>•  B.S. Computer Science, UW–Madison — built Outlay to bring that same financial rigor to AI/LLM spend.</a:t>
             </a:r>
           </a:p>
         </p:txBody>
@@ -7801,7 +7801,7 @@
         </p:nvSpPr>
         <p:spPr>
           <a:xfrm>
-            <a:off x="3566160" y="5989320"/>
+            <a:off x="3566160" y="6053328"/>
             <a:ext cx="8092440" cy="457200"/>
           </a:xfrm>
           <a:prstGeom prst="rect">
@@ -7821,7 +7821,7 @@
               </a:spcAft>
             </a:pPr>
             <a:r>
-              <a:rPr sz="1400" b="1">
+              <a:rPr sz="1300" b="1">
                 <a:solidFill>
                   <a:srgbClr val="5C6470"/>
                 </a:solidFill>
@@ -8095,7 +8095,7 @@
                 </a:solidFill>
                 <a:latin typeface="Calibri"/>
               </a:rPr>
-              <a:t>Outlay.ai   ·   Demo · June 26, 2026 · [presenter]</a:t>
+              <a:t>Outlay.ai   ·   Demo · June 26, 2026 · Krethikram Gowrisankar</a:t>
             </a:r>
           </a:p>
         </p:txBody>

</xml_diff>